<commit_message>
Minor adjustments to scrum board.
</commit_message>
<xml_diff>
--- a/SE202526/Management/Scrum Board.pptx
+++ b/SE202526/Management/Scrum Board.pptx
@@ -120,6 +120,11 @@
       </a:defRPr>
     </a:lvl9pPr>
   </p:defaultTextStyle>
+  <p:extLst>
+    <p:ext uri="{EFAFB233-063F-42B5-8137-9DF3F51BA10A}">
+      <p15:sldGuideLst xmlns:p15="http://schemas.microsoft.com/office/powerpoint/2012/main"/>
+    </p:ext>
+  </p:extLst>
 </p:presentation>
 </file>
 
@@ -17908,6 +17913,188 @@
               </a:rPr>
               <a:t>Define the structure and behavior of the new warning messages</a:t>
             </a:r>
+            <a:endParaRPr lang="pt-PT" sz="1400" b="0" u="none" strike="noStrike" dirty="0">
+              <a:solidFill>
+                <a:srgbClr val="000000"/>
+              </a:solidFill>
+              <a:effectLst/>
+              <a:uFillTx/>
+              <a:latin typeface="Arial"/>
+            </a:endParaRPr>
+          </a:p>
+        </p:txBody>
+      </p:sp>
+      <p:sp>
+        <p:nvSpPr>
+          <p:cNvPr id="2" name="Google Shape;86;p15">
+            <a:extLst>
+              <a:ext uri="{FF2B5EF4-FFF2-40B4-BE49-F238E27FC236}">
+                <a16:creationId xmlns:a16="http://schemas.microsoft.com/office/drawing/2014/main" id="{EABC4697-C325-E97D-571B-A96A86A7BB5F}"/>
+              </a:ext>
+            </a:extLst>
+          </p:cNvPr>
+          <p:cNvSpPr/>
+          <p:nvPr/>
+        </p:nvSpPr>
+        <p:spPr>
+          <a:xfrm>
+            <a:off x="167400" y="1639472"/>
+            <a:ext cx="2409840" cy="879561"/>
+          </a:xfrm>
+          <a:prstGeom prst="roundRect">
+            <a:avLst>
+              <a:gd name="adj" fmla="val 16667"/>
+            </a:avLst>
+          </a:prstGeom>
+          <a:solidFill>
+            <a:srgbClr val="D9EAD3"/>
+          </a:solidFill>
+          <a:ln w="28575">
+            <a:solidFill>
+              <a:srgbClr val="274E13"/>
+            </a:solidFill>
+            <a:round/>
+          </a:ln>
+        </p:spPr>
+        <p:style>
+          <a:lnRef idx="0">
+            <a:scrgbClr r="0" g="0" b="0"/>
+          </a:lnRef>
+          <a:fillRef idx="0">
+            <a:scrgbClr r="0" g="0" b="0"/>
+          </a:fillRef>
+          <a:effectRef idx="0">
+            <a:scrgbClr r="0" g="0" b="0"/>
+          </a:effectRef>
+          <a:fontRef idx="minor"/>
+        </p:style>
+        <p:txBody>
+          <a:bodyPr lIns="90000" tIns="91440" rIns="90000" bIns="91440" anchor="t">
+            <a:noAutofit/>
+          </a:bodyPr>
+          <a:lstStyle/>
+          <a:p>
+            <a:pPr>
+              <a:lnSpc>
+                <a:spcPct val="100000"/>
+              </a:lnSpc>
+            </a:pPr>
+            <a:r>
+              <a:rPr lang="pt-PT" sz="1400" dirty="0">
+                <a:solidFill>
+                  <a:srgbClr val="000000"/>
+                </a:solidFill>
+                <a:latin typeface="Arial"/>
+              </a:rPr>
+              <a:t>US1</a:t>
+            </a:r>
+            <a:r>
+              <a:rPr lang="en-US" sz="1400" dirty="0">
+                <a:solidFill>
+                  <a:srgbClr val="000000"/>
+                </a:solidFill>
+                <a:latin typeface="Arial"/>
+              </a:rPr>
+              <a:t>: implementing</a:t>
+            </a:r>
+          </a:p>
+          <a:p>
+            <a:pPr>
+              <a:lnSpc>
+                <a:spcPct val="100000"/>
+              </a:lnSpc>
+            </a:pPr>
+            <a:endParaRPr lang="pt-PT" sz="1400" b="0" u="none" strike="noStrike" dirty="0">
+              <a:solidFill>
+                <a:srgbClr val="000000"/>
+              </a:solidFill>
+              <a:effectLst/>
+              <a:uFillTx/>
+              <a:latin typeface="Arial"/>
+            </a:endParaRPr>
+          </a:p>
+        </p:txBody>
+      </p:sp>
+      <p:sp>
+        <p:nvSpPr>
+          <p:cNvPr id="3" name="Google Shape;86;p15">
+            <a:extLst>
+              <a:ext uri="{FF2B5EF4-FFF2-40B4-BE49-F238E27FC236}">
+                <a16:creationId xmlns:a16="http://schemas.microsoft.com/office/drawing/2014/main" id="{06688CFE-324B-3DE4-AFB0-E9378C7A3251}"/>
+              </a:ext>
+            </a:extLst>
+          </p:cNvPr>
+          <p:cNvSpPr/>
+          <p:nvPr/>
+        </p:nvSpPr>
+        <p:spPr>
+          <a:xfrm>
+            <a:off x="184230" y="3568487"/>
+            <a:ext cx="2393010" cy="879561"/>
+          </a:xfrm>
+          <a:prstGeom prst="roundRect">
+            <a:avLst>
+              <a:gd name="adj" fmla="val 16667"/>
+            </a:avLst>
+          </a:prstGeom>
+          <a:solidFill>
+            <a:srgbClr val="D9EAD3"/>
+          </a:solidFill>
+          <a:ln w="28575">
+            <a:solidFill>
+              <a:srgbClr val="274E13"/>
+            </a:solidFill>
+            <a:round/>
+          </a:ln>
+        </p:spPr>
+        <p:style>
+          <a:lnRef idx="0">
+            <a:scrgbClr r="0" g="0" b="0"/>
+          </a:lnRef>
+          <a:fillRef idx="0">
+            <a:scrgbClr r="0" g="0" b="0"/>
+          </a:fillRef>
+          <a:effectRef idx="0">
+            <a:scrgbClr r="0" g="0" b="0"/>
+          </a:effectRef>
+          <a:fontRef idx="minor"/>
+        </p:style>
+        <p:txBody>
+          <a:bodyPr lIns="90000" tIns="91440" rIns="90000" bIns="91440" anchor="t">
+            <a:noAutofit/>
+          </a:bodyPr>
+          <a:lstStyle/>
+          <a:p>
+            <a:pPr>
+              <a:lnSpc>
+                <a:spcPct val="100000"/>
+              </a:lnSpc>
+            </a:pPr>
+            <a:r>
+              <a:rPr lang="pt-PT" sz="1400" dirty="0">
+                <a:solidFill>
+                  <a:srgbClr val="000000"/>
+                </a:solidFill>
+                <a:latin typeface="Arial"/>
+              </a:rPr>
+              <a:t>US2</a:t>
+            </a:r>
+            <a:r>
+              <a:rPr lang="en-US" sz="1400" dirty="0">
+                <a:solidFill>
+                  <a:srgbClr val="000000"/>
+                </a:solidFill>
+                <a:latin typeface="Arial"/>
+              </a:rPr>
+              <a:t>: implementing</a:t>
+            </a:r>
+          </a:p>
+          <a:p>
+            <a:pPr>
+              <a:lnSpc>
+                <a:spcPct val="100000"/>
+              </a:lnSpc>
+            </a:pPr>
             <a:endParaRPr lang="pt-PT" sz="1400" b="0" u="none" strike="noStrike" dirty="0">
               <a:solidFill>
                 <a:srgbClr val="000000"/>

</xml_diff>

<commit_message>
middle of sprint 4
</commit_message>
<xml_diff>
--- a/SE202526/Management/Scrum Board.pptx
+++ b/SE202526/Management/Scrum Board.pptx
@@ -22,6 +22,7 @@
     <p:sldId id="270" r:id="rId16"/>
     <p:sldId id="271" r:id="rId17"/>
     <p:sldId id="272" r:id="rId18"/>
+    <p:sldId id="273" r:id="rId19"/>
   </p:sldIdLst>
   <p:sldSz cx="21599525" cy="10799763"/>
   <p:notesSz cx="7559675" cy="10691813"/>
@@ -18110,6 +18111,2683 @@
     <p:extLst>
       <p:ext uri="{BB962C8B-B14F-4D97-AF65-F5344CB8AC3E}">
         <p14:creationId xmlns:p14="http://schemas.microsoft.com/office/powerpoint/2010/main" val="3190489301"/>
+      </p:ext>
+    </p:extLst>
+  </p:cSld>
+  <p:clrMapOvr>
+    <a:masterClrMapping/>
+  </p:clrMapOvr>
+</p:sld>
+</file>
+
+<file path=ppt/slides/slide18.xml><?xml version="1.0" encoding="utf-8"?>
+<p:sld xmlns:a="http://schemas.openxmlformats.org/drawingml/2006/main" xmlns:r="http://schemas.openxmlformats.org/officeDocument/2006/relationships" xmlns:p="http://schemas.openxmlformats.org/presentationml/2006/main">
+  <p:cSld>
+    <p:spTree>
+      <p:nvGrpSpPr>
+        <p:cNvPr id="1" name="">
+          <a:extLst>
+            <a:ext uri="{FF2B5EF4-FFF2-40B4-BE49-F238E27FC236}">
+              <a16:creationId xmlns:a16="http://schemas.microsoft.com/office/drawing/2014/main" id="{D0B8E483-D5F1-EAE7-91CD-F13934DE1D74}"/>
+            </a:ext>
+          </a:extLst>
+        </p:cNvPr>
+        <p:cNvGrpSpPr/>
+        <p:nvPr/>
+      </p:nvGrpSpPr>
+      <p:grpSpPr>
+        <a:xfrm>
+          <a:off x="0" y="0"/>
+          <a:ext cx="0" cy="0"/>
+          <a:chOff x="0" y="0"/>
+          <a:chExt cx="0" cy="0"/>
+        </a:xfrm>
+      </p:grpSpPr>
+      <p:cxnSp>
+        <p:nvCxnSpPr>
+          <p:cNvPr id="33" name="Google Shape;66;p15">
+            <a:extLst>
+              <a:ext uri="{FF2B5EF4-FFF2-40B4-BE49-F238E27FC236}">
+                <a16:creationId xmlns:a16="http://schemas.microsoft.com/office/drawing/2014/main" id="{AD1247B2-BAD1-3EBB-DF76-16F75A4AB4DB}"/>
+              </a:ext>
+            </a:extLst>
+          </p:cNvPr>
+          <p:cNvCxnSpPr/>
+          <p:nvPr/>
+        </p:nvCxnSpPr>
+        <p:spPr>
+          <a:xfrm>
+            <a:off x="5944680" y="-31320"/>
+            <a:ext cx="1080" cy="10857600"/>
+          </a:xfrm>
+          <a:prstGeom prst="straightConnector1">
+            <a:avLst/>
+          </a:prstGeom>
+          <a:ln w="38100">
+            <a:solidFill>
+              <a:srgbClr val="5B0F00"/>
+            </a:solidFill>
+            <a:round/>
+          </a:ln>
+        </p:spPr>
+      </p:cxnSp>
+      <p:sp>
+        <p:nvSpPr>
+          <p:cNvPr id="34" name="Google Shape;67;p15">
+            <a:extLst>
+              <a:ext uri="{FF2B5EF4-FFF2-40B4-BE49-F238E27FC236}">
+                <a16:creationId xmlns:a16="http://schemas.microsoft.com/office/drawing/2014/main" id="{625C174C-9066-096D-E396-62F164233D86}"/>
+              </a:ext>
+            </a:extLst>
+          </p:cNvPr>
+          <p:cNvSpPr/>
+          <p:nvPr/>
+        </p:nvSpPr>
+        <p:spPr>
+          <a:xfrm>
+            <a:off x="3197160" y="84240"/>
+            <a:ext cx="2409840" cy="479880"/>
+          </a:xfrm>
+          <a:prstGeom prst="roundRect">
+            <a:avLst>
+              <a:gd name="adj" fmla="val 16667"/>
+            </a:avLst>
+          </a:prstGeom>
+          <a:solidFill>
+            <a:srgbClr val="F9CB9C"/>
+          </a:solidFill>
+          <a:ln w="28575">
+            <a:solidFill>
+              <a:srgbClr val="B45F06"/>
+            </a:solidFill>
+            <a:round/>
+          </a:ln>
+        </p:spPr>
+        <p:style>
+          <a:lnRef idx="0">
+            <a:scrgbClr r="0" g="0" b="0"/>
+          </a:lnRef>
+          <a:fillRef idx="0">
+            <a:scrgbClr r="0" g="0" b="0"/>
+          </a:fillRef>
+          <a:effectRef idx="0">
+            <a:scrgbClr r="0" g="0" b="0"/>
+          </a:effectRef>
+          <a:fontRef idx="minor"/>
+        </p:style>
+        <p:txBody>
+          <a:bodyPr lIns="90000" tIns="91440" rIns="90000" bIns="91440" anchor="ctr">
+            <a:noAutofit/>
+          </a:bodyPr>
+          <a:lstStyle/>
+          <a:p>
+            <a:pPr algn="ctr">
+              <a:lnSpc>
+                <a:spcPct val="100000"/>
+              </a:lnSpc>
+              <a:tabLst>
+                <a:tab pos="0" algn="l"/>
+              </a:tabLst>
+            </a:pPr>
+            <a:r>
+              <a:rPr lang="en-GB" sz="1800" b="1" u="none" strike="noStrike">
+                <a:solidFill>
+                  <a:srgbClr val="000000"/>
+                </a:solidFill>
+                <a:effectLst/>
+                <a:uFillTx/>
+                <a:latin typeface="Consolas"/>
+                <a:ea typeface="Consolas"/>
+              </a:rPr>
+              <a:t>Student ID</a:t>
+            </a:r>
+            <a:endParaRPr lang="pt-PT" sz="1800" b="0" u="none" strike="noStrike">
+              <a:solidFill>
+                <a:srgbClr val="000000"/>
+              </a:solidFill>
+              <a:effectLst/>
+              <a:uFillTx/>
+              <a:latin typeface="Arial"/>
+            </a:endParaRPr>
+          </a:p>
+        </p:txBody>
+      </p:sp>
+      <p:sp>
+        <p:nvSpPr>
+          <p:cNvPr id="35" name="Google Shape;68;p15">
+            <a:extLst>
+              <a:ext uri="{FF2B5EF4-FFF2-40B4-BE49-F238E27FC236}">
+                <a16:creationId xmlns:a16="http://schemas.microsoft.com/office/drawing/2014/main" id="{56E11A6B-E1FF-11F1-603B-49F8FD0A5F23}"/>
+              </a:ext>
+            </a:extLst>
+          </p:cNvPr>
+          <p:cNvSpPr/>
+          <p:nvPr/>
+        </p:nvSpPr>
+        <p:spPr>
+          <a:xfrm>
+            <a:off x="6281640" y="84240"/>
+            <a:ext cx="2409840" cy="479880"/>
+          </a:xfrm>
+          <a:prstGeom prst="roundRect">
+            <a:avLst>
+              <a:gd name="adj" fmla="val 16667"/>
+            </a:avLst>
+          </a:prstGeom>
+          <a:solidFill>
+            <a:srgbClr val="F9CB9C"/>
+          </a:solidFill>
+          <a:ln w="28575">
+            <a:solidFill>
+              <a:srgbClr val="B45F06"/>
+            </a:solidFill>
+            <a:round/>
+          </a:ln>
+        </p:spPr>
+        <p:style>
+          <a:lnRef idx="0">
+            <a:scrgbClr r="0" g="0" b="0"/>
+          </a:lnRef>
+          <a:fillRef idx="0">
+            <a:scrgbClr r="0" g="0" b="0"/>
+          </a:fillRef>
+          <a:effectRef idx="0">
+            <a:scrgbClr r="0" g="0" b="0"/>
+          </a:effectRef>
+          <a:fontRef idx="minor"/>
+        </p:style>
+        <p:txBody>
+          <a:bodyPr lIns="90000" tIns="91440" rIns="90000" bIns="91440" anchor="ctr">
+            <a:noAutofit/>
+          </a:bodyPr>
+          <a:lstStyle/>
+          <a:p>
+            <a:pPr algn="ctr">
+              <a:lnSpc>
+                <a:spcPct val="100000"/>
+              </a:lnSpc>
+              <a:tabLst>
+                <a:tab pos="0" algn="l"/>
+              </a:tabLst>
+            </a:pPr>
+            <a:r>
+              <a:rPr lang="en-GB" sz="1800" b="1" u="none" strike="noStrike">
+                <a:solidFill>
+                  <a:srgbClr val="000000"/>
+                </a:solidFill>
+                <a:effectLst/>
+                <a:uFillTx/>
+                <a:latin typeface="Consolas"/>
+                <a:ea typeface="Consolas"/>
+              </a:rPr>
+              <a:t>Story</a:t>
+            </a:r>
+            <a:endParaRPr lang="pt-PT" sz="1800" b="0" u="none" strike="noStrike">
+              <a:solidFill>
+                <a:srgbClr val="000000"/>
+              </a:solidFill>
+              <a:effectLst/>
+              <a:uFillTx/>
+              <a:latin typeface="Arial"/>
+            </a:endParaRPr>
+          </a:p>
+        </p:txBody>
+      </p:sp>
+      <p:sp>
+        <p:nvSpPr>
+          <p:cNvPr id="36" name="Google Shape;69;p15">
+            <a:extLst>
+              <a:ext uri="{FF2B5EF4-FFF2-40B4-BE49-F238E27FC236}">
+                <a16:creationId xmlns:a16="http://schemas.microsoft.com/office/drawing/2014/main" id="{46F48B97-4CC8-13E0-CCD7-1E4F53FEBEA4}"/>
+              </a:ext>
+            </a:extLst>
+          </p:cNvPr>
+          <p:cNvSpPr/>
+          <p:nvPr/>
+        </p:nvSpPr>
+        <p:spPr>
+          <a:xfrm>
+            <a:off x="9366120" y="84240"/>
+            <a:ext cx="2409840" cy="479880"/>
+          </a:xfrm>
+          <a:prstGeom prst="roundRect">
+            <a:avLst>
+              <a:gd name="adj" fmla="val 16667"/>
+            </a:avLst>
+          </a:prstGeom>
+          <a:solidFill>
+            <a:srgbClr val="F9CB9C"/>
+          </a:solidFill>
+          <a:ln w="28575">
+            <a:solidFill>
+              <a:srgbClr val="B45F06"/>
+            </a:solidFill>
+            <a:round/>
+          </a:ln>
+        </p:spPr>
+        <p:style>
+          <a:lnRef idx="0">
+            <a:scrgbClr r="0" g="0" b="0"/>
+          </a:lnRef>
+          <a:fillRef idx="0">
+            <a:scrgbClr r="0" g="0" b="0"/>
+          </a:fillRef>
+          <a:effectRef idx="0">
+            <a:scrgbClr r="0" g="0" b="0"/>
+          </a:effectRef>
+          <a:fontRef idx="minor"/>
+        </p:style>
+        <p:txBody>
+          <a:bodyPr lIns="90000" tIns="91440" rIns="90000" bIns="91440" anchor="ctr">
+            <a:noAutofit/>
+          </a:bodyPr>
+          <a:lstStyle/>
+          <a:p>
+            <a:pPr algn="ctr">
+              <a:lnSpc>
+                <a:spcPct val="100000"/>
+              </a:lnSpc>
+              <a:tabLst>
+                <a:tab pos="0" algn="l"/>
+              </a:tabLst>
+            </a:pPr>
+            <a:r>
+              <a:rPr lang="en-GB" sz="1800" b="1" u="none" strike="noStrike">
+                <a:solidFill>
+                  <a:srgbClr val="000000"/>
+                </a:solidFill>
+                <a:effectLst/>
+                <a:uFillTx/>
+                <a:latin typeface="Consolas"/>
+                <a:ea typeface="Consolas"/>
+              </a:rPr>
+              <a:t>To Do</a:t>
+            </a:r>
+            <a:endParaRPr lang="pt-PT" sz="1800" b="0" u="none" strike="noStrike">
+              <a:solidFill>
+                <a:srgbClr val="000000"/>
+              </a:solidFill>
+              <a:effectLst/>
+              <a:uFillTx/>
+              <a:latin typeface="Arial"/>
+            </a:endParaRPr>
+          </a:p>
+        </p:txBody>
+      </p:sp>
+      <p:sp>
+        <p:nvSpPr>
+          <p:cNvPr id="37" name="Google Shape;70;p15">
+            <a:extLst>
+              <a:ext uri="{FF2B5EF4-FFF2-40B4-BE49-F238E27FC236}">
+                <a16:creationId xmlns:a16="http://schemas.microsoft.com/office/drawing/2014/main" id="{C7B03619-22DA-0B25-14DE-9068FB53CD7B}"/>
+              </a:ext>
+            </a:extLst>
+          </p:cNvPr>
+          <p:cNvSpPr/>
+          <p:nvPr/>
+        </p:nvSpPr>
+        <p:spPr>
+          <a:xfrm>
+            <a:off x="12395880" y="84240"/>
+            <a:ext cx="2409840" cy="479880"/>
+          </a:xfrm>
+          <a:prstGeom prst="roundRect">
+            <a:avLst>
+              <a:gd name="adj" fmla="val 16667"/>
+            </a:avLst>
+          </a:prstGeom>
+          <a:solidFill>
+            <a:srgbClr val="F9CB9C"/>
+          </a:solidFill>
+          <a:ln w="28575">
+            <a:solidFill>
+              <a:srgbClr val="B45F06"/>
+            </a:solidFill>
+            <a:round/>
+          </a:ln>
+        </p:spPr>
+        <p:style>
+          <a:lnRef idx="0">
+            <a:scrgbClr r="0" g="0" b="0"/>
+          </a:lnRef>
+          <a:fillRef idx="0">
+            <a:scrgbClr r="0" g="0" b="0"/>
+          </a:fillRef>
+          <a:effectRef idx="0">
+            <a:scrgbClr r="0" g="0" b="0"/>
+          </a:effectRef>
+          <a:fontRef idx="minor"/>
+        </p:style>
+        <p:txBody>
+          <a:bodyPr lIns="90000" tIns="91440" rIns="90000" bIns="91440" anchor="ctr">
+            <a:noAutofit/>
+          </a:bodyPr>
+          <a:lstStyle/>
+          <a:p>
+            <a:pPr algn="ctr">
+              <a:lnSpc>
+                <a:spcPct val="100000"/>
+              </a:lnSpc>
+              <a:tabLst>
+                <a:tab pos="0" algn="l"/>
+              </a:tabLst>
+            </a:pPr>
+            <a:r>
+              <a:rPr lang="en-GB" sz="1800" b="1" u="none" strike="noStrike">
+                <a:solidFill>
+                  <a:srgbClr val="000000"/>
+                </a:solidFill>
+                <a:effectLst/>
+                <a:uFillTx/>
+                <a:latin typeface="Consolas"/>
+                <a:ea typeface="Consolas"/>
+              </a:rPr>
+              <a:t>Doing</a:t>
+            </a:r>
+            <a:endParaRPr lang="pt-PT" sz="1800" b="0" u="none" strike="noStrike">
+              <a:solidFill>
+                <a:srgbClr val="000000"/>
+              </a:solidFill>
+              <a:effectLst/>
+              <a:uFillTx/>
+              <a:latin typeface="Arial"/>
+            </a:endParaRPr>
+          </a:p>
+        </p:txBody>
+      </p:sp>
+      <p:sp>
+        <p:nvSpPr>
+          <p:cNvPr id="38" name="Google Shape;71;p15">
+            <a:extLst>
+              <a:ext uri="{FF2B5EF4-FFF2-40B4-BE49-F238E27FC236}">
+                <a16:creationId xmlns:a16="http://schemas.microsoft.com/office/drawing/2014/main" id="{A96015B2-9C72-1449-F697-5A3D6ED13173}"/>
+              </a:ext>
+            </a:extLst>
+          </p:cNvPr>
+          <p:cNvSpPr/>
+          <p:nvPr/>
+        </p:nvSpPr>
+        <p:spPr>
+          <a:xfrm>
+            <a:off x="15532560" y="84240"/>
+            <a:ext cx="2409840" cy="479880"/>
+          </a:xfrm>
+          <a:prstGeom prst="roundRect">
+            <a:avLst>
+              <a:gd name="adj" fmla="val 16667"/>
+            </a:avLst>
+          </a:prstGeom>
+          <a:solidFill>
+            <a:srgbClr val="F9CB9C"/>
+          </a:solidFill>
+          <a:ln w="28575">
+            <a:solidFill>
+              <a:srgbClr val="B45F06"/>
+            </a:solidFill>
+            <a:round/>
+          </a:ln>
+        </p:spPr>
+        <p:style>
+          <a:lnRef idx="0">
+            <a:scrgbClr r="0" g="0" b="0"/>
+          </a:lnRef>
+          <a:fillRef idx="0">
+            <a:scrgbClr r="0" g="0" b="0"/>
+          </a:fillRef>
+          <a:effectRef idx="0">
+            <a:scrgbClr r="0" g="0" b="0"/>
+          </a:effectRef>
+          <a:fontRef idx="minor"/>
+        </p:style>
+        <p:txBody>
+          <a:bodyPr lIns="90000" tIns="91440" rIns="90000" bIns="91440" anchor="ctr">
+            <a:noAutofit/>
+          </a:bodyPr>
+          <a:lstStyle/>
+          <a:p>
+            <a:pPr algn="ctr">
+              <a:lnSpc>
+                <a:spcPct val="100000"/>
+              </a:lnSpc>
+              <a:tabLst>
+                <a:tab pos="0" algn="l"/>
+              </a:tabLst>
+            </a:pPr>
+            <a:r>
+              <a:rPr lang="en-GB" sz="1800" b="1" u="none" strike="noStrike">
+                <a:solidFill>
+                  <a:srgbClr val="000000"/>
+                </a:solidFill>
+                <a:effectLst/>
+                <a:uFillTx/>
+                <a:latin typeface="Consolas"/>
+                <a:ea typeface="Consolas"/>
+              </a:rPr>
+              <a:t>Review</a:t>
+            </a:r>
+            <a:endParaRPr lang="pt-PT" sz="1800" b="0" u="none" strike="noStrike">
+              <a:solidFill>
+                <a:srgbClr val="000000"/>
+              </a:solidFill>
+              <a:effectLst/>
+              <a:uFillTx/>
+              <a:latin typeface="Arial"/>
+            </a:endParaRPr>
+          </a:p>
+        </p:txBody>
+      </p:sp>
+      <p:sp>
+        <p:nvSpPr>
+          <p:cNvPr id="39" name="Google Shape;72;p15">
+            <a:extLst>
+              <a:ext uri="{FF2B5EF4-FFF2-40B4-BE49-F238E27FC236}">
+                <a16:creationId xmlns:a16="http://schemas.microsoft.com/office/drawing/2014/main" id="{ADB38658-052F-FCA7-CD4C-6F2A5913EC0B}"/>
+              </a:ext>
+            </a:extLst>
+          </p:cNvPr>
+          <p:cNvSpPr/>
+          <p:nvPr/>
+        </p:nvSpPr>
+        <p:spPr>
+          <a:xfrm>
+            <a:off x="18668880" y="84240"/>
+            <a:ext cx="2409840" cy="479880"/>
+          </a:xfrm>
+          <a:prstGeom prst="roundRect">
+            <a:avLst>
+              <a:gd name="adj" fmla="val 16667"/>
+            </a:avLst>
+          </a:prstGeom>
+          <a:solidFill>
+            <a:srgbClr val="F9CB9C"/>
+          </a:solidFill>
+          <a:ln w="28575">
+            <a:solidFill>
+              <a:srgbClr val="B45F06"/>
+            </a:solidFill>
+            <a:round/>
+          </a:ln>
+        </p:spPr>
+        <p:style>
+          <a:lnRef idx="0">
+            <a:scrgbClr r="0" g="0" b="0"/>
+          </a:lnRef>
+          <a:fillRef idx="0">
+            <a:scrgbClr r="0" g="0" b="0"/>
+          </a:fillRef>
+          <a:effectRef idx="0">
+            <a:scrgbClr r="0" g="0" b="0"/>
+          </a:effectRef>
+          <a:fontRef idx="minor"/>
+        </p:style>
+        <p:txBody>
+          <a:bodyPr lIns="90000" tIns="91440" rIns="90000" bIns="91440" anchor="ctr">
+            <a:noAutofit/>
+          </a:bodyPr>
+          <a:lstStyle/>
+          <a:p>
+            <a:pPr algn="ctr">
+              <a:lnSpc>
+                <a:spcPct val="100000"/>
+              </a:lnSpc>
+              <a:tabLst>
+                <a:tab pos="0" algn="l"/>
+              </a:tabLst>
+            </a:pPr>
+            <a:r>
+              <a:rPr lang="en-GB" sz="1800" b="1" u="none" strike="noStrike">
+                <a:solidFill>
+                  <a:srgbClr val="000000"/>
+                </a:solidFill>
+                <a:effectLst/>
+                <a:uFillTx/>
+                <a:latin typeface="Consolas"/>
+                <a:ea typeface="Consolas"/>
+              </a:rPr>
+              <a:t>Done</a:t>
+            </a:r>
+            <a:endParaRPr lang="pt-PT" sz="1800" b="0" u="none" strike="noStrike">
+              <a:solidFill>
+                <a:srgbClr val="000000"/>
+              </a:solidFill>
+              <a:effectLst/>
+              <a:uFillTx/>
+              <a:latin typeface="Arial"/>
+            </a:endParaRPr>
+          </a:p>
+        </p:txBody>
+      </p:sp>
+      <p:sp>
+        <p:nvSpPr>
+          <p:cNvPr id="40" name="Google Shape;73;p15">
+            <a:extLst>
+              <a:ext uri="{FF2B5EF4-FFF2-40B4-BE49-F238E27FC236}">
+                <a16:creationId xmlns:a16="http://schemas.microsoft.com/office/drawing/2014/main" id="{ED406476-3CBF-F9B8-1D0B-DC6FAFF6C7A7}"/>
+              </a:ext>
+            </a:extLst>
+          </p:cNvPr>
+          <p:cNvSpPr/>
+          <p:nvPr/>
+        </p:nvSpPr>
+        <p:spPr>
+          <a:xfrm>
+            <a:off x="167400" y="84240"/>
+            <a:ext cx="2409840" cy="479880"/>
+          </a:xfrm>
+          <a:prstGeom prst="roundRect">
+            <a:avLst>
+              <a:gd name="adj" fmla="val 16667"/>
+            </a:avLst>
+          </a:prstGeom>
+          <a:solidFill>
+            <a:srgbClr val="F9CB9C"/>
+          </a:solidFill>
+          <a:ln w="28575">
+            <a:solidFill>
+              <a:srgbClr val="B45F06"/>
+            </a:solidFill>
+            <a:round/>
+          </a:ln>
+        </p:spPr>
+        <p:style>
+          <a:lnRef idx="0">
+            <a:scrgbClr r="0" g="0" b="0"/>
+          </a:lnRef>
+          <a:fillRef idx="0">
+            <a:scrgbClr r="0" g="0" b="0"/>
+          </a:fillRef>
+          <a:effectRef idx="0">
+            <a:scrgbClr r="0" g="0" b="0"/>
+          </a:effectRef>
+          <a:fontRef idx="minor"/>
+        </p:style>
+        <p:txBody>
+          <a:bodyPr lIns="90000" tIns="91440" rIns="90000" bIns="91440" anchor="ctr">
+            <a:noAutofit/>
+          </a:bodyPr>
+          <a:lstStyle/>
+          <a:p>
+            <a:pPr algn="ctr">
+              <a:lnSpc>
+                <a:spcPct val="100000"/>
+              </a:lnSpc>
+              <a:tabLst>
+                <a:tab pos="0" algn="l"/>
+              </a:tabLst>
+            </a:pPr>
+            <a:r>
+              <a:rPr lang="en-GB" sz="1800" b="1" u="none" strike="noStrike">
+                <a:solidFill>
+                  <a:srgbClr val="000000"/>
+                </a:solidFill>
+                <a:effectLst/>
+                <a:uFillTx/>
+                <a:latin typeface="Consolas"/>
+                <a:ea typeface="Consolas"/>
+              </a:rPr>
+              <a:t>Backlog</a:t>
+            </a:r>
+            <a:endParaRPr lang="pt-PT" sz="1800" b="0" u="none" strike="noStrike">
+              <a:solidFill>
+                <a:srgbClr val="000000"/>
+              </a:solidFill>
+              <a:effectLst/>
+              <a:uFillTx/>
+              <a:latin typeface="Arial"/>
+            </a:endParaRPr>
+          </a:p>
+        </p:txBody>
+      </p:sp>
+      <p:sp>
+        <p:nvSpPr>
+          <p:cNvPr id="41" name="Google Shape;74;p15">
+            <a:extLst>
+              <a:ext uri="{FF2B5EF4-FFF2-40B4-BE49-F238E27FC236}">
+                <a16:creationId xmlns:a16="http://schemas.microsoft.com/office/drawing/2014/main" id="{581ED07E-0618-F66B-73BE-255706ECA5C8}"/>
+              </a:ext>
+            </a:extLst>
+          </p:cNvPr>
+          <p:cNvSpPr/>
+          <p:nvPr/>
+        </p:nvSpPr>
+        <p:spPr>
+          <a:xfrm>
+            <a:off x="3197160" y="1385640"/>
+            <a:ext cx="2409840" cy="479880"/>
+          </a:xfrm>
+          <a:prstGeom prst="roundRect">
+            <a:avLst>
+              <a:gd name="adj" fmla="val 16667"/>
+            </a:avLst>
+          </a:prstGeom>
+          <a:solidFill>
+            <a:srgbClr val="E6B8AF"/>
+          </a:solidFill>
+          <a:ln w="28575">
+            <a:solidFill>
+              <a:srgbClr val="5B0F00"/>
+            </a:solidFill>
+            <a:round/>
+          </a:ln>
+        </p:spPr>
+        <p:style>
+          <a:lnRef idx="0">
+            <a:scrgbClr r="0" g="0" b="0"/>
+          </a:lnRef>
+          <a:fillRef idx="0">
+            <a:scrgbClr r="0" g="0" b="0"/>
+          </a:fillRef>
+          <a:effectRef idx="0">
+            <a:scrgbClr r="0" g="0" b="0"/>
+          </a:effectRef>
+          <a:fontRef idx="minor"/>
+        </p:style>
+        <p:txBody>
+          <a:bodyPr lIns="90000" tIns="91440" rIns="90000" bIns="91440" anchor="ctr">
+            <a:noAutofit/>
+          </a:bodyPr>
+          <a:lstStyle/>
+          <a:p>
+            <a:pPr algn="ctr">
+              <a:lnSpc>
+                <a:spcPct val="100000"/>
+              </a:lnSpc>
+              <a:tabLst>
+                <a:tab pos="0" algn="l"/>
+              </a:tabLst>
+            </a:pPr>
+            <a:r>
+              <a:rPr lang="en-GB" sz="1800" b="1" u="none" strike="noStrike">
+                <a:solidFill>
+                  <a:srgbClr val="000000"/>
+                </a:solidFill>
+                <a:effectLst/>
+                <a:uFillTx/>
+                <a:latin typeface="Consolas"/>
+                <a:ea typeface="Consolas"/>
+              </a:rPr>
+              <a:t>66565</a:t>
+            </a:r>
+            <a:endParaRPr lang="pt-PT" sz="1800" b="0" u="none" strike="noStrike">
+              <a:solidFill>
+                <a:srgbClr val="000000"/>
+              </a:solidFill>
+              <a:effectLst/>
+              <a:uFillTx/>
+              <a:latin typeface="Arial"/>
+            </a:endParaRPr>
+          </a:p>
+        </p:txBody>
+      </p:sp>
+      <p:sp>
+        <p:nvSpPr>
+          <p:cNvPr id="42" name="Google Shape;75;p15">
+            <a:extLst>
+              <a:ext uri="{FF2B5EF4-FFF2-40B4-BE49-F238E27FC236}">
+                <a16:creationId xmlns:a16="http://schemas.microsoft.com/office/drawing/2014/main" id="{6AF7B3E5-87A3-82A0-24EB-C223A8964607}"/>
+              </a:ext>
+            </a:extLst>
+          </p:cNvPr>
+          <p:cNvSpPr/>
+          <p:nvPr/>
+        </p:nvSpPr>
+        <p:spPr>
+          <a:xfrm>
+            <a:off x="3197160" y="6126258"/>
+            <a:ext cx="2409840" cy="479880"/>
+          </a:xfrm>
+          <a:prstGeom prst="roundRect">
+            <a:avLst>
+              <a:gd name="adj" fmla="val 16667"/>
+            </a:avLst>
+          </a:prstGeom>
+          <a:solidFill>
+            <a:srgbClr val="E6B8AF"/>
+          </a:solidFill>
+          <a:ln w="28575">
+            <a:solidFill>
+              <a:srgbClr val="5B0F00"/>
+            </a:solidFill>
+            <a:round/>
+          </a:ln>
+        </p:spPr>
+        <p:style>
+          <a:lnRef idx="0">
+            <a:scrgbClr r="0" g="0" b="0"/>
+          </a:lnRef>
+          <a:fillRef idx="0">
+            <a:scrgbClr r="0" g="0" b="0"/>
+          </a:fillRef>
+          <a:effectRef idx="0">
+            <a:scrgbClr r="0" g="0" b="0"/>
+          </a:effectRef>
+          <a:fontRef idx="minor"/>
+        </p:style>
+        <p:txBody>
+          <a:bodyPr lIns="90000" tIns="91440" rIns="90000" bIns="91440" anchor="ctr">
+            <a:noAutofit/>
+          </a:bodyPr>
+          <a:lstStyle/>
+          <a:p>
+            <a:pPr algn="ctr">
+              <a:lnSpc>
+                <a:spcPct val="100000"/>
+              </a:lnSpc>
+              <a:tabLst>
+                <a:tab pos="0" algn="l"/>
+              </a:tabLst>
+            </a:pPr>
+            <a:r>
+              <a:rPr lang="en-GB" sz="1800" b="1" u="none" strike="noStrike">
+                <a:solidFill>
+                  <a:srgbClr val="000000"/>
+                </a:solidFill>
+                <a:effectLst/>
+                <a:uFillTx/>
+                <a:latin typeface="Consolas"/>
+                <a:ea typeface="Consolas"/>
+              </a:rPr>
+              <a:t>67196</a:t>
+            </a:r>
+            <a:endParaRPr lang="pt-PT" sz="1800" b="0" u="none" strike="noStrike">
+              <a:solidFill>
+                <a:srgbClr val="000000"/>
+              </a:solidFill>
+              <a:effectLst/>
+              <a:uFillTx/>
+              <a:latin typeface="Arial"/>
+            </a:endParaRPr>
+          </a:p>
+        </p:txBody>
+      </p:sp>
+      <p:sp>
+        <p:nvSpPr>
+          <p:cNvPr id="43" name="Google Shape;76;p15">
+            <a:extLst>
+              <a:ext uri="{FF2B5EF4-FFF2-40B4-BE49-F238E27FC236}">
+                <a16:creationId xmlns:a16="http://schemas.microsoft.com/office/drawing/2014/main" id="{D15E634C-0422-0D98-1B70-01ABCBBAB6D4}"/>
+              </a:ext>
+            </a:extLst>
+          </p:cNvPr>
+          <p:cNvSpPr/>
+          <p:nvPr/>
+        </p:nvSpPr>
+        <p:spPr>
+          <a:xfrm>
+            <a:off x="3197160" y="2990658"/>
+            <a:ext cx="2409840" cy="479880"/>
+          </a:xfrm>
+          <a:prstGeom prst="roundRect">
+            <a:avLst>
+              <a:gd name="adj" fmla="val 16667"/>
+            </a:avLst>
+          </a:prstGeom>
+          <a:solidFill>
+            <a:srgbClr val="E6B8AF"/>
+          </a:solidFill>
+          <a:ln w="28575">
+            <a:solidFill>
+              <a:srgbClr val="5B0F00"/>
+            </a:solidFill>
+            <a:round/>
+          </a:ln>
+        </p:spPr>
+        <p:style>
+          <a:lnRef idx="0">
+            <a:scrgbClr r="0" g="0" b="0"/>
+          </a:lnRef>
+          <a:fillRef idx="0">
+            <a:scrgbClr r="0" g="0" b="0"/>
+          </a:fillRef>
+          <a:effectRef idx="0">
+            <a:scrgbClr r="0" g="0" b="0"/>
+          </a:effectRef>
+          <a:fontRef idx="minor"/>
+        </p:style>
+        <p:txBody>
+          <a:bodyPr lIns="90000" tIns="91440" rIns="90000" bIns="91440" anchor="ctr">
+            <a:noAutofit/>
+          </a:bodyPr>
+          <a:lstStyle/>
+          <a:p>
+            <a:pPr algn="ctr">
+              <a:lnSpc>
+                <a:spcPct val="100000"/>
+              </a:lnSpc>
+              <a:tabLst>
+                <a:tab pos="0" algn="l"/>
+              </a:tabLst>
+            </a:pPr>
+            <a:r>
+              <a:rPr lang="en-GB" sz="1800" b="1" u="none" strike="noStrike">
+                <a:solidFill>
+                  <a:srgbClr val="000000"/>
+                </a:solidFill>
+                <a:effectLst/>
+                <a:uFillTx/>
+                <a:latin typeface="Consolas"/>
+                <a:ea typeface="Consolas"/>
+              </a:rPr>
+              <a:t>67215</a:t>
+            </a:r>
+            <a:endParaRPr lang="pt-PT" sz="1800" b="0" u="none" strike="noStrike">
+              <a:solidFill>
+                <a:srgbClr val="000000"/>
+              </a:solidFill>
+              <a:effectLst/>
+              <a:uFillTx/>
+              <a:latin typeface="Arial"/>
+            </a:endParaRPr>
+          </a:p>
+        </p:txBody>
+      </p:sp>
+      <p:sp>
+        <p:nvSpPr>
+          <p:cNvPr id="44" name="Google Shape;77;p15">
+            <a:extLst>
+              <a:ext uri="{FF2B5EF4-FFF2-40B4-BE49-F238E27FC236}">
+                <a16:creationId xmlns:a16="http://schemas.microsoft.com/office/drawing/2014/main" id="{6EB6E2F5-8A10-2D84-A784-26AC2AFB67D0}"/>
+              </a:ext>
+            </a:extLst>
+          </p:cNvPr>
+          <p:cNvSpPr/>
+          <p:nvPr/>
+        </p:nvSpPr>
+        <p:spPr>
+          <a:xfrm>
+            <a:off x="3212280" y="4550178"/>
+            <a:ext cx="2409840" cy="479880"/>
+          </a:xfrm>
+          <a:prstGeom prst="roundRect">
+            <a:avLst>
+              <a:gd name="adj" fmla="val 16667"/>
+            </a:avLst>
+          </a:prstGeom>
+          <a:solidFill>
+            <a:srgbClr val="E6B8AF"/>
+          </a:solidFill>
+          <a:ln w="28575">
+            <a:solidFill>
+              <a:srgbClr val="5B0F00"/>
+            </a:solidFill>
+            <a:round/>
+          </a:ln>
+        </p:spPr>
+        <p:style>
+          <a:lnRef idx="0">
+            <a:scrgbClr r="0" g="0" b="0"/>
+          </a:lnRef>
+          <a:fillRef idx="0">
+            <a:scrgbClr r="0" g="0" b="0"/>
+          </a:fillRef>
+          <a:effectRef idx="0">
+            <a:scrgbClr r="0" g="0" b="0"/>
+          </a:effectRef>
+          <a:fontRef idx="minor"/>
+        </p:style>
+        <p:txBody>
+          <a:bodyPr lIns="90000" tIns="91440" rIns="90000" bIns="91440" anchor="ctr">
+            <a:noAutofit/>
+          </a:bodyPr>
+          <a:lstStyle/>
+          <a:p>
+            <a:pPr algn="ctr">
+              <a:lnSpc>
+                <a:spcPct val="100000"/>
+              </a:lnSpc>
+              <a:tabLst>
+                <a:tab pos="0" algn="l"/>
+              </a:tabLst>
+            </a:pPr>
+            <a:r>
+              <a:rPr lang="pt-PT" sz="1800" b="1" u="none" strike="noStrike">
+                <a:solidFill>
+                  <a:srgbClr val="000000"/>
+                </a:solidFill>
+                <a:effectLst/>
+                <a:uFillTx/>
+                <a:latin typeface="Consolas"/>
+                <a:ea typeface="Consolas"/>
+              </a:rPr>
+              <a:t>68509</a:t>
+            </a:r>
+            <a:endParaRPr lang="pt-PT" sz="1800" b="0" u="none" strike="noStrike">
+              <a:solidFill>
+                <a:srgbClr val="000000"/>
+              </a:solidFill>
+              <a:effectLst/>
+              <a:uFillTx/>
+              <a:latin typeface="Arial"/>
+            </a:endParaRPr>
+          </a:p>
+        </p:txBody>
+      </p:sp>
+      <p:sp>
+        <p:nvSpPr>
+          <p:cNvPr id="45" name="Google Shape;78;p15">
+            <a:extLst>
+              <a:ext uri="{FF2B5EF4-FFF2-40B4-BE49-F238E27FC236}">
+                <a16:creationId xmlns:a16="http://schemas.microsoft.com/office/drawing/2014/main" id="{2C9AF98C-26E9-8D90-1A7A-75B6909A8672}"/>
+              </a:ext>
+            </a:extLst>
+          </p:cNvPr>
+          <p:cNvSpPr/>
+          <p:nvPr/>
+        </p:nvSpPr>
+        <p:spPr>
+          <a:xfrm>
+            <a:off x="3197160" y="7685778"/>
+            <a:ext cx="2409840" cy="479880"/>
+          </a:xfrm>
+          <a:prstGeom prst="roundRect">
+            <a:avLst>
+              <a:gd name="adj" fmla="val 16667"/>
+            </a:avLst>
+          </a:prstGeom>
+          <a:solidFill>
+            <a:srgbClr val="E6B8AF"/>
+          </a:solidFill>
+          <a:ln w="28575">
+            <a:solidFill>
+              <a:srgbClr val="5B0F00"/>
+            </a:solidFill>
+            <a:round/>
+          </a:ln>
+        </p:spPr>
+        <p:style>
+          <a:lnRef idx="0">
+            <a:scrgbClr r="0" g="0" b="0"/>
+          </a:lnRef>
+          <a:fillRef idx="0">
+            <a:scrgbClr r="0" g="0" b="0"/>
+          </a:fillRef>
+          <a:effectRef idx="0">
+            <a:scrgbClr r="0" g="0" b="0"/>
+          </a:effectRef>
+          <a:fontRef idx="minor"/>
+        </p:style>
+        <p:txBody>
+          <a:bodyPr lIns="90000" tIns="91440" rIns="90000" bIns="91440" anchor="ctr">
+            <a:noAutofit/>
+          </a:bodyPr>
+          <a:lstStyle/>
+          <a:p>
+            <a:pPr algn="ctr">
+              <a:lnSpc>
+                <a:spcPct val="100000"/>
+              </a:lnSpc>
+              <a:tabLst>
+                <a:tab pos="0" algn="l"/>
+              </a:tabLst>
+            </a:pPr>
+            <a:r>
+              <a:rPr lang="en-GB" sz="1800" b="1" u="none" strike="noStrike">
+                <a:solidFill>
+                  <a:srgbClr val="000000"/>
+                </a:solidFill>
+                <a:effectLst/>
+                <a:uFillTx/>
+                <a:latin typeface="Consolas"/>
+                <a:ea typeface="Consolas"/>
+              </a:rPr>
+              <a:t>68663</a:t>
+            </a:r>
+            <a:endParaRPr lang="pt-PT" sz="1800" b="0" u="none" strike="noStrike">
+              <a:solidFill>
+                <a:srgbClr val="000000"/>
+              </a:solidFill>
+              <a:effectLst/>
+              <a:uFillTx/>
+              <a:latin typeface="Arial"/>
+            </a:endParaRPr>
+          </a:p>
+        </p:txBody>
+      </p:sp>
+      <p:sp>
+        <p:nvSpPr>
+          <p:cNvPr id="46" name="Google Shape;79;p15">
+            <a:extLst>
+              <a:ext uri="{FF2B5EF4-FFF2-40B4-BE49-F238E27FC236}">
+                <a16:creationId xmlns:a16="http://schemas.microsoft.com/office/drawing/2014/main" id="{6C784DE9-4EE8-649A-DA42-1D8A5AAA84C4}"/>
+              </a:ext>
+            </a:extLst>
+          </p:cNvPr>
+          <p:cNvSpPr/>
+          <p:nvPr/>
+        </p:nvSpPr>
+        <p:spPr>
+          <a:xfrm>
+            <a:off x="3197160" y="9264960"/>
+            <a:ext cx="2409840" cy="479880"/>
+          </a:xfrm>
+          <a:prstGeom prst="roundRect">
+            <a:avLst>
+              <a:gd name="adj" fmla="val 16667"/>
+            </a:avLst>
+          </a:prstGeom>
+          <a:solidFill>
+            <a:srgbClr val="E6B8AF"/>
+          </a:solidFill>
+          <a:ln w="28575">
+            <a:solidFill>
+              <a:srgbClr val="5B0F00"/>
+            </a:solidFill>
+            <a:round/>
+          </a:ln>
+        </p:spPr>
+        <p:style>
+          <a:lnRef idx="0">
+            <a:scrgbClr r="0" g="0" b="0"/>
+          </a:lnRef>
+          <a:fillRef idx="0">
+            <a:scrgbClr r="0" g="0" b="0"/>
+          </a:fillRef>
+          <a:effectRef idx="0">
+            <a:scrgbClr r="0" g="0" b="0"/>
+          </a:effectRef>
+          <a:fontRef idx="minor"/>
+        </p:style>
+        <p:txBody>
+          <a:bodyPr lIns="90000" tIns="91440" rIns="90000" bIns="91440" anchor="ctr">
+            <a:noAutofit/>
+          </a:bodyPr>
+          <a:lstStyle/>
+          <a:p>
+            <a:pPr algn="ctr">
+              <a:lnSpc>
+                <a:spcPct val="100000"/>
+              </a:lnSpc>
+              <a:tabLst>
+                <a:tab pos="0" algn="l"/>
+              </a:tabLst>
+            </a:pPr>
+            <a:r>
+              <a:rPr lang="en-GB" sz="1800" b="1" u="none" strike="noStrike">
+                <a:solidFill>
+                  <a:srgbClr val="000000"/>
+                </a:solidFill>
+                <a:effectLst/>
+                <a:uFillTx/>
+                <a:latin typeface="Consolas"/>
+                <a:ea typeface="Consolas"/>
+              </a:rPr>
+              <a:t>70116</a:t>
+            </a:r>
+            <a:endParaRPr lang="pt-PT" sz="1800" b="0" u="none" strike="noStrike">
+              <a:solidFill>
+                <a:srgbClr val="000000"/>
+              </a:solidFill>
+              <a:effectLst/>
+              <a:uFillTx/>
+              <a:latin typeface="Arial"/>
+            </a:endParaRPr>
+          </a:p>
+        </p:txBody>
+      </p:sp>
+      <p:cxnSp>
+        <p:nvCxnSpPr>
+          <p:cNvPr id="47" name="Google Shape;80;p15">
+            <a:extLst>
+              <a:ext uri="{FF2B5EF4-FFF2-40B4-BE49-F238E27FC236}">
+                <a16:creationId xmlns:a16="http://schemas.microsoft.com/office/drawing/2014/main" id="{B9D2D41C-150C-D6BB-4081-15C328FB9C45}"/>
+              </a:ext>
+            </a:extLst>
+          </p:cNvPr>
+          <p:cNvCxnSpPr/>
+          <p:nvPr/>
+        </p:nvCxnSpPr>
+        <p:spPr>
+          <a:xfrm>
+            <a:off x="5607720" y="1625760"/>
+            <a:ext cx="16043400" cy="1080"/>
+          </a:xfrm>
+          <a:prstGeom prst="straightConnector1">
+            <a:avLst/>
+          </a:prstGeom>
+          <a:ln w="28575">
+            <a:solidFill>
+              <a:srgbClr val="999999"/>
+            </a:solidFill>
+            <a:prstDash val="dash"/>
+            <a:round/>
+          </a:ln>
+        </p:spPr>
+      </p:cxnSp>
+      <p:cxnSp>
+        <p:nvCxnSpPr>
+          <p:cNvPr id="48" name="Google Shape;81;p15">
+            <a:extLst>
+              <a:ext uri="{FF2B5EF4-FFF2-40B4-BE49-F238E27FC236}">
+                <a16:creationId xmlns:a16="http://schemas.microsoft.com/office/drawing/2014/main" id="{06D541C3-B34D-A031-2C27-3DE8A013D113}"/>
+              </a:ext>
+            </a:extLst>
+          </p:cNvPr>
+          <p:cNvCxnSpPr/>
+          <p:nvPr/>
+        </p:nvCxnSpPr>
+        <p:spPr>
+          <a:xfrm>
+            <a:off x="5607720" y="3201840"/>
+            <a:ext cx="16043400" cy="1080"/>
+          </a:xfrm>
+          <a:prstGeom prst="straightConnector1">
+            <a:avLst/>
+          </a:prstGeom>
+          <a:ln w="28575">
+            <a:solidFill>
+              <a:srgbClr val="999999"/>
+            </a:solidFill>
+            <a:prstDash val="dash"/>
+            <a:round/>
+          </a:ln>
+        </p:spPr>
+      </p:cxnSp>
+      <p:cxnSp>
+        <p:nvCxnSpPr>
+          <p:cNvPr id="49" name="Google Shape;82;p15">
+            <a:extLst>
+              <a:ext uri="{FF2B5EF4-FFF2-40B4-BE49-F238E27FC236}">
+                <a16:creationId xmlns:a16="http://schemas.microsoft.com/office/drawing/2014/main" id="{0B2587F0-5002-3140-013A-127D38B7CDEA}"/>
+              </a:ext>
+            </a:extLst>
+          </p:cNvPr>
+          <p:cNvCxnSpPr/>
+          <p:nvPr/>
+        </p:nvCxnSpPr>
+        <p:spPr>
+          <a:xfrm>
+            <a:off x="5607720" y="4777560"/>
+            <a:ext cx="16043400" cy="1080"/>
+          </a:xfrm>
+          <a:prstGeom prst="straightConnector1">
+            <a:avLst/>
+          </a:prstGeom>
+          <a:ln w="28575">
+            <a:solidFill>
+              <a:srgbClr val="999999"/>
+            </a:solidFill>
+            <a:prstDash val="dash"/>
+            <a:round/>
+          </a:ln>
+        </p:spPr>
+      </p:cxnSp>
+      <p:cxnSp>
+        <p:nvCxnSpPr>
+          <p:cNvPr id="50" name="Google Shape;83;p15">
+            <a:extLst>
+              <a:ext uri="{FF2B5EF4-FFF2-40B4-BE49-F238E27FC236}">
+                <a16:creationId xmlns:a16="http://schemas.microsoft.com/office/drawing/2014/main" id="{AECEDE54-E3AE-F7C3-7A32-0282FE4CDA59}"/>
+              </a:ext>
+            </a:extLst>
+          </p:cNvPr>
+          <p:cNvCxnSpPr/>
+          <p:nvPr/>
+        </p:nvCxnSpPr>
+        <p:spPr>
+          <a:xfrm>
+            <a:off x="5607720" y="6353640"/>
+            <a:ext cx="16043400" cy="1080"/>
+          </a:xfrm>
+          <a:prstGeom prst="straightConnector1">
+            <a:avLst/>
+          </a:prstGeom>
+          <a:ln w="28575">
+            <a:solidFill>
+              <a:srgbClr val="999999"/>
+            </a:solidFill>
+            <a:prstDash val="dash"/>
+            <a:round/>
+          </a:ln>
+        </p:spPr>
+      </p:cxnSp>
+      <p:cxnSp>
+        <p:nvCxnSpPr>
+          <p:cNvPr id="51" name="Google Shape;84;p15">
+            <a:extLst>
+              <a:ext uri="{FF2B5EF4-FFF2-40B4-BE49-F238E27FC236}">
+                <a16:creationId xmlns:a16="http://schemas.microsoft.com/office/drawing/2014/main" id="{E9816BE7-9A80-AF09-53FD-A6AD0A9A5C66}"/>
+              </a:ext>
+            </a:extLst>
+          </p:cNvPr>
+          <p:cNvCxnSpPr/>
+          <p:nvPr/>
+        </p:nvCxnSpPr>
+        <p:spPr>
+          <a:xfrm>
+            <a:off x="5607720" y="7929360"/>
+            <a:ext cx="16043400" cy="1080"/>
+          </a:xfrm>
+          <a:prstGeom prst="straightConnector1">
+            <a:avLst/>
+          </a:prstGeom>
+          <a:ln w="28575">
+            <a:solidFill>
+              <a:srgbClr val="999999"/>
+            </a:solidFill>
+            <a:prstDash val="dash"/>
+            <a:round/>
+          </a:ln>
+        </p:spPr>
+      </p:cxnSp>
+      <p:cxnSp>
+        <p:nvCxnSpPr>
+          <p:cNvPr id="52" name="Google Shape;85;p15">
+            <a:extLst>
+              <a:ext uri="{FF2B5EF4-FFF2-40B4-BE49-F238E27FC236}">
+                <a16:creationId xmlns:a16="http://schemas.microsoft.com/office/drawing/2014/main" id="{57493F2E-C542-AC27-8870-BFCFE82D4772}"/>
+              </a:ext>
+            </a:extLst>
+          </p:cNvPr>
+          <p:cNvCxnSpPr/>
+          <p:nvPr/>
+        </p:nvCxnSpPr>
+        <p:spPr>
+          <a:xfrm>
+            <a:off x="5607720" y="9505440"/>
+            <a:ext cx="16043400" cy="1080"/>
+          </a:xfrm>
+          <a:prstGeom prst="straightConnector1">
+            <a:avLst/>
+          </a:prstGeom>
+          <a:ln w="28575">
+            <a:solidFill>
+              <a:srgbClr val="999999"/>
+            </a:solidFill>
+            <a:prstDash val="dash"/>
+            <a:round/>
+          </a:ln>
+        </p:spPr>
+      </p:cxnSp>
+      <p:sp>
+        <p:nvSpPr>
+          <p:cNvPr id="53" name="Google Shape;86;p15">
+            <a:extLst>
+              <a:ext uri="{FF2B5EF4-FFF2-40B4-BE49-F238E27FC236}">
+                <a16:creationId xmlns:a16="http://schemas.microsoft.com/office/drawing/2014/main" id="{8EB2805B-B679-2A77-2CFD-48E0DE4437DA}"/>
+              </a:ext>
+            </a:extLst>
+          </p:cNvPr>
+          <p:cNvSpPr/>
+          <p:nvPr/>
+        </p:nvSpPr>
+        <p:spPr>
+          <a:xfrm>
+            <a:off x="6395940" y="1257039"/>
+            <a:ext cx="2436120" cy="3838374"/>
+          </a:xfrm>
+          <a:prstGeom prst="roundRect">
+            <a:avLst>
+              <a:gd name="adj" fmla="val 16667"/>
+            </a:avLst>
+          </a:prstGeom>
+          <a:solidFill>
+            <a:srgbClr val="D9EAD3"/>
+          </a:solidFill>
+          <a:ln w="28575">
+            <a:solidFill>
+              <a:srgbClr val="274E13"/>
+            </a:solidFill>
+            <a:round/>
+          </a:ln>
+        </p:spPr>
+        <p:style>
+          <a:lnRef idx="0">
+            <a:scrgbClr r="0" g="0" b="0"/>
+          </a:lnRef>
+          <a:fillRef idx="0">
+            <a:scrgbClr r="0" g="0" b="0"/>
+          </a:fillRef>
+          <a:effectRef idx="0">
+            <a:scrgbClr r="0" g="0" b="0"/>
+          </a:effectRef>
+          <a:fontRef idx="minor"/>
+        </p:style>
+        <p:txBody>
+          <a:bodyPr lIns="90000" tIns="91440" rIns="90000" bIns="91440" anchor="t">
+            <a:noAutofit/>
+          </a:bodyPr>
+          <a:lstStyle/>
+          <a:p>
+            <a:pPr>
+              <a:lnSpc>
+                <a:spcPct val="100000"/>
+              </a:lnSpc>
+            </a:pPr>
+            <a:r>
+              <a:rPr lang="en-GB" sz="1400" b="0" u="none" strike="noStrike" dirty="0">
+                <a:solidFill>
+                  <a:srgbClr val="000000"/>
+                </a:solidFill>
+                <a:effectLst/>
+                <a:uFillTx/>
+                <a:latin typeface="Consolas"/>
+                <a:ea typeface="Consolas"/>
+              </a:rPr>
+              <a:t>US1: </a:t>
+            </a:r>
+            <a:r>
+              <a:rPr lang="en-US" sz="1400" dirty="0">
+                <a:solidFill>
+                  <a:srgbClr val="000000"/>
+                </a:solidFill>
+                <a:ea typeface="Arial"/>
+              </a:rPr>
+              <a:t>As a Mindustry player, I want to upgrade machines with efficiency levels, so that I can create more resources per time unit in case of drills and other resource generators, and have better defences in case of weapons.</a:t>
+            </a:r>
+            <a:endParaRPr lang="pt-PT" sz="1400" b="0" u="none" strike="noStrike" dirty="0">
+              <a:solidFill>
+                <a:srgbClr val="000000"/>
+              </a:solidFill>
+              <a:effectLst/>
+              <a:uFillTx/>
+              <a:latin typeface="Arial"/>
+            </a:endParaRPr>
+          </a:p>
+        </p:txBody>
+      </p:sp>
+      <p:sp>
+        <p:nvSpPr>
+          <p:cNvPr id="54" name="Google Shape;87;p15">
+            <a:extLst>
+              <a:ext uri="{FF2B5EF4-FFF2-40B4-BE49-F238E27FC236}">
+                <a16:creationId xmlns:a16="http://schemas.microsoft.com/office/drawing/2014/main" id="{3B1F639D-90B0-1A58-C539-E09F74DF2154}"/>
+              </a:ext>
+            </a:extLst>
+          </p:cNvPr>
+          <p:cNvSpPr/>
+          <p:nvPr/>
+        </p:nvSpPr>
+        <p:spPr>
+          <a:xfrm>
+            <a:off x="167400" y="6967080"/>
+            <a:ext cx="2436120" cy="2775600"/>
+          </a:xfrm>
+          <a:prstGeom prst="roundRect">
+            <a:avLst>
+              <a:gd name="adj" fmla="val 16667"/>
+            </a:avLst>
+          </a:prstGeom>
+          <a:solidFill>
+            <a:srgbClr val="D9EAD3"/>
+          </a:solidFill>
+          <a:ln w="28575">
+            <a:solidFill>
+              <a:srgbClr val="274E13"/>
+            </a:solidFill>
+            <a:round/>
+          </a:ln>
+        </p:spPr>
+        <p:style>
+          <a:lnRef idx="0">
+            <a:scrgbClr r="0" g="0" b="0"/>
+          </a:lnRef>
+          <a:fillRef idx="0">
+            <a:scrgbClr r="0" g="0" b="0"/>
+          </a:fillRef>
+          <a:effectRef idx="0">
+            <a:scrgbClr r="0" g="0" b="0"/>
+          </a:effectRef>
+          <a:fontRef idx="minor"/>
+        </p:style>
+        <p:txBody>
+          <a:bodyPr lIns="90000" tIns="91440" rIns="90000" bIns="91440" anchor="t">
+            <a:noAutofit/>
+          </a:bodyPr>
+          <a:lstStyle/>
+          <a:p>
+            <a:pPr>
+              <a:lnSpc>
+                <a:spcPct val="100000"/>
+              </a:lnSpc>
+            </a:pPr>
+            <a:r>
+              <a:rPr lang="en-GB" sz="1400" b="0" u="none" strike="noStrike" dirty="0">
+                <a:solidFill>
+                  <a:srgbClr val="000000"/>
+                </a:solidFill>
+                <a:effectLst/>
+                <a:uFillTx/>
+                <a:latin typeface="Consolas"/>
+                <a:ea typeface="Consolas"/>
+              </a:rPr>
+              <a:t>US3: </a:t>
+            </a:r>
+            <a:r>
+              <a:rPr lang="en-US" sz="1400" dirty="0">
+                <a:solidFill>
+                  <a:srgbClr val="000000"/>
+                </a:solidFill>
+                <a:ea typeface="Arial"/>
+              </a:rPr>
+              <a:t>As a veteran player, I want to orchestrate a new defensive strategy by pulling enemy air units to the ground, so that I can play the game in a more creative way.</a:t>
+            </a:r>
+            <a:endParaRPr lang="pt-PT" sz="1400" b="0" u="none" strike="noStrike" dirty="0">
+              <a:solidFill>
+                <a:srgbClr val="000000"/>
+              </a:solidFill>
+              <a:effectLst/>
+              <a:uFillTx/>
+              <a:latin typeface="Arial"/>
+            </a:endParaRPr>
+          </a:p>
+        </p:txBody>
+      </p:sp>
+      <p:cxnSp>
+        <p:nvCxnSpPr>
+          <p:cNvPr id="55" name="Google Shape;91;p15">
+            <a:extLst>
+              <a:ext uri="{FF2B5EF4-FFF2-40B4-BE49-F238E27FC236}">
+                <a16:creationId xmlns:a16="http://schemas.microsoft.com/office/drawing/2014/main" id="{0C8C7E71-73BF-6917-49BA-2EBCE132FB2F}"/>
+              </a:ext>
+            </a:extLst>
+          </p:cNvPr>
+          <p:cNvCxnSpPr/>
+          <p:nvPr/>
+        </p:nvCxnSpPr>
+        <p:spPr>
+          <a:xfrm>
+            <a:off x="2874240" y="-28440"/>
+            <a:ext cx="1080" cy="10857960"/>
+          </a:xfrm>
+          <a:prstGeom prst="straightConnector1">
+            <a:avLst/>
+          </a:prstGeom>
+          <a:ln w="38100">
+            <a:solidFill>
+              <a:srgbClr val="5B0F00"/>
+            </a:solidFill>
+            <a:round/>
+          </a:ln>
+        </p:spPr>
+      </p:cxnSp>
+      <p:sp>
+        <p:nvSpPr>
+          <p:cNvPr id="56" name="Google Shape;92;p15">
+            <a:extLst>
+              <a:ext uri="{FF2B5EF4-FFF2-40B4-BE49-F238E27FC236}">
+                <a16:creationId xmlns:a16="http://schemas.microsoft.com/office/drawing/2014/main" id="{189D625E-A668-C98F-BF0D-6B132E939699}"/>
+              </a:ext>
+            </a:extLst>
+          </p:cNvPr>
+          <p:cNvSpPr/>
+          <p:nvPr/>
+        </p:nvSpPr>
+        <p:spPr>
+          <a:xfrm>
+            <a:off x="6422220" y="6126258"/>
+            <a:ext cx="2436120" cy="3616422"/>
+          </a:xfrm>
+          <a:prstGeom prst="roundRect">
+            <a:avLst>
+              <a:gd name="adj" fmla="val 16667"/>
+            </a:avLst>
+          </a:prstGeom>
+          <a:solidFill>
+            <a:srgbClr val="D9EAD3"/>
+          </a:solidFill>
+          <a:ln w="28575">
+            <a:solidFill>
+              <a:srgbClr val="274E13"/>
+            </a:solidFill>
+            <a:round/>
+          </a:ln>
+        </p:spPr>
+        <p:style>
+          <a:lnRef idx="0">
+            <a:scrgbClr r="0" g="0" b="0"/>
+          </a:lnRef>
+          <a:fillRef idx="0">
+            <a:scrgbClr r="0" g="0" b="0"/>
+          </a:fillRef>
+          <a:effectRef idx="0">
+            <a:scrgbClr r="0" g="0" b="0"/>
+          </a:effectRef>
+          <a:fontRef idx="minor"/>
+        </p:style>
+        <p:txBody>
+          <a:bodyPr lIns="90000" tIns="91440" rIns="90000" bIns="91440" anchor="t">
+            <a:noAutofit/>
+          </a:bodyPr>
+          <a:lstStyle/>
+          <a:p>
+            <a:pPr>
+              <a:lnSpc>
+                <a:spcPct val="100000"/>
+              </a:lnSpc>
+            </a:pPr>
+            <a:r>
+              <a:rPr lang="en-GB" sz="1400" b="0" u="none" strike="noStrike" dirty="0">
+                <a:solidFill>
+                  <a:srgbClr val="000000"/>
+                </a:solidFill>
+                <a:effectLst/>
+                <a:uFillTx/>
+                <a:latin typeface="Consolas"/>
+                <a:ea typeface="Consolas"/>
+              </a:rPr>
+              <a:t>US2: </a:t>
+            </a:r>
+            <a:r>
+              <a:rPr lang="en-US" sz="1400" dirty="0">
+                <a:solidFill>
+                  <a:srgbClr val="000000"/>
+                </a:solidFill>
+                <a:ea typeface="Arial"/>
+              </a:rPr>
+              <a:t>As a player that likes to keep track of everything, I want to receive a text warning everytime I misplace a conveyor for whatever reason and obtain possible fixes, so that I can have everything under my watch and build solid structures quickly.</a:t>
+            </a:r>
+            <a:endParaRPr lang="pt-PT" sz="1400" b="0" u="none" strike="noStrike" dirty="0">
+              <a:solidFill>
+                <a:srgbClr val="000000"/>
+              </a:solidFill>
+              <a:effectLst/>
+              <a:uFillTx/>
+              <a:latin typeface="Arial"/>
+            </a:endParaRPr>
+          </a:p>
+        </p:txBody>
+      </p:sp>
+      <p:sp>
+        <p:nvSpPr>
+          <p:cNvPr id="5" name="Google Shape;86;p15">
+            <a:extLst>
+              <a:ext uri="{FF2B5EF4-FFF2-40B4-BE49-F238E27FC236}">
+                <a16:creationId xmlns:a16="http://schemas.microsoft.com/office/drawing/2014/main" id="{FE843AF7-7EBD-7A79-BE98-0005E7DCFC37}"/>
+              </a:ext>
+            </a:extLst>
+          </p:cNvPr>
+          <p:cNvSpPr/>
+          <p:nvPr/>
+        </p:nvSpPr>
+        <p:spPr>
+          <a:xfrm>
+            <a:off x="15532560" y="5913499"/>
+            <a:ext cx="2436120" cy="879561"/>
+          </a:xfrm>
+          <a:prstGeom prst="roundRect">
+            <a:avLst>
+              <a:gd name="adj" fmla="val 16667"/>
+            </a:avLst>
+          </a:prstGeom>
+          <a:solidFill>
+            <a:srgbClr val="D9EAD3"/>
+          </a:solidFill>
+          <a:ln w="28575">
+            <a:solidFill>
+              <a:srgbClr val="274E13"/>
+            </a:solidFill>
+            <a:round/>
+          </a:ln>
+        </p:spPr>
+        <p:style>
+          <a:lnRef idx="0">
+            <a:scrgbClr r="0" g="0" b="0"/>
+          </a:lnRef>
+          <a:fillRef idx="0">
+            <a:scrgbClr r="0" g="0" b="0"/>
+          </a:fillRef>
+          <a:effectRef idx="0">
+            <a:scrgbClr r="0" g="0" b="0"/>
+          </a:effectRef>
+          <a:fontRef idx="minor"/>
+        </p:style>
+        <p:txBody>
+          <a:bodyPr lIns="90000" tIns="91440" rIns="90000" bIns="91440" anchor="t">
+            <a:noAutofit/>
+          </a:bodyPr>
+          <a:lstStyle/>
+          <a:p>
+            <a:pPr>
+              <a:lnSpc>
+                <a:spcPct val="100000"/>
+              </a:lnSpc>
+            </a:pPr>
+            <a:r>
+              <a:rPr lang="pt-PT" sz="1400" b="0" u="none" strike="noStrike" dirty="0">
+                <a:solidFill>
+                  <a:srgbClr val="000000"/>
+                </a:solidFill>
+                <a:effectLst/>
+                <a:uFillTx/>
+                <a:latin typeface="Arial"/>
+              </a:rPr>
+              <a:t>Review and map the existing code related to machines.</a:t>
+            </a:r>
+          </a:p>
+        </p:txBody>
+      </p:sp>
+      <p:sp>
+        <p:nvSpPr>
+          <p:cNvPr id="6" name="Rectangle 1">
+            <a:extLst>
+              <a:ext uri="{FF2B5EF4-FFF2-40B4-BE49-F238E27FC236}">
+                <a16:creationId xmlns:a16="http://schemas.microsoft.com/office/drawing/2014/main" id="{6C42508C-D1BE-4FBE-C644-D8EDDDDA8C6B}"/>
+              </a:ext>
+            </a:extLst>
+          </p:cNvPr>
+          <p:cNvSpPr>
+            <a:spLocks noChangeArrowheads="1"/>
+          </p:cNvSpPr>
+          <p:nvPr/>
+        </p:nvSpPr>
+        <p:spPr bwMode="auto">
+          <a:xfrm>
+            <a:off x="0" y="0"/>
+            <a:ext cx="21599525" cy="0"/>
+          </a:xfrm>
+          <a:prstGeom prst="rect">
+            <a:avLst/>
+          </a:prstGeom>
+          <a:noFill/>
+          <a:ln>
+            <a:noFill/>
+          </a:ln>
+          <a:effectLst/>
+          <a:extLst>
+            <a:ext uri="{909E8E84-426E-40DD-AFC4-6F175D3DCCD1}">
+              <a14:hiddenFill xmlns:a14="http://schemas.microsoft.com/office/drawing/2010/main">
+                <a:solidFill>
+                  <a:schemeClr val="accent1"/>
+                </a:solidFill>
+              </a14:hiddenFill>
+            </a:ext>
+            <a:ext uri="{91240B29-F687-4F45-9708-019B960494DF}">
+              <a14:hiddenLine xmlns:a14="http://schemas.microsoft.com/office/drawing/2010/main" w="9525">
+                <a:solidFill>
+                  <a:schemeClr val="tx1"/>
+                </a:solidFill>
+                <a:miter lim="800000"/>
+                <a:headEnd/>
+                <a:tailEnd/>
+              </a14:hiddenLine>
+            </a:ext>
+            <a:ext uri="{AF507438-7753-43E0-B8FC-AC1667EBCBE1}">
+              <a14:hiddenEffects xmlns:a14="http://schemas.microsoft.com/office/drawing/2010/main">
+                <a:effectLst>
+                  <a:outerShdw dist="35921" dir="2700000" algn="ctr" rotWithShape="0">
+                    <a:schemeClr val="bg2"/>
+                  </a:outerShdw>
+                </a:effectLst>
+              </a14:hiddenEffects>
+            </a:ext>
+          </a:extLst>
+        </p:spPr>
+        <p:txBody>
+          <a:bodyPr vert="horz" wrap="none" lIns="91440" tIns="45720" rIns="91440" bIns="45720" numCol="1" anchor="ctr" anchorCtr="0" compatLnSpc="1">
+            <a:prstTxWarp prst="textNoShape">
+              <a:avLst/>
+            </a:prstTxWarp>
+            <a:spAutoFit/>
+          </a:bodyPr>
+          <a:lstStyle/>
+          <a:p>
+            <a:pPr marL="0" marR="0" lvl="0" indent="0" algn="l" defTabSz="914400" rtl="0" eaLnBrk="0" fontAlgn="base" latinLnBrk="0" hangingPunct="0">
+              <a:lnSpc>
+                <a:spcPct val="100000"/>
+              </a:lnSpc>
+              <a:spcBef>
+                <a:spcPct val="0"/>
+              </a:spcBef>
+              <a:spcAft>
+                <a:spcPct val="0"/>
+              </a:spcAft>
+              <a:buClrTx/>
+              <a:buSzTx/>
+              <a:buFontTx/>
+              <a:buChar char="•"/>
+              <a:tabLst/>
+            </a:pPr>
+            <a:r>
+              <a:rPr kumimoji="0" lang="en-US" altLang="en-US" sz="1800" b="0" i="0" u="none" strike="noStrike" cap="none" normalizeH="0" baseline="0">
+                <a:ln>
+                  <a:noFill/>
+                </a:ln>
+                <a:solidFill>
+                  <a:schemeClr val="tx1"/>
+                </a:solidFill>
+                <a:effectLst/>
+                <a:latin typeface="Arial" panose="020B0604020202020204" pitchFamily="34" charset="0"/>
+              </a:rPr>
+              <a:t>Review and map the existing code related to machine efficiency and stats.</a:t>
+            </a:r>
+          </a:p>
+          <a:p>
+            <a:pPr marL="0" marR="0" lvl="0" indent="0" algn="l" defTabSz="914400" rtl="0" eaLnBrk="0" fontAlgn="base" latinLnBrk="0" hangingPunct="0">
+              <a:lnSpc>
+                <a:spcPct val="100000"/>
+              </a:lnSpc>
+              <a:spcBef>
+                <a:spcPct val="0"/>
+              </a:spcBef>
+              <a:spcAft>
+                <a:spcPct val="0"/>
+              </a:spcAft>
+              <a:buClrTx/>
+              <a:buSzTx/>
+              <a:buFontTx/>
+              <a:buChar char="•"/>
+              <a:tabLst/>
+            </a:pPr>
+            <a:endParaRPr kumimoji="0" lang="en-US" altLang="en-US" sz="1800" b="0" i="0" u="none" strike="noStrike" cap="none" normalizeH="0" baseline="0">
+              <a:ln>
+                <a:noFill/>
+              </a:ln>
+              <a:solidFill>
+                <a:schemeClr val="tx1"/>
+              </a:solidFill>
+              <a:effectLst/>
+              <a:latin typeface="Arial" panose="020B0604020202020204" pitchFamily="34" charset="0"/>
+            </a:endParaRPr>
+          </a:p>
+        </p:txBody>
+      </p:sp>
+      <p:sp>
+        <p:nvSpPr>
+          <p:cNvPr id="8" name="Google Shape;86;p15">
+            <a:extLst>
+              <a:ext uri="{FF2B5EF4-FFF2-40B4-BE49-F238E27FC236}">
+                <a16:creationId xmlns:a16="http://schemas.microsoft.com/office/drawing/2014/main" id="{6956E678-D824-4F4B-C6E6-30647D1963FB}"/>
+              </a:ext>
+            </a:extLst>
+          </p:cNvPr>
+          <p:cNvSpPr/>
+          <p:nvPr/>
+        </p:nvSpPr>
+        <p:spPr>
+          <a:xfrm>
+            <a:off x="15532560" y="7553740"/>
+            <a:ext cx="2436120" cy="1158203"/>
+          </a:xfrm>
+          <a:prstGeom prst="roundRect">
+            <a:avLst>
+              <a:gd name="adj" fmla="val 16667"/>
+            </a:avLst>
+          </a:prstGeom>
+          <a:solidFill>
+            <a:srgbClr val="D9EAD3"/>
+          </a:solidFill>
+          <a:ln w="28575">
+            <a:solidFill>
+              <a:srgbClr val="274E13"/>
+            </a:solidFill>
+            <a:round/>
+          </a:ln>
+        </p:spPr>
+        <p:style>
+          <a:lnRef idx="0">
+            <a:scrgbClr r="0" g="0" b="0"/>
+          </a:lnRef>
+          <a:fillRef idx="0">
+            <a:scrgbClr r="0" g="0" b="0"/>
+          </a:fillRef>
+          <a:effectRef idx="0">
+            <a:scrgbClr r="0" g="0" b="0"/>
+          </a:effectRef>
+          <a:fontRef idx="minor"/>
+        </p:style>
+        <p:txBody>
+          <a:bodyPr lIns="90000" tIns="91440" rIns="90000" bIns="91440" anchor="t">
+            <a:noAutofit/>
+          </a:bodyPr>
+          <a:lstStyle/>
+          <a:p>
+            <a:pPr>
+              <a:lnSpc>
+                <a:spcPct val="100000"/>
+              </a:lnSpc>
+            </a:pPr>
+            <a:r>
+              <a:rPr lang="pt-PT" sz="1400" b="0" u="none" strike="noStrike" dirty="0">
+                <a:solidFill>
+                  <a:srgbClr val="000000"/>
+                </a:solidFill>
+                <a:effectLst/>
+                <a:uFillTx/>
+                <a:latin typeface="Arial"/>
+              </a:rPr>
+              <a:t>Identify the classes that could support upgrade levels or if there’s a need to create new ones/</a:t>
+            </a:r>
+          </a:p>
+        </p:txBody>
+      </p:sp>
+      <p:sp>
+        <p:nvSpPr>
+          <p:cNvPr id="9" name="Google Shape;86;p15">
+            <a:extLst>
+              <a:ext uri="{FF2B5EF4-FFF2-40B4-BE49-F238E27FC236}">
+                <a16:creationId xmlns:a16="http://schemas.microsoft.com/office/drawing/2014/main" id="{41F72F27-EAAB-B0F0-0519-257DFD25A299}"/>
+              </a:ext>
+            </a:extLst>
+          </p:cNvPr>
+          <p:cNvSpPr/>
+          <p:nvPr/>
+        </p:nvSpPr>
+        <p:spPr>
+          <a:xfrm>
+            <a:off x="15536797" y="9128380"/>
+            <a:ext cx="2436120" cy="1158203"/>
+          </a:xfrm>
+          <a:prstGeom prst="roundRect">
+            <a:avLst>
+              <a:gd name="adj" fmla="val 16667"/>
+            </a:avLst>
+          </a:prstGeom>
+          <a:solidFill>
+            <a:srgbClr val="D9EAD3"/>
+          </a:solidFill>
+          <a:ln w="28575">
+            <a:solidFill>
+              <a:srgbClr val="274E13"/>
+            </a:solidFill>
+            <a:round/>
+          </a:ln>
+        </p:spPr>
+        <p:style>
+          <a:lnRef idx="0">
+            <a:scrgbClr r="0" g="0" b="0"/>
+          </a:lnRef>
+          <a:fillRef idx="0">
+            <a:scrgbClr r="0" g="0" b="0"/>
+          </a:fillRef>
+          <a:effectRef idx="0">
+            <a:scrgbClr r="0" g="0" b="0"/>
+          </a:effectRef>
+          <a:fontRef idx="minor"/>
+        </p:style>
+        <p:txBody>
+          <a:bodyPr lIns="90000" tIns="91440" rIns="90000" bIns="91440" anchor="t">
+            <a:noAutofit/>
+          </a:bodyPr>
+          <a:lstStyle/>
+          <a:p>
+            <a:pPr>
+              <a:lnSpc>
+                <a:spcPct val="100000"/>
+              </a:lnSpc>
+            </a:pPr>
+            <a:r>
+              <a:rPr lang="pt-PT" sz="1400" dirty="0">
+                <a:solidFill>
+                  <a:srgbClr val="000000"/>
+                </a:solidFill>
+                <a:latin typeface="Arial"/>
+              </a:rPr>
+              <a:t>Draft possible methods needed for implementing efficieny upgrades.</a:t>
+            </a:r>
+            <a:endParaRPr lang="pt-PT" sz="1400" b="0" u="none" strike="noStrike" dirty="0">
+              <a:solidFill>
+                <a:srgbClr val="000000"/>
+              </a:solidFill>
+              <a:effectLst/>
+              <a:uFillTx/>
+              <a:latin typeface="Arial"/>
+            </a:endParaRPr>
+          </a:p>
+        </p:txBody>
+      </p:sp>
+      <p:sp>
+        <p:nvSpPr>
+          <p:cNvPr id="10" name="Google Shape;86;p15">
+            <a:extLst>
+              <a:ext uri="{FF2B5EF4-FFF2-40B4-BE49-F238E27FC236}">
+                <a16:creationId xmlns:a16="http://schemas.microsoft.com/office/drawing/2014/main" id="{8560747D-AD5F-22DC-F591-73A5396DD9B4}"/>
+              </a:ext>
+            </a:extLst>
+          </p:cNvPr>
+          <p:cNvSpPr/>
+          <p:nvPr/>
+        </p:nvSpPr>
+        <p:spPr>
+          <a:xfrm>
+            <a:off x="15532560" y="1127097"/>
+            <a:ext cx="2436120" cy="1158203"/>
+          </a:xfrm>
+          <a:prstGeom prst="roundRect">
+            <a:avLst>
+              <a:gd name="adj" fmla="val 16667"/>
+            </a:avLst>
+          </a:prstGeom>
+          <a:solidFill>
+            <a:srgbClr val="D9EAD3"/>
+          </a:solidFill>
+          <a:ln w="28575">
+            <a:solidFill>
+              <a:srgbClr val="274E13"/>
+            </a:solidFill>
+            <a:round/>
+          </a:ln>
+        </p:spPr>
+        <p:style>
+          <a:lnRef idx="0">
+            <a:scrgbClr r="0" g="0" b="0"/>
+          </a:lnRef>
+          <a:fillRef idx="0">
+            <a:scrgbClr r="0" g="0" b="0"/>
+          </a:fillRef>
+          <a:effectRef idx="0">
+            <a:scrgbClr r="0" g="0" b="0"/>
+          </a:effectRef>
+          <a:fontRef idx="minor"/>
+        </p:style>
+        <p:txBody>
+          <a:bodyPr lIns="90000" tIns="91440" rIns="90000" bIns="91440" anchor="t">
+            <a:noAutofit/>
+          </a:bodyPr>
+          <a:lstStyle/>
+          <a:p>
+            <a:pPr>
+              <a:lnSpc>
+                <a:spcPct val="100000"/>
+              </a:lnSpc>
+            </a:pPr>
+            <a:r>
+              <a:rPr lang="pt-PT" sz="1400" b="0" u="none" strike="noStrike" dirty="0">
+                <a:solidFill>
+                  <a:srgbClr val="000000"/>
+                </a:solidFill>
+                <a:effectLst/>
+                <a:uFillTx/>
+                <a:latin typeface="Arial"/>
+              </a:rPr>
+              <a:t>Review and map converyor related code, such as error detection.</a:t>
+            </a:r>
+          </a:p>
+        </p:txBody>
+      </p:sp>
+      <p:sp>
+        <p:nvSpPr>
+          <p:cNvPr id="11" name="Google Shape;86;p15">
+            <a:extLst>
+              <a:ext uri="{FF2B5EF4-FFF2-40B4-BE49-F238E27FC236}">
+                <a16:creationId xmlns:a16="http://schemas.microsoft.com/office/drawing/2014/main" id="{41BA1EF1-9533-C028-C0F2-CC4DF63227CF}"/>
+              </a:ext>
+            </a:extLst>
+          </p:cNvPr>
+          <p:cNvSpPr/>
+          <p:nvPr/>
+        </p:nvSpPr>
+        <p:spPr>
+          <a:xfrm>
+            <a:off x="15532560" y="2726544"/>
+            <a:ext cx="2436120" cy="1158203"/>
+          </a:xfrm>
+          <a:prstGeom prst="roundRect">
+            <a:avLst>
+              <a:gd name="adj" fmla="val 16667"/>
+            </a:avLst>
+          </a:prstGeom>
+          <a:solidFill>
+            <a:srgbClr val="D9EAD3"/>
+          </a:solidFill>
+          <a:ln w="28575">
+            <a:solidFill>
+              <a:srgbClr val="274E13"/>
+            </a:solidFill>
+            <a:round/>
+          </a:ln>
+        </p:spPr>
+        <p:style>
+          <a:lnRef idx="0">
+            <a:scrgbClr r="0" g="0" b="0"/>
+          </a:lnRef>
+          <a:fillRef idx="0">
+            <a:scrgbClr r="0" g="0" b="0"/>
+          </a:fillRef>
+          <a:effectRef idx="0">
+            <a:scrgbClr r="0" g="0" b="0"/>
+          </a:effectRef>
+          <a:fontRef idx="minor"/>
+        </p:style>
+        <p:txBody>
+          <a:bodyPr lIns="90000" tIns="91440" rIns="90000" bIns="91440" anchor="t">
+            <a:noAutofit/>
+          </a:bodyPr>
+          <a:lstStyle/>
+          <a:p>
+            <a:pPr>
+              <a:lnSpc>
+                <a:spcPct val="100000"/>
+              </a:lnSpc>
+            </a:pPr>
+            <a:r>
+              <a:rPr lang="pt-PT" sz="1400" b="0" u="none" strike="noStrike" dirty="0">
+                <a:solidFill>
+                  <a:srgbClr val="000000"/>
+                </a:solidFill>
+                <a:effectLst/>
+                <a:uFillTx/>
+                <a:latin typeface="Arial"/>
+              </a:rPr>
+              <a:t>Locate where warnings and destination checks are currently handled</a:t>
+            </a:r>
+          </a:p>
+        </p:txBody>
+      </p:sp>
+      <p:sp>
+        <p:nvSpPr>
+          <p:cNvPr id="12" name="Google Shape;86;p15">
+            <a:extLst>
+              <a:ext uri="{FF2B5EF4-FFF2-40B4-BE49-F238E27FC236}">
+                <a16:creationId xmlns:a16="http://schemas.microsoft.com/office/drawing/2014/main" id="{A691CAC6-7058-B5AB-F38C-D4E2C2CF898B}"/>
+              </a:ext>
+            </a:extLst>
+          </p:cNvPr>
+          <p:cNvSpPr/>
+          <p:nvPr/>
+        </p:nvSpPr>
+        <p:spPr>
+          <a:xfrm>
+            <a:off x="15532560" y="4316956"/>
+            <a:ext cx="2436120" cy="1158203"/>
+          </a:xfrm>
+          <a:prstGeom prst="roundRect">
+            <a:avLst>
+              <a:gd name="adj" fmla="val 16667"/>
+            </a:avLst>
+          </a:prstGeom>
+          <a:solidFill>
+            <a:srgbClr val="D9EAD3"/>
+          </a:solidFill>
+          <a:ln w="28575">
+            <a:solidFill>
+              <a:srgbClr val="274E13"/>
+            </a:solidFill>
+            <a:round/>
+          </a:ln>
+        </p:spPr>
+        <p:style>
+          <a:lnRef idx="0">
+            <a:scrgbClr r="0" g="0" b="0"/>
+          </a:lnRef>
+          <a:fillRef idx="0">
+            <a:scrgbClr r="0" g="0" b="0"/>
+          </a:fillRef>
+          <a:effectRef idx="0">
+            <a:scrgbClr r="0" g="0" b="0"/>
+          </a:effectRef>
+          <a:fontRef idx="minor"/>
+        </p:style>
+        <p:txBody>
+          <a:bodyPr lIns="90000" tIns="91440" rIns="90000" bIns="91440" anchor="t">
+            <a:noAutofit/>
+          </a:bodyPr>
+          <a:lstStyle/>
+          <a:p>
+            <a:pPr>
+              <a:lnSpc>
+                <a:spcPct val="100000"/>
+              </a:lnSpc>
+            </a:pPr>
+            <a:r>
+              <a:rPr lang="pt-PT" sz="1400" dirty="0">
+                <a:solidFill>
+                  <a:srgbClr val="000000"/>
+                </a:solidFill>
+                <a:latin typeface="Arial"/>
+              </a:rPr>
+              <a:t>Define the structure and behavior of the new warning messages</a:t>
+            </a:r>
+            <a:endParaRPr lang="pt-PT" sz="1400" b="0" u="none" strike="noStrike" dirty="0">
+              <a:solidFill>
+                <a:srgbClr val="000000"/>
+              </a:solidFill>
+              <a:effectLst/>
+              <a:uFillTx/>
+              <a:latin typeface="Arial"/>
+            </a:endParaRPr>
+          </a:p>
+        </p:txBody>
+      </p:sp>
+      <p:sp>
+        <p:nvSpPr>
+          <p:cNvPr id="2" name="Google Shape;86;p15">
+            <a:extLst>
+              <a:ext uri="{FF2B5EF4-FFF2-40B4-BE49-F238E27FC236}">
+                <a16:creationId xmlns:a16="http://schemas.microsoft.com/office/drawing/2014/main" id="{4CBF43E1-0378-1E31-182F-22085CD351A0}"/>
+              </a:ext>
+            </a:extLst>
+          </p:cNvPr>
+          <p:cNvSpPr/>
+          <p:nvPr/>
+        </p:nvSpPr>
+        <p:spPr>
+          <a:xfrm>
+            <a:off x="12424500" y="1382566"/>
+            <a:ext cx="2409840" cy="879561"/>
+          </a:xfrm>
+          <a:prstGeom prst="roundRect">
+            <a:avLst>
+              <a:gd name="adj" fmla="val 16667"/>
+            </a:avLst>
+          </a:prstGeom>
+          <a:solidFill>
+            <a:srgbClr val="D9EAD3"/>
+          </a:solidFill>
+          <a:ln w="28575">
+            <a:solidFill>
+              <a:srgbClr val="274E13"/>
+            </a:solidFill>
+            <a:round/>
+          </a:ln>
+        </p:spPr>
+        <p:style>
+          <a:lnRef idx="0">
+            <a:scrgbClr r="0" g="0" b="0"/>
+          </a:lnRef>
+          <a:fillRef idx="0">
+            <a:scrgbClr r="0" g="0" b="0"/>
+          </a:fillRef>
+          <a:effectRef idx="0">
+            <a:scrgbClr r="0" g="0" b="0"/>
+          </a:effectRef>
+          <a:fontRef idx="minor"/>
+        </p:style>
+        <p:txBody>
+          <a:bodyPr lIns="90000" tIns="91440" rIns="90000" bIns="91440" anchor="t">
+            <a:noAutofit/>
+          </a:bodyPr>
+          <a:lstStyle/>
+          <a:p>
+            <a:pPr>
+              <a:lnSpc>
+                <a:spcPct val="100000"/>
+              </a:lnSpc>
+            </a:pPr>
+            <a:r>
+              <a:rPr lang="pt-PT" sz="1400" dirty="0">
+                <a:solidFill>
+                  <a:srgbClr val="000000"/>
+                </a:solidFill>
+                <a:latin typeface="Arial"/>
+              </a:rPr>
+              <a:t>US1</a:t>
+            </a:r>
+            <a:r>
+              <a:rPr lang="en-US" sz="1400" dirty="0">
+                <a:solidFill>
+                  <a:srgbClr val="000000"/>
+                </a:solidFill>
+                <a:latin typeface="Arial"/>
+              </a:rPr>
+              <a:t>: implementing</a:t>
+            </a:r>
+          </a:p>
+          <a:p>
+            <a:pPr>
+              <a:lnSpc>
+                <a:spcPct val="100000"/>
+              </a:lnSpc>
+            </a:pPr>
+            <a:endParaRPr lang="pt-PT" sz="1400" b="0" u="none" strike="noStrike" dirty="0">
+              <a:solidFill>
+                <a:srgbClr val="000000"/>
+              </a:solidFill>
+              <a:effectLst/>
+              <a:uFillTx/>
+              <a:latin typeface="Arial"/>
+            </a:endParaRPr>
+          </a:p>
+        </p:txBody>
+      </p:sp>
+      <p:sp>
+        <p:nvSpPr>
+          <p:cNvPr id="3" name="Google Shape;86;p15">
+            <a:extLst>
+              <a:ext uri="{FF2B5EF4-FFF2-40B4-BE49-F238E27FC236}">
+                <a16:creationId xmlns:a16="http://schemas.microsoft.com/office/drawing/2014/main" id="{7152AF48-7718-F551-126C-AF68C04A9C13}"/>
+              </a:ext>
+            </a:extLst>
+          </p:cNvPr>
+          <p:cNvSpPr/>
+          <p:nvPr/>
+        </p:nvSpPr>
+        <p:spPr>
+          <a:xfrm>
+            <a:off x="12395880" y="5940128"/>
+            <a:ext cx="2393010" cy="879561"/>
+          </a:xfrm>
+          <a:prstGeom prst="roundRect">
+            <a:avLst>
+              <a:gd name="adj" fmla="val 16667"/>
+            </a:avLst>
+          </a:prstGeom>
+          <a:solidFill>
+            <a:srgbClr val="D9EAD3"/>
+          </a:solidFill>
+          <a:ln w="28575">
+            <a:solidFill>
+              <a:srgbClr val="274E13"/>
+            </a:solidFill>
+            <a:round/>
+          </a:ln>
+        </p:spPr>
+        <p:style>
+          <a:lnRef idx="0">
+            <a:scrgbClr r="0" g="0" b="0"/>
+          </a:lnRef>
+          <a:fillRef idx="0">
+            <a:scrgbClr r="0" g="0" b="0"/>
+          </a:fillRef>
+          <a:effectRef idx="0">
+            <a:scrgbClr r="0" g="0" b="0"/>
+          </a:effectRef>
+          <a:fontRef idx="minor"/>
+        </p:style>
+        <p:txBody>
+          <a:bodyPr lIns="90000" tIns="91440" rIns="90000" bIns="91440" anchor="t">
+            <a:noAutofit/>
+          </a:bodyPr>
+          <a:lstStyle/>
+          <a:p>
+            <a:pPr>
+              <a:lnSpc>
+                <a:spcPct val="100000"/>
+              </a:lnSpc>
+            </a:pPr>
+            <a:r>
+              <a:rPr lang="pt-PT" sz="1400" dirty="0">
+                <a:solidFill>
+                  <a:srgbClr val="000000"/>
+                </a:solidFill>
+                <a:latin typeface="Arial"/>
+              </a:rPr>
+              <a:t>US2</a:t>
+            </a:r>
+            <a:r>
+              <a:rPr lang="en-US" sz="1400" dirty="0">
+                <a:solidFill>
+                  <a:srgbClr val="000000"/>
+                </a:solidFill>
+                <a:latin typeface="Arial"/>
+              </a:rPr>
+              <a:t>: implementing</a:t>
+            </a:r>
+          </a:p>
+          <a:p>
+            <a:pPr>
+              <a:lnSpc>
+                <a:spcPct val="100000"/>
+              </a:lnSpc>
+            </a:pPr>
+            <a:endParaRPr lang="pt-PT" sz="1400" b="0" u="none" strike="noStrike" dirty="0">
+              <a:solidFill>
+                <a:srgbClr val="000000"/>
+              </a:solidFill>
+              <a:effectLst/>
+              <a:uFillTx/>
+              <a:latin typeface="Arial"/>
+            </a:endParaRPr>
+          </a:p>
+        </p:txBody>
+      </p:sp>
+      <p:sp>
+        <p:nvSpPr>
+          <p:cNvPr id="4" name="Google Shape;86;p15">
+            <a:extLst>
+              <a:ext uri="{FF2B5EF4-FFF2-40B4-BE49-F238E27FC236}">
+                <a16:creationId xmlns:a16="http://schemas.microsoft.com/office/drawing/2014/main" id="{5757B0F9-E62B-9C63-CCEA-87F0FE43BE99}"/>
+              </a:ext>
+            </a:extLst>
+          </p:cNvPr>
+          <p:cNvSpPr/>
+          <p:nvPr/>
+        </p:nvSpPr>
+        <p:spPr>
+          <a:xfrm>
+            <a:off x="12424500" y="2775604"/>
+            <a:ext cx="2409840" cy="879561"/>
+          </a:xfrm>
+          <a:prstGeom prst="roundRect">
+            <a:avLst>
+              <a:gd name="adj" fmla="val 16667"/>
+            </a:avLst>
+          </a:prstGeom>
+          <a:solidFill>
+            <a:srgbClr val="D9EAD3"/>
+          </a:solidFill>
+          <a:ln w="28575">
+            <a:solidFill>
+              <a:srgbClr val="274E13"/>
+            </a:solidFill>
+            <a:round/>
+          </a:ln>
+        </p:spPr>
+        <p:style>
+          <a:lnRef idx="0">
+            <a:scrgbClr r="0" g="0" b="0"/>
+          </a:lnRef>
+          <a:fillRef idx="0">
+            <a:scrgbClr r="0" g="0" b="0"/>
+          </a:fillRef>
+          <a:effectRef idx="0">
+            <a:scrgbClr r="0" g="0" b="0"/>
+          </a:effectRef>
+          <a:fontRef idx="minor"/>
+        </p:style>
+        <p:txBody>
+          <a:bodyPr lIns="90000" tIns="91440" rIns="90000" bIns="91440" anchor="t">
+            <a:noAutofit/>
+          </a:bodyPr>
+          <a:lstStyle/>
+          <a:p>
+            <a:pPr>
+              <a:lnSpc>
+                <a:spcPct val="100000"/>
+              </a:lnSpc>
+            </a:pPr>
+            <a:r>
+              <a:rPr lang="pt-PT" sz="1400" dirty="0">
+                <a:solidFill>
+                  <a:srgbClr val="000000"/>
+                </a:solidFill>
+                <a:latin typeface="Arial"/>
+              </a:rPr>
+              <a:t>US1</a:t>
+            </a:r>
+            <a:r>
+              <a:rPr lang="en-US" sz="1400" dirty="0">
+                <a:solidFill>
+                  <a:srgbClr val="000000"/>
+                </a:solidFill>
+                <a:latin typeface="Arial"/>
+              </a:rPr>
+              <a:t>: implementing</a:t>
+            </a:r>
+          </a:p>
+          <a:p>
+            <a:pPr>
+              <a:lnSpc>
+                <a:spcPct val="100000"/>
+              </a:lnSpc>
+            </a:pPr>
+            <a:endParaRPr lang="pt-PT" sz="1400" b="0" u="none" strike="noStrike" dirty="0">
+              <a:solidFill>
+                <a:srgbClr val="000000"/>
+              </a:solidFill>
+              <a:effectLst/>
+              <a:uFillTx/>
+              <a:latin typeface="Arial"/>
+            </a:endParaRPr>
+          </a:p>
+        </p:txBody>
+      </p:sp>
+      <p:sp>
+        <p:nvSpPr>
+          <p:cNvPr id="7" name="Google Shape;86;p15">
+            <a:extLst>
+              <a:ext uri="{FF2B5EF4-FFF2-40B4-BE49-F238E27FC236}">
+                <a16:creationId xmlns:a16="http://schemas.microsoft.com/office/drawing/2014/main" id="{5CF0B81E-A683-EA4D-D850-9682EFE8D6DB}"/>
+              </a:ext>
+            </a:extLst>
+          </p:cNvPr>
+          <p:cNvSpPr/>
+          <p:nvPr/>
+        </p:nvSpPr>
+        <p:spPr>
+          <a:xfrm>
+            <a:off x="12395880" y="4329211"/>
+            <a:ext cx="2409840" cy="879561"/>
+          </a:xfrm>
+          <a:prstGeom prst="roundRect">
+            <a:avLst>
+              <a:gd name="adj" fmla="val 16667"/>
+            </a:avLst>
+          </a:prstGeom>
+          <a:solidFill>
+            <a:srgbClr val="D9EAD3"/>
+          </a:solidFill>
+          <a:ln w="28575">
+            <a:solidFill>
+              <a:srgbClr val="274E13"/>
+            </a:solidFill>
+            <a:round/>
+          </a:ln>
+        </p:spPr>
+        <p:style>
+          <a:lnRef idx="0">
+            <a:scrgbClr r="0" g="0" b="0"/>
+          </a:lnRef>
+          <a:fillRef idx="0">
+            <a:scrgbClr r="0" g="0" b="0"/>
+          </a:fillRef>
+          <a:effectRef idx="0">
+            <a:scrgbClr r="0" g="0" b="0"/>
+          </a:effectRef>
+          <a:fontRef idx="minor"/>
+        </p:style>
+        <p:txBody>
+          <a:bodyPr lIns="90000" tIns="91440" rIns="90000" bIns="91440" anchor="t">
+            <a:noAutofit/>
+          </a:bodyPr>
+          <a:lstStyle/>
+          <a:p>
+            <a:pPr>
+              <a:lnSpc>
+                <a:spcPct val="100000"/>
+              </a:lnSpc>
+            </a:pPr>
+            <a:r>
+              <a:rPr lang="pt-PT" sz="1400" dirty="0">
+                <a:solidFill>
+                  <a:srgbClr val="000000"/>
+                </a:solidFill>
+                <a:latin typeface="Arial"/>
+              </a:rPr>
+              <a:t>US1</a:t>
+            </a:r>
+            <a:r>
+              <a:rPr lang="en-US" sz="1400" dirty="0">
+                <a:solidFill>
+                  <a:srgbClr val="000000"/>
+                </a:solidFill>
+                <a:latin typeface="Arial"/>
+              </a:rPr>
+              <a:t>: implementing</a:t>
+            </a:r>
+          </a:p>
+          <a:p>
+            <a:pPr>
+              <a:lnSpc>
+                <a:spcPct val="100000"/>
+              </a:lnSpc>
+            </a:pPr>
+            <a:endParaRPr lang="pt-PT" sz="1400" b="0" u="none" strike="noStrike" dirty="0">
+              <a:solidFill>
+                <a:srgbClr val="000000"/>
+              </a:solidFill>
+              <a:effectLst/>
+              <a:uFillTx/>
+              <a:latin typeface="Arial"/>
+            </a:endParaRPr>
+          </a:p>
+        </p:txBody>
+      </p:sp>
+      <p:sp>
+        <p:nvSpPr>
+          <p:cNvPr id="14" name="Google Shape;86;p15">
+            <a:extLst>
+              <a:ext uri="{FF2B5EF4-FFF2-40B4-BE49-F238E27FC236}">
+                <a16:creationId xmlns:a16="http://schemas.microsoft.com/office/drawing/2014/main" id="{5D9ABB46-445D-2846-9DF9-AF41EB61458A}"/>
+              </a:ext>
+            </a:extLst>
+          </p:cNvPr>
+          <p:cNvSpPr/>
+          <p:nvPr/>
+        </p:nvSpPr>
+        <p:spPr>
+          <a:xfrm>
+            <a:off x="12395880" y="9079172"/>
+            <a:ext cx="2393010" cy="879561"/>
+          </a:xfrm>
+          <a:prstGeom prst="roundRect">
+            <a:avLst>
+              <a:gd name="adj" fmla="val 16667"/>
+            </a:avLst>
+          </a:prstGeom>
+          <a:solidFill>
+            <a:srgbClr val="D9EAD3"/>
+          </a:solidFill>
+          <a:ln w="28575">
+            <a:solidFill>
+              <a:srgbClr val="274E13"/>
+            </a:solidFill>
+            <a:round/>
+          </a:ln>
+        </p:spPr>
+        <p:style>
+          <a:lnRef idx="0">
+            <a:scrgbClr r="0" g="0" b="0"/>
+          </a:lnRef>
+          <a:fillRef idx="0">
+            <a:scrgbClr r="0" g="0" b="0"/>
+          </a:fillRef>
+          <a:effectRef idx="0">
+            <a:scrgbClr r="0" g="0" b="0"/>
+          </a:effectRef>
+          <a:fontRef idx="minor"/>
+        </p:style>
+        <p:txBody>
+          <a:bodyPr lIns="90000" tIns="91440" rIns="90000" bIns="91440" anchor="t">
+            <a:noAutofit/>
+          </a:bodyPr>
+          <a:lstStyle/>
+          <a:p>
+            <a:pPr>
+              <a:lnSpc>
+                <a:spcPct val="100000"/>
+              </a:lnSpc>
+            </a:pPr>
+            <a:r>
+              <a:rPr lang="pt-PT" sz="1400" dirty="0">
+                <a:solidFill>
+                  <a:srgbClr val="000000"/>
+                </a:solidFill>
+                <a:latin typeface="Arial"/>
+              </a:rPr>
+              <a:t>US2</a:t>
+            </a:r>
+            <a:r>
+              <a:rPr lang="en-US" sz="1400" dirty="0">
+                <a:solidFill>
+                  <a:srgbClr val="000000"/>
+                </a:solidFill>
+                <a:latin typeface="Arial"/>
+              </a:rPr>
+              <a:t>: implementing</a:t>
+            </a:r>
+          </a:p>
+          <a:p>
+            <a:pPr>
+              <a:lnSpc>
+                <a:spcPct val="100000"/>
+              </a:lnSpc>
+            </a:pPr>
+            <a:endParaRPr lang="pt-PT" sz="1400" b="0" u="none" strike="noStrike" dirty="0">
+              <a:solidFill>
+                <a:srgbClr val="000000"/>
+              </a:solidFill>
+              <a:effectLst/>
+              <a:uFillTx/>
+              <a:latin typeface="Arial"/>
+            </a:endParaRPr>
+          </a:p>
+        </p:txBody>
+      </p:sp>
+      <p:sp>
+        <p:nvSpPr>
+          <p:cNvPr id="15" name="Google Shape;86;p15">
+            <a:extLst>
+              <a:ext uri="{FF2B5EF4-FFF2-40B4-BE49-F238E27FC236}">
+                <a16:creationId xmlns:a16="http://schemas.microsoft.com/office/drawing/2014/main" id="{D10A08A2-C74B-536F-7A4C-1C968E1849AA}"/>
+              </a:ext>
+            </a:extLst>
+          </p:cNvPr>
+          <p:cNvSpPr/>
+          <p:nvPr/>
+        </p:nvSpPr>
+        <p:spPr>
+          <a:xfrm>
+            <a:off x="12424500" y="7385601"/>
+            <a:ext cx="2393010" cy="879561"/>
+          </a:xfrm>
+          <a:prstGeom prst="roundRect">
+            <a:avLst>
+              <a:gd name="adj" fmla="val 16667"/>
+            </a:avLst>
+          </a:prstGeom>
+          <a:solidFill>
+            <a:srgbClr val="D9EAD3"/>
+          </a:solidFill>
+          <a:ln w="28575">
+            <a:solidFill>
+              <a:srgbClr val="274E13"/>
+            </a:solidFill>
+            <a:round/>
+          </a:ln>
+        </p:spPr>
+        <p:style>
+          <a:lnRef idx="0">
+            <a:scrgbClr r="0" g="0" b="0"/>
+          </a:lnRef>
+          <a:fillRef idx="0">
+            <a:scrgbClr r="0" g="0" b="0"/>
+          </a:fillRef>
+          <a:effectRef idx="0">
+            <a:scrgbClr r="0" g="0" b="0"/>
+          </a:effectRef>
+          <a:fontRef idx="minor"/>
+        </p:style>
+        <p:txBody>
+          <a:bodyPr lIns="90000" tIns="91440" rIns="90000" bIns="91440" anchor="t">
+            <a:noAutofit/>
+          </a:bodyPr>
+          <a:lstStyle/>
+          <a:p>
+            <a:pPr>
+              <a:lnSpc>
+                <a:spcPct val="100000"/>
+              </a:lnSpc>
+            </a:pPr>
+            <a:r>
+              <a:rPr lang="pt-PT" sz="1400" dirty="0">
+                <a:solidFill>
+                  <a:srgbClr val="000000"/>
+                </a:solidFill>
+                <a:latin typeface="Arial"/>
+              </a:rPr>
+              <a:t>US2</a:t>
+            </a:r>
+            <a:r>
+              <a:rPr lang="en-US" sz="1400" dirty="0">
+                <a:solidFill>
+                  <a:srgbClr val="000000"/>
+                </a:solidFill>
+                <a:latin typeface="Arial"/>
+              </a:rPr>
+              <a:t>: implementing</a:t>
+            </a:r>
+          </a:p>
+          <a:p>
+            <a:pPr>
+              <a:lnSpc>
+                <a:spcPct val="100000"/>
+              </a:lnSpc>
+            </a:pPr>
+            <a:endParaRPr lang="pt-PT" sz="1400" b="0" u="none" strike="noStrike" dirty="0">
+              <a:solidFill>
+                <a:srgbClr val="000000"/>
+              </a:solidFill>
+              <a:effectLst/>
+              <a:uFillTx/>
+              <a:latin typeface="Arial"/>
+            </a:endParaRPr>
+          </a:p>
+        </p:txBody>
+      </p:sp>
+    </p:spTree>
+    <p:extLst>
+      <p:ext uri="{BB962C8B-B14F-4D97-AF65-F5344CB8AC3E}">
+        <p14:creationId xmlns:p14="http://schemas.microsoft.com/office/powerpoint/2010/main" val="3933779894"/>
       </p:ext>
     </p:extLst>
   </p:cSld>

</xml_diff>

<commit_message>
end of sprint 4
</commit_message>
<xml_diff>
--- a/SE202526/Management/Scrum Board.pptx
+++ b/SE202526/Management/Scrum Board.pptx
@@ -23,6 +23,7 @@
     <p:sldId id="271" r:id="rId17"/>
     <p:sldId id="272" r:id="rId18"/>
     <p:sldId id="273" r:id="rId19"/>
+    <p:sldId id="274" r:id="rId20"/>
   </p:sldIdLst>
   <p:sldSz cx="21599525" cy="10799763"/>
   <p:notesSz cx="7559675" cy="10691813"/>
@@ -20788,6 +20789,2683 @@
     <p:extLst>
       <p:ext uri="{BB962C8B-B14F-4D97-AF65-F5344CB8AC3E}">
         <p14:creationId xmlns:p14="http://schemas.microsoft.com/office/powerpoint/2010/main" val="3933779894"/>
+      </p:ext>
+    </p:extLst>
+  </p:cSld>
+  <p:clrMapOvr>
+    <a:masterClrMapping/>
+  </p:clrMapOvr>
+</p:sld>
+</file>
+
+<file path=ppt/slides/slide19.xml><?xml version="1.0" encoding="utf-8"?>
+<p:sld xmlns:a="http://schemas.openxmlformats.org/drawingml/2006/main" xmlns:r="http://schemas.openxmlformats.org/officeDocument/2006/relationships" xmlns:p="http://schemas.openxmlformats.org/presentationml/2006/main">
+  <p:cSld>
+    <p:spTree>
+      <p:nvGrpSpPr>
+        <p:cNvPr id="1" name="">
+          <a:extLst>
+            <a:ext uri="{FF2B5EF4-FFF2-40B4-BE49-F238E27FC236}">
+              <a16:creationId xmlns:a16="http://schemas.microsoft.com/office/drawing/2014/main" id="{1D06A9F8-57ED-18F9-4BA0-35BDB3DD43B6}"/>
+            </a:ext>
+          </a:extLst>
+        </p:cNvPr>
+        <p:cNvGrpSpPr/>
+        <p:nvPr/>
+      </p:nvGrpSpPr>
+      <p:grpSpPr>
+        <a:xfrm>
+          <a:off x="0" y="0"/>
+          <a:ext cx="0" cy="0"/>
+          <a:chOff x="0" y="0"/>
+          <a:chExt cx="0" cy="0"/>
+        </a:xfrm>
+      </p:grpSpPr>
+      <p:cxnSp>
+        <p:nvCxnSpPr>
+          <p:cNvPr id="33" name="Google Shape;66;p15">
+            <a:extLst>
+              <a:ext uri="{FF2B5EF4-FFF2-40B4-BE49-F238E27FC236}">
+                <a16:creationId xmlns:a16="http://schemas.microsoft.com/office/drawing/2014/main" id="{D9C9D0FD-2945-1266-2E78-354B8FC3E878}"/>
+              </a:ext>
+            </a:extLst>
+          </p:cNvPr>
+          <p:cNvCxnSpPr/>
+          <p:nvPr/>
+        </p:nvCxnSpPr>
+        <p:spPr>
+          <a:xfrm>
+            <a:off x="5944680" y="-31320"/>
+            <a:ext cx="1080" cy="10857600"/>
+          </a:xfrm>
+          <a:prstGeom prst="straightConnector1">
+            <a:avLst/>
+          </a:prstGeom>
+          <a:ln w="38100">
+            <a:solidFill>
+              <a:srgbClr val="5B0F00"/>
+            </a:solidFill>
+            <a:round/>
+          </a:ln>
+        </p:spPr>
+      </p:cxnSp>
+      <p:sp>
+        <p:nvSpPr>
+          <p:cNvPr id="34" name="Google Shape;67;p15">
+            <a:extLst>
+              <a:ext uri="{FF2B5EF4-FFF2-40B4-BE49-F238E27FC236}">
+                <a16:creationId xmlns:a16="http://schemas.microsoft.com/office/drawing/2014/main" id="{3A8CD87B-6F20-BB6E-97BF-6055D88C363E}"/>
+              </a:ext>
+            </a:extLst>
+          </p:cNvPr>
+          <p:cNvSpPr/>
+          <p:nvPr/>
+        </p:nvSpPr>
+        <p:spPr>
+          <a:xfrm>
+            <a:off x="3197160" y="84240"/>
+            <a:ext cx="2409840" cy="479880"/>
+          </a:xfrm>
+          <a:prstGeom prst="roundRect">
+            <a:avLst>
+              <a:gd name="adj" fmla="val 16667"/>
+            </a:avLst>
+          </a:prstGeom>
+          <a:solidFill>
+            <a:srgbClr val="F9CB9C"/>
+          </a:solidFill>
+          <a:ln w="28575">
+            <a:solidFill>
+              <a:srgbClr val="B45F06"/>
+            </a:solidFill>
+            <a:round/>
+          </a:ln>
+        </p:spPr>
+        <p:style>
+          <a:lnRef idx="0">
+            <a:scrgbClr r="0" g="0" b="0"/>
+          </a:lnRef>
+          <a:fillRef idx="0">
+            <a:scrgbClr r="0" g="0" b="0"/>
+          </a:fillRef>
+          <a:effectRef idx="0">
+            <a:scrgbClr r="0" g="0" b="0"/>
+          </a:effectRef>
+          <a:fontRef idx="minor"/>
+        </p:style>
+        <p:txBody>
+          <a:bodyPr lIns="90000" tIns="91440" rIns="90000" bIns="91440" anchor="ctr">
+            <a:noAutofit/>
+          </a:bodyPr>
+          <a:lstStyle/>
+          <a:p>
+            <a:pPr algn="ctr">
+              <a:lnSpc>
+                <a:spcPct val="100000"/>
+              </a:lnSpc>
+              <a:tabLst>
+                <a:tab pos="0" algn="l"/>
+              </a:tabLst>
+            </a:pPr>
+            <a:r>
+              <a:rPr lang="en-GB" sz="1800" b="1" u="none" strike="noStrike">
+                <a:solidFill>
+                  <a:srgbClr val="000000"/>
+                </a:solidFill>
+                <a:effectLst/>
+                <a:uFillTx/>
+                <a:latin typeface="Consolas"/>
+                <a:ea typeface="Consolas"/>
+              </a:rPr>
+              <a:t>Student ID</a:t>
+            </a:r>
+            <a:endParaRPr lang="pt-PT" sz="1800" b="0" u="none" strike="noStrike">
+              <a:solidFill>
+                <a:srgbClr val="000000"/>
+              </a:solidFill>
+              <a:effectLst/>
+              <a:uFillTx/>
+              <a:latin typeface="Arial"/>
+            </a:endParaRPr>
+          </a:p>
+        </p:txBody>
+      </p:sp>
+      <p:sp>
+        <p:nvSpPr>
+          <p:cNvPr id="35" name="Google Shape;68;p15">
+            <a:extLst>
+              <a:ext uri="{FF2B5EF4-FFF2-40B4-BE49-F238E27FC236}">
+                <a16:creationId xmlns:a16="http://schemas.microsoft.com/office/drawing/2014/main" id="{C18FBEF4-00A5-6FA4-9F7E-7BC524C7A2A3}"/>
+              </a:ext>
+            </a:extLst>
+          </p:cNvPr>
+          <p:cNvSpPr/>
+          <p:nvPr/>
+        </p:nvSpPr>
+        <p:spPr>
+          <a:xfrm>
+            <a:off x="6281640" y="84240"/>
+            <a:ext cx="2409840" cy="479880"/>
+          </a:xfrm>
+          <a:prstGeom prst="roundRect">
+            <a:avLst>
+              <a:gd name="adj" fmla="val 16667"/>
+            </a:avLst>
+          </a:prstGeom>
+          <a:solidFill>
+            <a:srgbClr val="F9CB9C"/>
+          </a:solidFill>
+          <a:ln w="28575">
+            <a:solidFill>
+              <a:srgbClr val="B45F06"/>
+            </a:solidFill>
+            <a:round/>
+          </a:ln>
+        </p:spPr>
+        <p:style>
+          <a:lnRef idx="0">
+            <a:scrgbClr r="0" g="0" b="0"/>
+          </a:lnRef>
+          <a:fillRef idx="0">
+            <a:scrgbClr r="0" g="0" b="0"/>
+          </a:fillRef>
+          <a:effectRef idx="0">
+            <a:scrgbClr r="0" g="0" b="0"/>
+          </a:effectRef>
+          <a:fontRef idx="minor"/>
+        </p:style>
+        <p:txBody>
+          <a:bodyPr lIns="90000" tIns="91440" rIns="90000" bIns="91440" anchor="ctr">
+            <a:noAutofit/>
+          </a:bodyPr>
+          <a:lstStyle/>
+          <a:p>
+            <a:pPr algn="ctr">
+              <a:lnSpc>
+                <a:spcPct val="100000"/>
+              </a:lnSpc>
+              <a:tabLst>
+                <a:tab pos="0" algn="l"/>
+              </a:tabLst>
+            </a:pPr>
+            <a:r>
+              <a:rPr lang="en-GB" sz="1800" b="1" u="none" strike="noStrike">
+                <a:solidFill>
+                  <a:srgbClr val="000000"/>
+                </a:solidFill>
+                <a:effectLst/>
+                <a:uFillTx/>
+                <a:latin typeface="Consolas"/>
+                <a:ea typeface="Consolas"/>
+              </a:rPr>
+              <a:t>Story</a:t>
+            </a:r>
+            <a:endParaRPr lang="pt-PT" sz="1800" b="0" u="none" strike="noStrike">
+              <a:solidFill>
+                <a:srgbClr val="000000"/>
+              </a:solidFill>
+              <a:effectLst/>
+              <a:uFillTx/>
+              <a:latin typeface="Arial"/>
+            </a:endParaRPr>
+          </a:p>
+        </p:txBody>
+      </p:sp>
+      <p:sp>
+        <p:nvSpPr>
+          <p:cNvPr id="36" name="Google Shape;69;p15">
+            <a:extLst>
+              <a:ext uri="{FF2B5EF4-FFF2-40B4-BE49-F238E27FC236}">
+                <a16:creationId xmlns:a16="http://schemas.microsoft.com/office/drawing/2014/main" id="{BBEB81C7-9B48-61AB-A931-FCEF17015F5C}"/>
+              </a:ext>
+            </a:extLst>
+          </p:cNvPr>
+          <p:cNvSpPr/>
+          <p:nvPr/>
+        </p:nvSpPr>
+        <p:spPr>
+          <a:xfrm>
+            <a:off x="9366120" y="84240"/>
+            <a:ext cx="2409840" cy="479880"/>
+          </a:xfrm>
+          <a:prstGeom prst="roundRect">
+            <a:avLst>
+              <a:gd name="adj" fmla="val 16667"/>
+            </a:avLst>
+          </a:prstGeom>
+          <a:solidFill>
+            <a:srgbClr val="F9CB9C"/>
+          </a:solidFill>
+          <a:ln w="28575">
+            <a:solidFill>
+              <a:srgbClr val="B45F06"/>
+            </a:solidFill>
+            <a:round/>
+          </a:ln>
+        </p:spPr>
+        <p:style>
+          <a:lnRef idx="0">
+            <a:scrgbClr r="0" g="0" b="0"/>
+          </a:lnRef>
+          <a:fillRef idx="0">
+            <a:scrgbClr r="0" g="0" b="0"/>
+          </a:fillRef>
+          <a:effectRef idx="0">
+            <a:scrgbClr r="0" g="0" b="0"/>
+          </a:effectRef>
+          <a:fontRef idx="minor"/>
+        </p:style>
+        <p:txBody>
+          <a:bodyPr lIns="90000" tIns="91440" rIns="90000" bIns="91440" anchor="ctr">
+            <a:noAutofit/>
+          </a:bodyPr>
+          <a:lstStyle/>
+          <a:p>
+            <a:pPr algn="ctr">
+              <a:lnSpc>
+                <a:spcPct val="100000"/>
+              </a:lnSpc>
+              <a:tabLst>
+                <a:tab pos="0" algn="l"/>
+              </a:tabLst>
+            </a:pPr>
+            <a:r>
+              <a:rPr lang="en-GB" sz="1800" b="1" u="none" strike="noStrike">
+                <a:solidFill>
+                  <a:srgbClr val="000000"/>
+                </a:solidFill>
+                <a:effectLst/>
+                <a:uFillTx/>
+                <a:latin typeface="Consolas"/>
+                <a:ea typeface="Consolas"/>
+              </a:rPr>
+              <a:t>To Do</a:t>
+            </a:r>
+            <a:endParaRPr lang="pt-PT" sz="1800" b="0" u="none" strike="noStrike">
+              <a:solidFill>
+                <a:srgbClr val="000000"/>
+              </a:solidFill>
+              <a:effectLst/>
+              <a:uFillTx/>
+              <a:latin typeface="Arial"/>
+            </a:endParaRPr>
+          </a:p>
+        </p:txBody>
+      </p:sp>
+      <p:sp>
+        <p:nvSpPr>
+          <p:cNvPr id="37" name="Google Shape;70;p15">
+            <a:extLst>
+              <a:ext uri="{FF2B5EF4-FFF2-40B4-BE49-F238E27FC236}">
+                <a16:creationId xmlns:a16="http://schemas.microsoft.com/office/drawing/2014/main" id="{3531F911-4422-57C0-FA7A-BF6844E0A9FC}"/>
+              </a:ext>
+            </a:extLst>
+          </p:cNvPr>
+          <p:cNvSpPr/>
+          <p:nvPr/>
+        </p:nvSpPr>
+        <p:spPr>
+          <a:xfrm>
+            <a:off x="12395880" y="84240"/>
+            <a:ext cx="2409840" cy="479880"/>
+          </a:xfrm>
+          <a:prstGeom prst="roundRect">
+            <a:avLst>
+              <a:gd name="adj" fmla="val 16667"/>
+            </a:avLst>
+          </a:prstGeom>
+          <a:solidFill>
+            <a:srgbClr val="F9CB9C"/>
+          </a:solidFill>
+          <a:ln w="28575">
+            <a:solidFill>
+              <a:srgbClr val="B45F06"/>
+            </a:solidFill>
+            <a:round/>
+          </a:ln>
+        </p:spPr>
+        <p:style>
+          <a:lnRef idx="0">
+            <a:scrgbClr r="0" g="0" b="0"/>
+          </a:lnRef>
+          <a:fillRef idx="0">
+            <a:scrgbClr r="0" g="0" b="0"/>
+          </a:fillRef>
+          <a:effectRef idx="0">
+            <a:scrgbClr r="0" g="0" b="0"/>
+          </a:effectRef>
+          <a:fontRef idx="minor"/>
+        </p:style>
+        <p:txBody>
+          <a:bodyPr lIns="90000" tIns="91440" rIns="90000" bIns="91440" anchor="ctr">
+            <a:noAutofit/>
+          </a:bodyPr>
+          <a:lstStyle/>
+          <a:p>
+            <a:pPr algn="ctr">
+              <a:lnSpc>
+                <a:spcPct val="100000"/>
+              </a:lnSpc>
+              <a:tabLst>
+                <a:tab pos="0" algn="l"/>
+              </a:tabLst>
+            </a:pPr>
+            <a:r>
+              <a:rPr lang="en-GB" sz="1800" b="1" u="none" strike="noStrike">
+                <a:solidFill>
+                  <a:srgbClr val="000000"/>
+                </a:solidFill>
+                <a:effectLst/>
+                <a:uFillTx/>
+                <a:latin typeface="Consolas"/>
+                <a:ea typeface="Consolas"/>
+              </a:rPr>
+              <a:t>Doing</a:t>
+            </a:r>
+            <a:endParaRPr lang="pt-PT" sz="1800" b="0" u="none" strike="noStrike">
+              <a:solidFill>
+                <a:srgbClr val="000000"/>
+              </a:solidFill>
+              <a:effectLst/>
+              <a:uFillTx/>
+              <a:latin typeface="Arial"/>
+            </a:endParaRPr>
+          </a:p>
+        </p:txBody>
+      </p:sp>
+      <p:sp>
+        <p:nvSpPr>
+          <p:cNvPr id="38" name="Google Shape;71;p15">
+            <a:extLst>
+              <a:ext uri="{FF2B5EF4-FFF2-40B4-BE49-F238E27FC236}">
+                <a16:creationId xmlns:a16="http://schemas.microsoft.com/office/drawing/2014/main" id="{27B37BF0-7636-D106-DEC3-BE5380F3B6F1}"/>
+              </a:ext>
+            </a:extLst>
+          </p:cNvPr>
+          <p:cNvSpPr/>
+          <p:nvPr/>
+        </p:nvSpPr>
+        <p:spPr>
+          <a:xfrm>
+            <a:off x="15532560" y="84240"/>
+            <a:ext cx="2409840" cy="479880"/>
+          </a:xfrm>
+          <a:prstGeom prst="roundRect">
+            <a:avLst>
+              <a:gd name="adj" fmla="val 16667"/>
+            </a:avLst>
+          </a:prstGeom>
+          <a:solidFill>
+            <a:srgbClr val="F9CB9C"/>
+          </a:solidFill>
+          <a:ln w="28575">
+            <a:solidFill>
+              <a:srgbClr val="B45F06"/>
+            </a:solidFill>
+            <a:round/>
+          </a:ln>
+        </p:spPr>
+        <p:style>
+          <a:lnRef idx="0">
+            <a:scrgbClr r="0" g="0" b="0"/>
+          </a:lnRef>
+          <a:fillRef idx="0">
+            <a:scrgbClr r="0" g="0" b="0"/>
+          </a:fillRef>
+          <a:effectRef idx="0">
+            <a:scrgbClr r="0" g="0" b="0"/>
+          </a:effectRef>
+          <a:fontRef idx="minor"/>
+        </p:style>
+        <p:txBody>
+          <a:bodyPr lIns="90000" tIns="91440" rIns="90000" bIns="91440" anchor="ctr">
+            <a:noAutofit/>
+          </a:bodyPr>
+          <a:lstStyle/>
+          <a:p>
+            <a:pPr algn="ctr">
+              <a:lnSpc>
+                <a:spcPct val="100000"/>
+              </a:lnSpc>
+              <a:tabLst>
+                <a:tab pos="0" algn="l"/>
+              </a:tabLst>
+            </a:pPr>
+            <a:r>
+              <a:rPr lang="en-GB" sz="1800" b="1" u="none" strike="noStrike">
+                <a:solidFill>
+                  <a:srgbClr val="000000"/>
+                </a:solidFill>
+                <a:effectLst/>
+                <a:uFillTx/>
+                <a:latin typeface="Consolas"/>
+                <a:ea typeface="Consolas"/>
+              </a:rPr>
+              <a:t>Review</a:t>
+            </a:r>
+            <a:endParaRPr lang="pt-PT" sz="1800" b="0" u="none" strike="noStrike">
+              <a:solidFill>
+                <a:srgbClr val="000000"/>
+              </a:solidFill>
+              <a:effectLst/>
+              <a:uFillTx/>
+              <a:latin typeface="Arial"/>
+            </a:endParaRPr>
+          </a:p>
+        </p:txBody>
+      </p:sp>
+      <p:sp>
+        <p:nvSpPr>
+          <p:cNvPr id="39" name="Google Shape;72;p15">
+            <a:extLst>
+              <a:ext uri="{FF2B5EF4-FFF2-40B4-BE49-F238E27FC236}">
+                <a16:creationId xmlns:a16="http://schemas.microsoft.com/office/drawing/2014/main" id="{21283855-2F5B-0DA4-093F-1CEE1AE77C30}"/>
+              </a:ext>
+            </a:extLst>
+          </p:cNvPr>
+          <p:cNvSpPr/>
+          <p:nvPr/>
+        </p:nvSpPr>
+        <p:spPr>
+          <a:xfrm>
+            <a:off x="18668880" y="84240"/>
+            <a:ext cx="2409840" cy="479880"/>
+          </a:xfrm>
+          <a:prstGeom prst="roundRect">
+            <a:avLst>
+              <a:gd name="adj" fmla="val 16667"/>
+            </a:avLst>
+          </a:prstGeom>
+          <a:solidFill>
+            <a:srgbClr val="F9CB9C"/>
+          </a:solidFill>
+          <a:ln w="28575">
+            <a:solidFill>
+              <a:srgbClr val="B45F06"/>
+            </a:solidFill>
+            <a:round/>
+          </a:ln>
+        </p:spPr>
+        <p:style>
+          <a:lnRef idx="0">
+            <a:scrgbClr r="0" g="0" b="0"/>
+          </a:lnRef>
+          <a:fillRef idx="0">
+            <a:scrgbClr r="0" g="0" b="0"/>
+          </a:fillRef>
+          <a:effectRef idx="0">
+            <a:scrgbClr r="0" g="0" b="0"/>
+          </a:effectRef>
+          <a:fontRef idx="minor"/>
+        </p:style>
+        <p:txBody>
+          <a:bodyPr lIns="90000" tIns="91440" rIns="90000" bIns="91440" anchor="ctr">
+            <a:noAutofit/>
+          </a:bodyPr>
+          <a:lstStyle/>
+          <a:p>
+            <a:pPr algn="ctr">
+              <a:lnSpc>
+                <a:spcPct val="100000"/>
+              </a:lnSpc>
+              <a:tabLst>
+                <a:tab pos="0" algn="l"/>
+              </a:tabLst>
+            </a:pPr>
+            <a:r>
+              <a:rPr lang="en-GB" sz="1800" b="1" u="none" strike="noStrike">
+                <a:solidFill>
+                  <a:srgbClr val="000000"/>
+                </a:solidFill>
+                <a:effectLst/>
+                <a:uFillTx/>
+                <a:latin typeface="Consolas"/>
+                <a:ea typeface="Consolas"/>
+              </a:rPr>
+              <a:t>Done</a:t>
+            </a:r>
+            <a:endParaRPr lang="pt-PT" sz="1800" b="0" u="none" strike="noStrike">
+              <a:solidFill>
+                <a:srgbClr val="000000"/>
+              </a:solidFill>
+              <a:effectLst/>
+              <a:uFillTx/>
+              <a:latin typeface="Arial"/>
+            </a:endParaRPr>
+          </a:p>
+        </p:txBody>
+      </p:sp>
+      <p:sp>
+        <p:nvSpPr>
+          <p:cNvPr id="40" name="Google Shape;73;p15">
+            <a:extLst>
+              <a:ext uri="{FF2B5EF4-FFF2-40B4-BE49-F238E27FC236}">
+                <a16:creationId xmlns:a16="http://schemas.microsoft.com/office/drawing/2014/main" id="{EB7F3498-906F-68EA-7972-5CA374352A44}"/>
+              </a:ext>
+            </a:extLst>
+          </p:cNvPr>
+          <p:cNvSpPr/>
+          <p:nvPr/>
+        </p:nvSpPr>
+        <p:spPr>
+          <a:xfrm>
+            <a:off x="167400" y="84240"/>
+            <a:ext cx="2409840" cy="479880"/>
+          </a:xfrm>
+          <a:prstGeom prst="roundRect">
+            <a:avLst>
+              <a:gd name="adj" fmla="val 16667"/>
+            </a:avLst>
+          </a:prstGeom>
+          <a:solidFill>
+            <a:srgbClr val="F9CB9C"/>
+          </a:solidFill>
+          <a:ln w="28575">
+            <a:solidFill>
+              <a:srgbClr val="B45F06"/>
+            </a:solidFill>
+            <a:round/>
+          </a:ln>
+        </p:spPr>
+        <p:style>
+          <a:lnRef idx="0">
+            <a:scrgbClr r="0" g="0" b="0"/>
+          </a:lnRef>
+          <a:fillRef idx="0">
+            <a:scrgbClr r="0" g="0" b="0"/>
+          </a:fillRef>
+          <a:effectRef idx="0">
+            <a:scrgbClr r="0" g="0" b="0"/>
+          </a:effectRef>
+          <a:fontRef idx="minor"/>
+        </p:style>
+        <p:txBody>
+          <a:bodyPr lIns="90000" tIns="91440" rIns="90000" bIns="91440" anchor="ctr">
+            <a:noAutofit/>
+          </a:bodyPr>
+          <a:lstStyle/>
+          <a:p>
+            <a:pPr algn="ctr">
+              <a:lnSpc>
+                <a:spcPct val="100000"/>
+              </a:lnSpc>
+              <a:tabLst>
+                <a:tab pos="0" algn="l"/>
+              </a:tabLst>
+            </a:pPr>
+            <a:r>
+              <a:rPr lang="en-GB" sz="1800" b="1" u="none" strike="noStrike">
+                <a:solidFill>
+                  <a:srgbClr val="000000"/>
+                </a:solidFill>
+                <a:effectLst/>
+                <a:uFillTx/>
+                <a:latin typeface="Consolas"/>
+                <a:ea typeface="Consolas"/>
+              </a:rPr>
+              <a:t>Backlog</a:t>
+            </a:r>
+            <a:endParaRPr lang="pt-PT" sz="1800" b="0" u="none" strike="noStrike">
+              <a:solidFill>
+                <a:srgbClr val="000000"/>
+              </a:solidFill>
+              <a:effectLst/>
+              <a:uFillTx/>
+              <a:latin typeface="Arial"/>
+            </a:endParaRPr>
+          </a:p>
+        </p:txBody>
+      </p:sp>
+      <p:sp>
+        <p:nvSpPr>
+          <p:cNvPr id="41" name="Google Shape;74;p15">
+            <a:extLst>
+              <a:ext uri="{FF2B5EF4-FFF2-40B4-BE49-F238E27FC236}">
+                <a16:creationId xmlns:a16="http://schemas.microsoft.com/office/drawing/2014/main" id="{A528DA52-4C98-8EAE-82F2-CF18D84D42EF}"/>
+              </a:ext>
+            </a:extLst>
+          </p:cNvPr>
+          <p:cNvSpPr/>
+          <p:nvPr/>
+        </p:nvSpPr>
+        <p:spPr>
+          <a:xfrm>
+            <a:off x="3197160" y="1385640"/>
+            <a:ext cx="2409840" cy="479880"/>
+          </a:xfrm>
+          <a:prstGeom prst="roundRect">
+            <a:avLst>
+              <a:gd name="adj" fmla="val 16667"/>
+            </a:avLst>
+          </a:prstGeom>
+          <a:solidFill>
+            <a:srgbClr val="E6B8AF"/>
+          </a:solidFill>
+          <a:ln w="28575">
+            <a:solidFill>
+              <a:srgbClr val="5B0F00"/>
+            </a:solidFill>
+            <a:round/>
+          </a:ln>
+        </p:spPr>
+        <p:style>
+          <a:lnRef idx="0">
+            <a:scrgbClr r="0" g="0" b="0"/>
+          </a:lnRef>
+          <a:fillRef idx="0">
+            <a:scrgbClr r="0" g="0" b="0"/>
+          </a:fillRef>
+          <a:effectRef idx="0">
+            <a:scrgbClr r="0" g="0" b="0"/>
+          </a:effectRef>
+          <a:fontRef idx="minor"/>
+        </p:style>
+        <p:txBody>
+          <a:bodyPr lIns="90000" tIns="91440" rIns="90000" bIns="91440" anchor="ctr">
+            <a:noAutofit/>
+          </a:bodyPr>
+          <a:lstStyle/>
+          <a:p>
+            <a:pPr algn="ctr">
+              <a:lnSpc>
+                <a:spcPct val="100000"/>
+              </a:lnSpc>
+              <a:tabLst>
+                <a:tab pos="0" algn="l"/>
+              </a:tabLst>
+            </a:pPr>
+            <a:r>
+              <a:rPr lang="en-GB" sz="1800" b="1" u="none" strike="noStrike">
+                <a:solidFill>
+                  <a:srgbClr val="000000"/>
+                </a:solidFill>
+                <a:effectLst/>
+                <a:uFillTx/>
+                <a:latin typeface="Consolas"/>
+                <a:ea typeface="Consolas"/>
+              </a:rPr>
+              <a:t>66565</a:t>
+            </a:r>
+            <a:endParaRPr lang="pt-PT" sz="1800" b="0" u="none" strike="noStrike">
+              <a:solidFill>
+                <a:srgbClr val="000000"/>
+              </a:solidFill>
+              <a:effectLst/>
+              <a:uFillTx/>
+              <a:latin typeface="Arial"/>
+            </a:endParaRPr>
+          </a:p>
+        </p:txBody>
+      </p:sp>
+      <p:sp>
+        <p:nvSpPr>
+          <p:cNvPr id="42" name="Google Shape;75;p15">
+            <a:extLst>
+              <a:ext uri="{FF2B5EF4-FFF2-40B4-BE49-F238E27FC236}">
+                <a16:creationId xmlns:a16="http://schemas.microsoft.com/office/drawing/2014/main" id="{F0EF2A9A-F424-F0EE-CE46-51431AEA799F}"/>
+              </a:ext>
+            </a:extLst>
+          </p:cNvPr>
+          <p:cNvSpPr/>
+          <p:nvPr/>
+        </p:nvSpPr>
+        <p:spPr>
+          <a:xfrm>
+            <a:off x="3197160" y="6126258"/>
+            <a:ext cx="2409840" cy="479880"/>
+          </a:xfrm>
+          <a:prstGeom prst="roundRect">
+            <a:avLst>
+              <a:gd name="adj" fmla="val 16667"/>
+            </a:avLst>
+          </a:prstGeom>
+          <a:solidFill>
+            <a:srgbClr val="E6B8AF"/>
+          </a:solidFill>
+          <a:ln w="28575">
+            <a:solidFill>
+              <a:srgbClr val="5B0F00"/>
+            </a:solidFill>
+            <a:round/>
+          </a:ln>
+        </p:spPr>
+        <p:style>
+          <a:lnRef idx="0">
+            <a:scrgbClr r="0" g="0" b="0"/>
+          </a:lnRef>
+          <a:fillRef idx="0">
+            <a:scrgbClr r="0" g="0" b="0"/>
+          </a:fillRef>
+          <a:effectRef idx="0">
+            <a:scrgbClr r="0" g="0" b="0"/>
+          </a:effectRef>
+          <a:fontRef idx="minor"/>
+        </p:style>
+        <p:txBody>
+          <a:bodyPr lIns="90000" tIns="91440" rIns="90000" bIns="91440" anchor="ctr">
+            <a:noAutofit/>
+          </a:bodyPr>
+          <a:lstStyle/>
+          <a:p>
+            <a:pPr algn="ctr">
+              <a:lnSpc>
+                <a:spcPct val="100000"/>
+              </a:lnSpc>
+              <a:tabLst>
+                <a:tab pos="0" algn="l"/>
+              </a:tabLst>
+            </a:pPr>
+            <a:r>
+              <a:rPr lang="en-GB" sz="1800" b="1" u="none" strike="noStrike">
+                <a:solidFill>
+                  <a:srgbClr val="000000"/>
+                </a:solidFill>
+                <a:effectLst/>
+                <a:uFillTx/>
+                <a:latin typeface="Consolas"/>
+                <a:ea typeface="Consolas"/>
+              </a:rPr>
+              <a:t>67196</a:t>
+            </a:r>
+            <a:endParaRPr lang="pt-PT" sz="1800" b="0" u="none" strike="noStrike">
+              <a:solidFill>
+                <a:srgbClr val="000000"/>
+              </a:solidFill>
+              <a:effectLst/>
+              <a:uFillTx/>
+              <a:latin typeface="Arial"/>
+            </a:endParaRPr>
+          </a:p>
+        </p:txBody>
+      </p:sp>
+      <p:sp>
+        <p:nvSpPr>
+          <p:cNvPr id="43" name="Google Shape;76;p15">
+            <a:extLst>
+              <a:ext uri="{FF2B5EF4-FFF2-40B4-BE49-F238E27FC236}">
+                <a16:creationId xmlns:a16="http://schemas.microsoft.com/office/drawing/2014/main" id="{BD1B1485-975B-31DE-1178-9EB35A67F5EE}"/>
+              </a:ext>
+            </a:extLst>
+          </p:cNvPr>
+          <p:cNvSpPr/>
+          <p:nvPr/>
+        </p:nvSpPr>
+        <p:spPr>
+          <a:xfrm>
+            <a:off x="3197160" y="2990658"/>
+            <a:ext cx="2409840" cy="479880"/>
+          </a:xfrm>
+          <a:prstGeom prst="roundRect">
+            <a:avLst>
+              <a:gd name="adj" fmla="val 16667"/>
+            </a:avLst>
+          </a:prstGeom>
+          <a:solidFill>
+            <a:srgbClr val="E6B8AF"/>
+          </a:solidFill>
+          <a:ln w="28575">
+            <a:solidFill>
+              <a:srgbClr val="5B0F00"/>
+            </a:solidFill>
+            <a:round/>
+          </a:ln>
+        </p:spPr>
+        <p:style>
+          <a:lnRef idx="0">
+            <a:scrgbClr r="0" g="0" b="0"/>
+          </a:lnRef>
+          <a:fillRef idx="0">
+            <a:scrgbClr r="0" g="0" b="0"/>
+          </a:fillRef>
+          <a:effectRef idx="0">
+            <a:scrgbClr r="0" g="0" b="0"/>
+          </a:effectRef>
+          <a:fontRef idx="minor"/>
+        </p:style>
+        <p:txBody>
+          <a:bodyPr lIns="90000" tIns="91440" rIns="90000" bIns="91440" anchor="ctr">
+            <a:noAutofit/>
+          </a:bodyPr>
+          <a:lstStyle/>
+          <a:p>
+            <a:pPr algn="ctr">
+              <a:lnSpc>
+                <a:spcPct val="100000"/>
+              </a:lnSpc>
+              <a:tabLst>
+                <a:tab pos="0" algn="l"/>
+              </a:tabLst>
+            </a:pPr>
+            <a:r>
+              <a:rPr lang="en-GB" sz="1800" b="1" u="none" strike="noStrike">
+                <a:solidFill>
+                  <a:srgbClr val="000000"/>
+                </a:solidFill>
+                <a:effectLst/>
+                <a:uFillTx/>
+                <a:latin typeface="Consolas"/>
+                <a:ea typeface="Consolas"/>
+              </a:rPr>
+              <a:t>67215</a:t>
+            </a:r>
+            <a:endParaRPr lang="pt-PT" sz="1800" b="0" u="none" strike="noStrike">
+              <a:solidFill>
+                <a:srgbClr val="000000"/>
+              </a:solidFill>
+              <a:effectLst/>
+              <a:uFillTx/>
+              <a:latin typeface="Arial"/>
+            </a:endParaRPr>
+          </a:p>
+        </p:txBody>
+      </p:sp>
+      <p:sp>
+        <p:nvSpPr>
+          <p:cNvPr id="44" name="Google Shape;77;p15">
+            <a:extLst>
+              <a:ext uri="{FF2B5EF4-FFF2-40B4-BE49-F238E27FC236}">
+                <a16:creationId xmlns:a16="http://schemas.microsoft.com/office/drawing/2014/main" id="{A53BD2EB-BE0B-C6D0-52CE-8FBF92F85D7D}"/>
+              </a:ext>
+            </a:extLst>
+          </p:cNvPr>
+          <p:cNvSpPr/>
+          <p:nvPr/>
+        </p:nvSpPr>
+        <p:spPr>
+          <a:xfrm>
+            <a:off x="3212280" y="4550178"/>
+            <a:ext cx="2409840" cy="479880"/>
+          </a:xfrm>
+          <a:prstGeom prst="roundRect">
+            <a:avLst>
+              <a:gd name="adj" fmla="val 16667"/>
+            </a:avLst>
+          </a:prstGeom>
+          <a:solidFill>
+            <a:srgbClr val="E6B8AF"/>
+          </a:solidFill>
+          <a:ln w="28575">
+            <a:solidFill>
+              <a:srgbClr val="5B0F00"/>
+            </a:solidFill>
+            <a:round/>
+          </a:ln>
+        </p:spPr>
+        <p:style>
+          <a:lnRef idx="0">
+            <a:scrgbClr r="0" g="0" b="0"/>
+          </a:lnRef>
+          <a:fillRef idx="0">
+            <a:scrgbClr r="0" g="0" b="0"/>
+          </a:fillRef>
+          <a:effectRef idx="0">
+            <a:scrgbClr r="0" g="0" b="0"/>
+          </a:effectRef>
+          <a:fontRef idx="minor"/>
+        </p:style>
+        <p:txBody>
+          <a:bodyPr lIns="90000" tIns="91440" rIns="90000" bIns="91440" anchor="ctr">
+            <a:noAutofit/>
+          </a:bodyPr>
+          <a:lstStyle/>
+          <a:p>
+            <a:pPr algn="ctr">
+              <a:lnSpc>
+                <a:spcPct val="100000"/>
+              </a:lnSpc>
+              <a:tabLst>
+                <a:tab pos="0" algn="l"/>
+              </a:tabLst>
+            </a:pPr>
+            <a:r>
+              <a:rPr lang="pt-PT" sz="1800" b="1" u="none" strike="noStrike">
+                <a:solidFill>
+                  <a:srgbClr val="000000"/>
+                </a:solidFill>
+                <a:effectLst/>
+                <a:uFillTx/>
+                <a:latin typeface="Consolas"/>
+                <a:ea typeface="Consolas"/>
+              </a:rPr>
+              <a:t>68509</a:t>
+            </a:r>
+            <a:endParaRPr lang="pt-PT" sz="1800" b="0" u="none" strike="noStrike">
+              <a:solidFill>
+                <a:srgbClr val="000000"/>
+              </a:solidFill>
+              <a:effectLst/>
+              <a:uFillTx/>
+              <a:latin typeface="Arial"/>
+            </a:endParaRPr>
+          </a:p>
+        </p:txBody>
+      </p:sp>
+      <p:sp>
+        <p:nvSpPr>
+          <p:cNvPr id="45" name="Google Shape;78;p15">
+            <a:extLst>
+              <a:ext uri="{FF2B5EF4-FFF2-40B4-BE49-F238E27FC236}">
+                <a16:creationId xmlns:a16="http://schemas.microsoft.com/office/drawing/2014/main" id="{A082888F-8675-6A1E-207C-468D08FF21DD}"/>
+              </a:ext>
+            </a:extLst>
+          </p:cNvPr>
+          <p:cNvSpPr/>
+          <p:nvPr/>
+        </p:nvSpPr>
+        <p:spPr>
+          <a:xfrm>
+            <a:off x="3197160" y="7685778"/>
+            <a:ext cx="2409840" cy="479880"/>
+          </a:xfrm>
+          <a:prstGeom prst="roundRect">
+            <a:avLst>
+              <a:gd name="adj" fmla="val 16667"/>
+            </a:avLst>
+          </a:prstGeom>
+          <a:solidFill>
+            <a:srgbClr val="E6B8AF"/>
+          </a:solidFill>
+          <a:ln w="28575">
+            <a:solidFill>
+              <a:srgbClr val="5B0F00"/>
+            </a:solidFill>
+            <a:round/>
+          </a:ln>
+        </p:spPr>
+        <p:style>
+          <a:lnRef idx="0">
+            <a:scrgbClr r="0" g="0" b="0"/>
+          </a:lnRef>
+          <a:fillRef idx="0">
+            <a:scrgbClr r="0" g="0" b="0"/>
+          </a:fillRef>
+          <a:effectRef idx="0">
+            <a:scrgbClr r="0" g="0" b="0"/>
+          </a:effectRef>
+          <a:fontRef idx="minor"/>
+        </p:style>
+        <p:txBody>
+          <a:bodyPr lIns="90000" tIns="91440" rIns="90000" bIns="91440" anchor="ctr">
+            <a:noAutofit/>
+          </a:bodyPr>
+          <a:lstStyle/>
+          <a:p>
+            <a:pPr algn="ctr">
+              <a:lnSpc>
+                <a:spcPct val="100000"/>
+              </a:lnSpc>
+              <a:tabLst>
+                <a:tab pos="0" algn="l"/>
+              </a:tabLst>
+            </a:pPr>
+            <a:r>
+              <a:rPr lang="en-GB" sz="1800" b="1" u="none" strike="noStrike">
+                <a:solidFill>
+                  <a:srgbClr val="000000"/>
+                </a:solidFill>
+                <a:effectLst/>
+                <a:uFillTx/>
+                <a:latin typeface="Consolas"/>
+                <a:ea typeface="Consolas"/>
+              </a:rPr>
+              <a:t>68663</a:t>
+            </a:r>
+            <a:endParaRPr lang="pt-PT" sz="1800" b="0" u="none" strike="noStrike">
+              <a:solidFill>
+                <a:srgbClr val="000000"/>
+              </a:solidFill>
+              <a:effectLst/>
+              <a:uFillTx/>
+              <a:latin typeface="Arial"/>
+            </a:endParaRPr>
+          </a:p>
+        </p:txBody>
+      </p:sp>
+      <p:sp>
+        <p:nvSpPr>
+          <p:cNvPr id="46" name="Google Shape;79;p15">
+            <a:extLst>
+              <a:ext uri="{FF2B5EF4-FFF2-40B4-BE49-F238E27FC236}">
+                <a16:creationId xmlns:a16="http://schemas.microsoft.com/office/drawing/2014/main" id="{0D982CF8-936F-28FD-D91E-74F21F51AE55}"/>
+              </a:ext>
+            </a:extLst>
+          </p:cNvPr>
+          <p:cNvSpPr/>
+          <p:nvPr/>
+        </p:nvSpPr>
+        <p:spPr>
+          <a:xfrm>
+            <a:off x="3197160" y="9264960"/>
+            <a:ext cx="2409840" cy="479880"/>
+          </a:xfrm>
+          <a:prstGeom prst="roundRect">
+            <a:avLst>
+              <a:gd name="adj" fmla="val 16667"/>
+            </a:avLst>
+          </a:prstGeom>
+          <a:solidFill>
+            <a:srgbClr val="E6B8AF"/>
+          </a:solidFill>
+          <a:ln w="28575">
+            <a:solidFill>
+              <a:srgbClr val="5B0F00"/>
+            </a:solidFill>
+            <a:round/>
+          </a:ln>
+        </p:spPr>
+        <p:style>
+          <a:lnRef idx="0">
+            <a:scrgbClr r="0" g="0" b="0"/>
+          </a:lnRef>
+          <a:fillRef idx="0">
+            <a:scrgbClr r="0" g="0" b="0"/>
+          </a:fillRef>
+          <a:effectRef idx="0">
+            <a:scrgbClr r="0" g="0" b="0"/>
+          </a:effectRef>
+          <a:fontRef idx="minor"/>
+        </p:style>
+        <p:txBody>
+          <a:bodyPr lIns="90000" tIns="91440" rIns="90000" bIns="91440" anchor="ctr">
+            <a:noAutofit/>
+          </a:bodyPr>
+          <a:lstStyle/>
+          <a:p>
+            <a:pPr algn="ctr">
+              <a:lnSpc>
+                <a:spcPct val="100000"/>
+              </a:lnSpc>
+              <a:tabLst>
+                <a:tab pos="0" algn="l"/>
+              </a:tabLst>
+            </a:pPr>
+            <a:r>
+              <a:rPr lang="en-GB" sz="1800" b="1" u="none" strike="noStrike">
+                <a:solidFill>
+                  <a:srgbClr val="000000"/>
+                </a:solidFill>
+                <a:effectLst/>
+                <a:uFillTx/>
+                <a:latin typeface="Consolas"/>
+                <a:ea typeface="Consolas"/>
+              </a:rPr>
+              <a:t>70116</a:t>
+            </a:r>
+            <a:endParaRPr lang="pt-PT" sz="1800" b="0" u="none" strike="noStrike">
+              <a:solidFill>
+                <a:srgbClr val="000000"/>
+              </a:solidFill>
+              <a:effectLst/>
+              <a:uFillTx/>
+              <a:latin typeface="Arial"/>
+            </a:endParaRPr>
+          </a:p>
+        </p:txBody>
+      </p:sp>
+      <p:cxnSp>
+        <p:nvCxnSpPr>
+          <p:cNvPr id="47" name="Google Shape;80;p15">
+            <a:extLst>
+              <a:ext uri="{FF2B5EF4-FFF2-40B4-BE49-F238E27FC236}">
+                <a16:creationId xmlns:a16="http://schemas.microsoft.com/office/drawing/2014/main" id="{B115D71A-6A8E-ECB2-17C0-0F0891E9B81E}"/>
+              </a:ext>
+            </a:extLst>
+          </p:cNvPr>
+          <p:cNvCxnSpPr/>
+          <p:nvPr/>
+        </p:nvCxnSpPr>
+        <p:spPr>
+          <a:xfrm>
+            <a:off x="5607720" y="1625760"/>
+            <a:ext cx="16043400" cy="1080"/>
+          </a:xfrm>
+          <a:prstGeom prst="straightConnector1">
+            <a:avLst/>
+          </a:prstGeom>
+          <a:ln w="28575">
+            <a:solidFill>
+              <a:srgbClr val="999999"/>
+            </a:solidFill>
+            <a:prstDash val="dash"/>
+            <a:round/>
+          </a:ln>
+        </p:spPr>
+      </p:cxnSp>
+      <p:cxnSp>
+        <p:nvCxnSpPr>
+          <p:cNvPr id="48" name="Google Shape;81;p15">
+            <a:extLst>
+              <a:ext uri="{FF2B5EF4-FFF2-40B4-BE49-F238E27FC236}">
+                <a16:creationId xmlns:a16="http://schemas.microsoft.com/office/drawing/2014/main" id="{4C536CBD-7F24-1443-9AA3-CCA3491B06E1}"/>
+              </a:ext>
+            </a:extLst>
+          </p:cNvPr>
+          <p:cNvCxnSpPr/>
+          <p:nvPr/>
+        </p:nvCxnSpPr>
+        <p:spPr>
+          <a:xfrm>
+            <a:off x="5607720" y="3201840"/>
+            <a:ext cx="16043400" cy="1080"/>
+          </a:xfrm>
+          <a:prstGeom prst="straightConnector1">
+            <a:avLst/>
+          </a:prstGeom>
+          <a:ln w="28575">
+            <a:solidFill>
+              <a:srgbClr val="999999"/>
+            </a:solidFill>
+            <a:prstDash val="dash"/>
+            <a:round/>
+          </a:ln>
+        </p:spPr>
+      </p:cxnSp>
+      <p:cxnSp>
+        <p:nvCxnSpPr>
+          <p:cNvPr id="49" name="Google Shape;82;p15">
+            <a:extLst>
+              <a:ext uri="{FF2B5EF4-FFF2-40B4-BE49-F238E27FC236}">
+                <a16:creationId xmlns:a16="http://schemas.microsoft.com/office/drawing/2014/main" id="{A6D77680-4F35-5CB5-D00B-1E683B869FA6}"/>
+              </a:ext>
+            </a:extLst>
+          </p:cNvPr>
+          <p:cNvCxnSpPr/>
+          <p:nvPr/>
+        </p:nvCxnSpPr>
+        <p:spPr>
+          <a:xfrm>
+            <a:off x="5607720" y="4777560"/>
+            <a:ext cx="16043400" cy="1080"/>
+          </a:xfrm>
+          <a:prstGeom prst="straightConnector1">
+            <a:avLst/>
+          </a:prstGeom>
+          <a:ln w="28575">
+            <a:solidFill>
+              <a:srgbClr val="999999"/>
+            </a:solidFill>
+            <a:prstDash val="dash"/>
+            <a:round/>
+          </a:ln>
+        </p:spPr>
+      </p:cxnSp>
+      <p:cxnSp>
+        <p:nvCxnSpPr>
+          <p:cNvPr id="50" name="Google Shape;83;p15">
+            <a:extLst>
+              <a:ext uri="{FF2B5EF4-FFF2-40B4-BE49-F238E27FC236}">
+                <a16:creationId xmlns:a16="http://schemas.microsoft.com/office/drawing/2014/main" id="{E0719DA2-73FF-7FA7-F580-ABFFD5A39C29}"/>
+              </a:ext>
+            </a:extLst>
+          </p:cNvPr>
+          <p:cNvCxnSpPr/>
+          <p:nvPr/>
+        </p:nvCxnSpPr>
+        <p:spPr>
+          <a:xfrm>
+            <a:off x="5607720" y="6353640"/>
+            <a:ext cx="16043400" cy="1080"/>
+          </a:xfrm>
+          <a:prstGeom prst="straightConnector1">
+            <a:avLst/>
+          </a:prstGeom>
+          <a:ln w="28575">
+            <a:solidFill>
+              <a:srgbClr val="999999"/>
+            </a:solidFill>
+            <a:prstDash val="dash"/>
+            <a:round/>
+          </a:ln>
+        </p:spPr>
+      </p:cxnSp>
+      <p:cxnSp>
+        <p:nvCxnSpPr>
+          <p:cNvPr id="51" name="Google Shape;84;p15">
+            <a:extLst>
+              <a:ext uri="{FF2B5EF4-FFF2-40B4-BE49-F238E27FC236}">
+                <a16:creationId xmlns:a16="http://schemas.microsoft.com/office/drawing/2014/main" id="{2728881C-58CB-BD91-3CD7-535BA478B2B8}"/>
+              </a:ext>
+            </a:extLst>
+          </p:cNvPr>
+          <p:cNvCxnSpPr/>
+          <p:nvPr/>
+        </p:nvCxnSpPr>
+        <p:spPr>
+          <a:xfrm>
+            <a:off x="5607720" y="7929360"/>
+            <a:ext cx="16043400" cy="1080"/>
+          </a:xfrm>
+          <a:prstGeom prst="straightConnector1">
+            <a:avLst/>
+          </a:prstGeom>
+          <a:ln w="28575">
+            <a:solidFill>
+              <a:srgbClr val="999999"/>
+            </a:solidFill>
+            <a:prstDash val="dash"/>
+            <a:round/>
+          </a:ln>
+        </p:spPr>
+      </p:cxnSp>
+      <p:cxnSp>
+        <p:nvCxnSpPr>
+          <p:cNvPr id="52" name="Google Shape;85;p15">
+            <a:extLst>
+              <a:ext uri="{FF2B5EF4-FFF2-40B4-BE49-F238E27FC236}">
+                <a16:creationId xmlns:a16="http://schemas.microsoft.com/office/drawing/2014/main" id="{91B7C2B1-2155-925B-6D06-E9FC842D82CA}"/>
+              </a:ext>
+            </a:extLst>
+          </p:cNvPr>
+          <p:cNvCxnSpPr/>
+          <p:nvPr/>
+        </p:nvCxnSpPr>
+        <p:spPr>
+          <a:xfrm>
+            <a:off x="5607720" y="9505440"/>
+            <a:ext cx="16043400" cy="1080"/>
+          </a:xfrm>
+          <a:prstGeom prst="straightConnector1">
+            <a:avLst/>
+          </a:prstGeom>
+          <a:ln w="28575">
+            <a:solidFill>
+              <a:srgbClr val="999999"/>
+            </a:solidFill>
+            <a:prstDash val="dash"/>
+            <a:round/>
+          </a:ln>
+        </p:spPr>
+      </p:cxnSp>
+      <p:sp>
+        <p:nvSpPr>
+          <p:cNvPr id="53" name="Google Shape;86;p15">
+            <a:extLst>
+              <a:ext uri="{FF2B5EF4-FFF2-40B4-BE49-F238E27FC236}">
+                <a16:creationId xmlns:a16="http://schemas.microsoft.com/office/drawing/2014/main" id="{ECE400C2-C8CE-DFA2-0102-C55842BF3EB0}"/>
+              </a:ext>
+            </a:extLst>
+          </p:cNvPr>
+          <p:cNvSpPr/>
+          <p:nvPr/>
+        </p:nvSpPr>
+        <p:spPr>
+          <a:xfrm>
+            <a:off x="6395940" y="1257039"/>
+            <a:ext cx="2436120" cy="3838374"/>
+          </a:xfrm>
+          <a:prstGeom prst="roundRect">
+            <a:avLst>
+              <a:gd name="adj" fmla="val 16667"/>
+            </a:avLst>
+          </a:prstGeom>
+          <a:solidFill>
+            <a:srgbClr val="D9EAD3"/>
+          </a:solidFill>
+          <a:ln w="28575">
+            <a:solidFill>
+              <a:srgbClr val="274E13"/>
+            </a:solidFill>
+            <a:round/>
+          </a:ln>
+        </p:spPr>
+        <p:style>
+          <a:lnRef idx="0">
+            <a:scrgbClr r="0" g="0" b="0"/>
+          </a:lnRef>
+          <a:fillRef idx="0">
+            <a:scrgbClr r="0" g="0" b="0"/>
+          </a:fillRef>
+          <a:effectRef idx="0">
+            <a:scrgbClr r="0" g="0" b="0"/>
+          </a:effectRef>
+          <a:fontRef idx="minor"/>
+        </p:style>
+        <p:txBody>
+          <a:bodyPr lIns="90000" tIns="91440" rIns="90000" bIns="91440" anchor="t">
+            <a:noAutofit/>
+          </a:bodyPr>
+          <a:lstStyle/>
+          <a:p>
+            <a:pPr>
+              <a:lnSpc>
+                <a:spcPct val="100000"/>
+              </a:lnSpc>
+            </a:pPr>
+            <a:r>
+              <a:rPr lang="en-GB" sz="1400" b="0" u="none" strike="noStrike" dirty="0">
+                <a:solidFill>
+                  <a:srgbClr val="000000"/>
+                </a:solidFill>
+                <a:effectLst/>
+                <a:uFillTx/>
+                <a:latin typeface="Consolas"/>
+                <a:ea typeface="Consolas"/>
+              </a:rPr>
+              <a:t>US1: </a:t>
+            </a:r>
+            <a:r>
+              <a:rPr lang="en-US" sz="1400" dirty="0">
+                <a:solidFill>
+                  <a:srgbClr val="000000"/>
+                </a:solidFill>
+                <a:ea typeface="Arial"/>
+              </a:rPr>
+              <a:t>As a Mindustry player, I want to upgrade machines with efficiency levels, so that I can create more resources per time unit in case of drills and other resource generators, and have better defences in case of weapons.</a:t>
+            </a:r>
+            <a:endParaRPr lang="pt-PT" sz="1400" b="0" u="none" strike="noStrike" dirty="0">
+              <a:solidFill>
+                <a:srgbClr val="000000"/>
+              </a:solidFill>
+              <a:effectLst/>
+              <a:uFillTx/>
+              <a:latin typeface="Arial"/>
+            </a:endParaRPr>
+          </a:p>
+        </p:txBody>
+      </p:sp>
+      <p:sp>
+        <p:nvSpPr>
+          <p:cNvPr id="54" name="Google Shape;87;p15">
+            <a:extLst>
+              <a:ext uri="{FF2B5EF4-FFF2-40B4-BE49-F238E27FC236}">
+                <a16:creationId xmlns:a16="http://schemas.microsoft.com/office/drawing/2014/main" id="{E8D24EA4-8320-E329-7A6E-5AA8C93C8865}"/>
+              </a:ext>
+            </a:extLst>
+          </p:cNvPr>
+          <p:cNvSpPr/>
+          <p:nvPr/>
+        </p:nvSpPr>
+        <p:spPr>
+          <a:xfrm>
+            <a:off x="167400" y="6967080"/>
+            <a:ext cx="2436120" cy="2775600"/>
+          </a:xfrm>
+          <a:prstGeom prst="roundRect">
+            <a:avLst>
+              <a:gd name="adj" fmla="val 16667"/>
+            </a:avLst>
+          </a:prstGeom>
+          <a:solidFill>
+            <a:srgbClr val="D9EAD3"/>
+          </a:solidFill>
+          <a:ln w="28575">
+            <a:solidFill>
+              <a:srgbClr val="274E13"/>
+            </a:solidFill>
+            <a:round/>
+          </a:ln>
+        </p:spPr>
+        <p:style>
+          <a:lnRef idx="0">
+            <a:scrgbClr r="0" g="0" b="0"/>
+          </a:lnRef>
+          <a:fillRef idx="0">
+            <a:scrgbClr r="0" g="0" b="0"/>
+          </a:fillRef>
+          <a:effectRef idx="0">
+            <a:scrgbClr r="0" g="0" b="0"/>
+          </a:effectRef>
+          <a:fontRef idx="minor"/>
+        </p:style>
+        <p:txBody>
+          <a:bodyPr lIns="90000" tIns="91440" rIns="90000" bIns="91440" anchor="t">
+            <a:noAutofit/>
+          </a:bodyPr>
+          <a:lstStyle/>
+          <a:p>
+            <a:pPr>
+              <a:lnSpc>
+                <a:spcPct val="100000"/>
+              </a:lnSpc>
+            </a:pPr>
+            <a:r>
+              <a:rPr lang="en-GB" sz="1400" b="0" u="none" strike="noStrike" dirty="0">
+                <a:solidFill>
+                  <a:srgbClr val="000000"/>
+                </a:solidFill>
+                <a:effectLst/>
+                <a:uFillTx/>
+                <a:latin typeface="Consolas"/>
+                <a:ea typeface="Consolas"/>
+              </a:rPr>
+              <a:t>US3: </a:t>
+            </a:r>
+            <a:r>
+              <a:rPr lang="en-US" sz="1400" dirty="0">
+                <a:solidFill>
+                  <a:srgbClr val="000000"/>
+                </a:solidFill>
+                <a:ea typeface="Arial"/>
+              </a:rPr>
+              <a:t>As a veteran player, I want to orchestrate a new defensive strategy by pulling enemy air units to the ground, so that I can play the game in a more creative way.</a:t>
+            </a:r>
+            <a:endParaRPr lang="pt-PT" sz="1400" b="0" u="none" strike="noStrike" dirty="0">
+              <a:solidFill>
+                <a:srgbClr val="000000"/>
+              </a:solidFill>
+              <a:effectLst/>
+              <a:uFillTx/>
+              <a:latin typeface="Arial"/>
+            </a:endParaRPr>
+          </a:p>
+        </p:txBody>
+      </p:sp>
+      <p:cxnSp>
+        <p:nvCxnSpPr>
+          <p:cNvPr id="55" name="Google Shape;91;p15">
+            <a:extLst>
+              <a:ext uri="{FF2B5EF4-FFF2-40B4-BE49-F238E27FC236}">
+                <a16:creationId xmlns:a16="http://schemas.microsoft.com/office/drawing/2014/main" id="{09201D3C-ABF7-87AB-8C9D-DFE98B97CD1D}"/>
+              </a:ext>
+            </a:extLst>
+          </p:cNvPr>
+          <p:cNvCxnSpPr/>
+          <p:nvPr/>
+        </p:nvCxnSpPr>
+        <p:spPr>
+          <a:xfrm>
+            <a:off x="2874240" y="-28440"/>
+            <a:ext cx="1080" cy="10857960"/>
+          </a:xfrm>
+          <a:prstGeom prst="straightConnector1">
+            <a:avLst/>
+          </a:prstGeom>
+          <a:ln w="38100">
+            <a:solidFill>
+              <a:srgbClr val="5B0F00"/>
+            </a:solidFill>
+            <a:round/>
+          </a:ln>
+        </p:spPr>
+      </p:cxnSp>
+      <p:sp>
+        <p:nvSpPr>
+          <p:cNvPr id="56" name="Google Shape;92;p15">
+            <a:extLst>
+              <a:ext uri="{FF2B5EF4-FFF2-40B4-BE49-F238E27FC236}">
+                <a16:creationId xmlns:a16="http://schemas.microsoft.com/office/drawing/2014/main" id="{B84D6F46-FD5F-9EA0-5014-523554199AD9}"/>
+              </a:ext>
+            </a:extLst>
+          </p:cNvPr>
+          <p:cNvSpPr/>
+          <p:nvPr/>
+        </p:nvSpPr>
+        <p:spPr>
+          <a:xfrm>
+            <a:off x="6422220" y="6126258"/>
+            <a:ext cx="2436120" cy="3616422"/>
+          </a:xfrm>
+          <a:prstGeom prst="roundRect">
+            <a:avLst>
+              <a:gd name="adj" fmla="val 16667"/>
+            </a:avLst>
+          </a:prstGeom>
+          <a:solidFill>
+            <a:srgbClr val="D9EAD3"/>
+          </a:solidFill>
+          <a:ln w="28575">
+            <a:solidFill>
+              <a:srgbClr val="274E13"/>
+            </a:solidFill>
+            <a:round/>
+          </a:ln>
+        </p:spPr>
+        <p:style>
+          <a:lnRef idx="0">
+            <a:scrgbClr r="0" g="0" b="0"/>
+          </a:lnRef>
+          <a:fillRef idx="0">
+            <a:scrgbClr r="0" g="0" b="0"/>
+          </a:fillRef>
+          <a:effectRef idx="0">
+            <a:scrgbClr r="0" g="0" b="0"/>
+          </a:effectRef>
+          <a:fontRef idx="minor"/>
+        </p:style>
+        <p:txBody>
+          <a:bodyPr lIns="90000" tIns="91440" rIns="90000" bIns="91440" anchor="t">
+            <a:noAutofit/>
+          </a:bodyPr>
+          <a:lstStyle/>
+          <a:p>
+            <a:pPr>
+              <a:lnSpc>
+                <a:spcPct val="100000"/>
+              </a:lnSpc>
+            </a:pPr>
+            <a:r>
+              <a:rPr lang="en-GB" sz="1400" b="0" u="none" strike="noStrike" dirty="0">
+                <a:solidFill>
+                  <a:srgbClr val="000000"/>
+                </a:solidFill>
+                <a:effectLst/>
+                <a:uFillTx/>
+                <a:latin typeface="Consolas"/>
+                <a:ea typeface="Consolas"/>
+              </a:rPr>
+              <a:t>US2: </a:t>
+            </a:r>
+            <a:r>
+              <a:rPr lang="en-US" sz="1400" dirty="0">
+                <a:solidFill>
+                  <a:srgbClr val="000000"/>
+                </a:solidFill>
+                <a:ea typeface="Arial"/>
+              </a:rPr>
+              <a:t>As a player that likes to keep track of everything, I want to receive a text warning everytime I misplace a conveyor for whatever reason and obtain possible fixes, so that I can have everything under my watch and build solid structures quickly.</a:t>
+            </a:r>
+            <a:endParaRPr lang="pt-PT" sz="1400" b="0" u="none" strike="noStrike" dirty="0">
+              <a:solidFill>
+                <a:srgbClr val="000000"/>
+              </a:solidFill>
+              <a:effectLst/>
+              <a:uFillTx/>
+              <a:latin typeface="Arial"/>
+            </a:endParaRPr>
+          </a:p>
+        </p:txBody>
+      </p:sp>
+      <p:sp>
+        <p:nvSpPr>
+          <p:cNvPr id="5" name="Google Shape;86;p15">
+            <a:extLst>
+              <a:ext uri="{FF2B5EF4-FFF2-40B4-BE49-F238E27FC236}">
+                <a16:creationId xmlns:a16="http://schemas.microsoft.com/office/drawing/2014/main" id="{3A5CE281-BE4D-242A-4F79-B346969F2926}"/>
+              </a:ext>
+            </a:extLst>
+          </p:cNvPr>
+          <p:cNvSpPr/>
+          <p:nvPr/>
+        </p:nvSpPr>
+        <p:spPr>
+          <a:xfrm>
+            <a:off x="18668880" y="1203865"/>
+            <a:ext cx="2436120" cy="879561"/>
+          </a:xfrm>
+          <a:prstGeom prst="roundRect">
+            <a:avLst>
+              <a:gd name="adj" fmla="val 16667"/>
+            </a:avLst>
+          </a:prstGeom>
+          <a:solidFill>
+            <a:srgbClr val="D9EAD3"/>
+          </a:solidFill>
+          <a:ln w="28575">
+            <a:solidFill>
+              <a:srgbClr val="274E13"/>
+            </a:solidFill>
+            <a:round/>
+          </a:ln>
+        </p:spPr>
+        <p:style>
+          <a:lnRef idx="0">
+            <a:scrgbClr r="0" g="0" b="0"/>
+          </a:lnRef>
+          <a:fillRef idx="0">
+            <a:scrgbClr r="0" g="0" b="0"/>
+          </a:fillRef>
+          <a:effectRef idx="0">
+            <a:scrgbClr r="0" g="0" b="0"/>
+          </a:effectRef>
+          <a:fontRef idx="minor"/>
+        </p:style>
+        <p:txBody>
+          <a:bodyPr lIns="90000" tIns="91440" rIns="90000" bIns="91440" anchor="t">
+            <a:noAutofit/>
+          </a:bodyPr>
+          <a:lstStyle/>
+          <a:p>
+            <a:pPr>
+              <a:lnSpc>
+                <a:spcPct val="100000"/>
+              </a:lnSpc>
+            </a:pPr>
+            <a:r>
+              <a:rPr lang="pt-PT" sz="1400" b="0" u="none" strike="noStrike" dirty="0">
+                <a:solidFill>
+                  <a:srgbClr val="000000"/>
+                </a:solidFill>
+                <a:effectLst/>
+                <a:uFillTx/>
+                <a:latin typeface="Arial"/>
+              </a:rPr>
+              <a:t>Review and map the existing code related to machines.</a:t>
+            </a:r>
+          </a:p>
+        </p:txBody>
+      </p:sp>
+      <p:sp>
+        <p:nvSpPr>
+          <p:cNvPr id="6" name="Rectangle 1">
+            <a:extLst>
+              <a:ext uri="{FF2B5EF4-FFF2-40B4-BE49-F238E27FC236}">
+                <a16:creationId xmlns:a16="http://schemas.microsoft.com/office/drawing/2014/main" id="{339F6378-7111-9DCB-23F0-94A7D8FD181A}"/>
+              </a:ext>
+            </a:extLst>
+          </p:cNvPr>
+          <p:cNvSpPr>
+            <a:spLocks noChangeArrowheads="1"/>
+          </p:cNvSpPr>
+          <p:nvPr/>
+        </p:nvSpPr>
+        <p:spPr bwMode="auto">
+          <a:xfrm>
+            <a:off x="0" y="0"/>
+            <a:ext cx="21599525" cy="0"/>
+          </a:xfrm>
+          <a:prstGeom prst="rect">
+            <a:avLst/>
+          </a:prstGeom>
+          <a:noFill/>
+          <a:ln>
+            <a:noFill/>
+          </a:ln>
+          <a:effectLst/>
+          <a:extLst>
+            <a:ext uri="{909E8E84-426E-40DD-AFC4-6F175D3DCCD1}">
+              <a14:hiddenFill xmlns:a14="http://schemas.microsoft.com/office/drawing/2010/main">
+                <a:solidFill>
+                  <a:schemeClr val="accent1"/>
+                </a:solidFill>
+              </a14:hiddenFill>
+            </a:ext>
+            <a:ext uri="{91240B29-F687-4F45-9708-019B960494DF}">
+              <a14:hiddenLine xmlns:a14="http://schemas.microsoft.com/office/drawing/2010/main" w="9525">
+                <a:solidFill>
+                  <a:schemeClr val="tx1"/>
+                </a:solidFill>
+                <a:miter lim="800000"/>
+                <a:headEnd/>
+                <a:tailEnd/>
+              </a14:hiddenLine>
+            </a:ext>
+            <a:ext uri="{AF507438-7753-43E0-B8FC-AC1667EBCBE1}">
+              <a14:hiddenEffects xmlns:a14="http://schemas.microsoft.com/office/drawing/2010/main">
+                <a:effectLst>
+                  <a:outerShdw dist="35921" dir="2700000" algn="ctr" rotWithShape="0">
+                    <a:schemeClr val="bg2"/>
+                  </a:outerShdw>
+                </a:effectLst>
+              </a14:hiddenEffects>
+            </a:ext>
+          </a:extLst>
+        </p:spPr>
+        <p:txBody>
+          <a:bodyPr vert="horz" wrap="none" lIns="91440" tIns="45720" rIns="91440" bIns="45720" numCol="1" anchor="ctr" anchorCtr="0" compatLnSpc="1">
+            <a:prstTxWarp prst="textNoShape">
+              <a:avLst/>
+            </a:prstTxWarp>
+            <a:spAutoFit/>
+          </a:bodyPr>
+          <a:lstStyle/>
+          <a:p>
+            <a:pPr marL="0" marR="0" lvl="0" indent="0" algn="l" defTabSz="914400" rtl="0" eaLnBrk="0" fontAlgn="base" latinLnBrk="0" hangingPunct="0">
+              <a:lnSpc>
+                <a:spcPct val="100000"/>
+              </a:lnSpc>
+              <a:spcBef>
+                <a:spcPct val="0"/>
+              </a:spcBef>
+              <a:spcAft>
+                <a:spcPct val="0"/>
+              </a:spcAft>
+              <a:buClrTx/>
+              <a:buSzTx/>
+              <a:buFontTx/>
+              <a:buChar char="•"/>
+              <a:tabLst/>
+            </a:pPr>
+            <a:r>
+              <a:rPr kumimoji="0" lang="en-US" altLang="en-US" sz="1800" b="0" i="0" u="none" strike="noStrike" cap="none" normalizeH="0" baseline="0">
+                <a:ln>
+                  <a:noFill/>
+                </a:ln>
+                <a:solidFill>
+                  <a:schemeClr val="tx1"/>
+                </a:solidFill>
+                <a:effectLst/>
+                <a:latin typeface="Arial" panose="020B0604020202020204" pitchFamily="34" charset="0"/>
+              </a:rPr>
+              <a:t>Review and map the existing code related to machine efficiency and stats.</a:t>
+            </a:r>
+          </a:p>
+          <a:p>
+            <a:pPr marL="0" marR="0" lvl="0" indent="0" algn="l" defTabSz="914400" rtl="0" eaLnBrk="0" fontAlgn="base" latinLnBrk="0" hangingPunct="0">
+              <a:lnSpc>
+                <a:spcPct val="100000"/>
+              </a:lnSpc>
+              <a:spcBef>
+                <a:spcPct val="0"/>
+              </a:spcBef>
+              <a:spcAft>
+                <a:spcPct val="0"/>
+              </a:spcAft>
+              <a:buClrTx/>
+              <a:buSzTx/>
+              <a:buFontTx/>
+              <a:buChar char="•"/>
+              <a:tabLst/>
+            </a:pPr>
+            <a:endParaRPr kumimoji="0" lang="en-US" altLang="en-US" sz="1800" b="0" i="0" u="none" strike="noStrike" cap="none" normalizeH="0" baseline="0">
+              <a:ln>
+                <a:noFill/>
+              </a:ln>
+              <a:solidFill>
+                <a:schemeClr val="tx1"/>
+              </a:solidFill>
+              <a:effectLst/>
+              <a:latin typeface="Arial" panose="020B0604020202020204" pitchFamily="34" charset="0"/>
+            </a:endParaRPr>
+          </a:p>
+        </p:txBody>
+      </p:sp>
+      <p:sp>
+        <p:nvSpPr>
+          <p:cNvPr id="8" name="Google Shape;86;p15">
+            <a:extLst>
+              <a:ext uri="{FF2B5EF4-FFF2-40B4-BE49-F238E27FC236}">
+                <a16:creationId xmlns:a16="http://schemas.microsoft.com/office/drawing/2014/main" id="{081446FE-83FE-D60C-750A-4AE4157D064E}"/>
+              </a:ext>
+            </a:extLst>
+          </p:cNvPr>
+          <p:cNvSpPr/>
+          <p:nvPr/>
+        </p:nvSpPr>
+        <p:spPr>
+          <a:xfrm>
+            <a:off x="18668880" y="2623098"/>
+            <a:ext cx="2436120" cy="1158203"/>
+          </a:xfrm>
+          <a:prstGeom prst="roundRect">
+            <a:avLst>
+              <a:gd name="adj" fmla="val 16667"/>
+            </a:avLst>
+          </a:prstGeom>
+          <a:solidFill>
+            <a:srgbClr val="D9EAD3"/>
+          </a:solidFill>
+          <a:ln w="28575">
+            <a:solidFill>
+              <a:srgbClr val="274E13"/>
+            </a:solidFill>
+            <a:round/>
+          </a:ln>
+        </p:spPr>
+        <p:style>
+          <a:lnRef idx="0">
+            <a:scrgbClr r="0" g="0" b="0"/>
+          </a:lnRef>
+          <a:fillRef idx="0">
+            <a:scrgbClr r="0" g="0" b="0"/>
+          </a:fillRef>
+          <a:effectRef idx="0">
+            <a:scrgbClr r="0" g="0" b="0"/>
+          </a:effectRef>
+          <a:fontRef idx="minor"/>
+        </p:style>
+        <p:txBody>
+          <a:bodyPr lIns="90000" tIns="91440" rIns="90000" bIns="91440" anchor="t">
+            <a:noAutofit/>
+          </a:bodyPr>
+          <a:lstStyle/>
+          <a:p>
+            <a:pPr>
+              <a:lnSpc>
+                <a:spcPct val="100000"/>
+              </a:lnSpc>
+            </a:pPr>
+            <a:r>
+              <a:rPr lang="pt-PT" sz="1400" b="0" u="none" strike="noStrike" dirty="0">
+                <a:solidFill>
+                  <a:srgbClr val="000000"/>
+                </a:solidFill>
+                <a:effectLst/>
+                <a:uFillTx/>
+                <a:latin typeface="Arial"/>
+              </a:rPr>
+              <a:t>Identify the classes that could support upgrade levels or if there’s a need to create new ones.</a:t>
+            </a:r>
+          </a:p>
+        </p:txBody>
+      </p:sp>
+      <p:sp>
+        <p:nvSpPr>
+          <p:cNvPr id="9" name="Google Shape;86;p15">
+            <a:extLst>
+              <a:ext uri="{FF2B5EF4-FFF2-40B4-BE49-F238E27FC236}">
+                <a16:creationId xmlns:a16="http://schemas.microsoft.com/office/drawing/2014/main" id="{73862BF2-25D0-9A7C-9161-6E1572BAA46F}"/>
+              </a:ext>
+            </a:extLst>
+          </p:cNvPr>
+          <p:cNvSpPr/>
+          <p:nvPr/>
+        </p:nvSpPr>
+        <p:spPr>
+          <a:xfrm>
+            <a:off x="18668880" y="4265364"/>
+            <a:ext cx="2436120" cy="1158203"/>
+          </a:xfrm>
+          <a:prstGeom prst="roundRect">
+            <a:avLst>
+              <a:gd name="adj" fmla="val 16667"/>
+            </a:avLst>
+          </a:prstGeom>
+          <a:solidFill>
+            <a:srgbClr val="D9EAD3"/>
+          </a:solidFill>
+          <a:ln w="28575">
+            <a:solidFill>
+              <a:srgbClr val="274E13"/>
+            </a:solidFill>
+            <a:round/>
+          </a:ln>
+        </p:spPr>
+        <p:style>
+          <a:lnRef idx="0">
+            <a:scrgbClr r="0" g="0" b="0"/>
+          </a:lnRef>
+          <a:fillRef idx="0">
+            <a:scrgbClr r="0" g="0" b="0"/>
+          </a:fillRef>
+          <a:effectRef idx="0">
+            <a:scrgbClr r="0" g="0" b="0"/>
+          </a:effectRef>
+          <a:fontRef idx="minor"/>
+        </p:style>
+        <p:txBody>
+          <a:bodyPr lIns="90000" tIns="91440" rIns="90000" bIns="91440" anchor="t">
+            <a:noAutofit/>
+          </a:bodyPr>
+          <a:lstStyle/>
+          <a:p>
+            <a:pPr>
+              <a:lnSpc>
+                <a:spcPct val="100000"/>
+              </a:lnSpc>
+            </a:pPr>
+            <a:r>
+              <a:rPr lang="pt-PT" sz="1400" dirty="0">
+                <a:solidFill>
+                  <a:srgbClr val="000000"/>
+                </a:solidFill>
+                <a:latin typeface="Arial"/>
+              </a:rPr>
+              <a:t>Draft possible methods needed for implementing efficieny upgrades.</a:t>
+            </a:r>
+            <a:endParaRPr lang="pt-PT" sz="1400" b="0" u="none" strike="noStrike" dirty="0">
+              <a:solidFill>
+                <a:srgbClr val="000000"/>
+              </a:solidFill>
+              <a:effectLst/>
+              <a:uFillTx/>
+              <a:latin typeface="Arial"/>
+            </a:endParaRPr>
+          </a:p>
+        </p:txBody>
+      </p:sp>
+      <p:sp>
+        <p:nvSpPr>
+          <p:cNvPr id="10" name="Google Shape;86;p15">
+            <a:extLst>
+              <a:ext uri="{FF2B5EF4-FFF2-40B4-BE49-F238E27FC236}">
+                <a16:creationId xmlns:a16="http://schemas.microsoft.com/office/drawing/2014/main" id="{2B552442-DDE8-6053-C34A-CE20C303A9B2}"/>
+              </a:ext>
+            </a:extLst>
+          </p:cNvPr>
+          <p:cNvSpPr/>
+          <p:nvPr/>
+        </p:nvSpPr>
+        <p:spPr>
+          <a:xfrm>
+            <a:off x="18668880" y="5849835"/>
+            <a:ext cx="2436120" cy="1158203"/>
+          </a:xfrm>
+          <a:prstGeom prst="roundRect">
+            <a:avLst>
+              <a:gd name="adj" fmla="val 16667"/>
+            </a:avLst>
+          </a:prstGeom>
+          <a:solidFill>
+            <a:srgbClr val="D9EAD3"/>
+          </a:solidFill>
+          <a:ln w="28575">
+            <a:solidFill>
+              <a:srgbClr val="274E13"/>
+            </a:solidFill>
+            <a:round/>
+          </a:ln>
+        </p:spPr>
+        <p:style>
+          <a:lnRef idx="0">
+            <a:scrgbClr r="0" g="0" b="0"/>
+          </a:lnRef>
+          <a:fillRef idx="0">
+            <a:scrgbClr r="0" g="0" b="0"/>
+          </a:fillRef>
+          <a:effectRef idx="0">
+            <a:scrgbClr r="0" g="0" b="0"/>
+          </a:effectRef>
+          <a:fontRef idx="minor"/>
+        </p:style>
+        <p:txBody>
+          <a:bodyPr lIns="90000" tIns="91440" rIns="90000" bIns="91440" anchor="t">
+            <a:noAutofit/>
+          </a:bodyPr>
+          <a:lstStyle/>
+          <a:p>
+            <a:pPr>
+              <a:lnSpc>
+                <a:spcPct val="100000"/>
+              </a:lnSpc>
+            </a:pPr>
+            <a:r>
+              <a:rPr lang="pt-PT" sz="1400" b="0" u="none" strike="noStrike" dirty="0">
+                <a:solidFill>
+                  <a:srgbClr val="000000"/>
+                </a:solidFill>
+                <a:effectLst/>
+                <a:uFillTx/>
+                <a:latin typeface="Arial"/>
+              </a:rPr>
+              <a:t>Review and map converyor related code, such as error detection.</a:t>
+            </a:r>
+          </a:p>
+        </p:txBody>
+      </p:sp>
+      <p:sp>
+        <p:nvSpPr>
+          <p:cNvPr id="11" name="Google Shape;86;p15">
+            <a:extLst>
+              <a:ext uri="{FF2B5EF4-FFF2-40B4-BE49-F238E27FC236}">
+                <a16:creationId xmlns:a16="http://schemas.microsoft.com/office/drawing/2014/main" id="{BBAC9B1A-3682-236C-8017-7FEE9E535CD7}"/>
+              </a:ext>
+            </a:extLst>
+          </p:cNvPr>
+          <p:cNvSpPr/>
+          <p:nvPr/>
+        </p:nvSpPr>
+        <p:spPr>
+          <a:xfrm>
+            <a:off x="18668880" y="8890106"/>
+            <a:ext cx="2436120" cy="1158203"/>
+          </a:xfrm>
+          <a:prstGeom prst="roundRect">
+            <a:avLst>
+              <a:gd name="adj" fmla="val 16667"/>
+            </a:avLst>
+          </a:prstGeom>
+          <a:solidFill>
+            <a:srgbClr val="D9EAD3"/>
+          </a:solidFill>
+          <a:ln w="28575">
+            <a:solidFill>
+              <a:srgbClr val="274E13"/>
+            </a:solidFill>
+            <a:round/>
+          </a:ln>
+        </p:spPr>
+        <p:style>
+          <a:lnRef idx="0">
+            <a:scrgbClr r="0" g="0" b="0"/>
+          </a:lnRef>
+          <a:fillRef idx="0">
+            <a:scrgbClr r="0" g="0" b="0"/>
+          </a:fillRef>
+          <a:effectRef idx="0">
+            <a:scrgbClr r="0" g="0" b="0"/>
+          </a:effectRef>
+          <a:fontRef idx="minor"/>
+        </p:style>
+        <p:txBody>
+          <a:bodyPr lIns="90000" tIns="91440" rIns="90000" bIns="91440" anchor="t">
+            <a:noAutofit/>
+          </a:bodyPr>
+          <a:lstStyle/>
+          <a:p>
+            <a:pPr>
+              <a:lnSpc>
+                <a:spcPct val="100000"/>
+              </a:lnSpc>
+            </a:pPr>
+            <a:r>
+              <a:rPr lang="pt-PT" sz="1400" b="0" u="none" strike="noStrike" dirty="0">
+                <a:solidFill>
+                  <a:srgbClr val="000000"/>
+                </a:solidFill>
+                <a:effectLst/>
+                <a:uFillTx/>
+                <a:latin typeface="Arial"/>
+              </a:rPr>
+              <a:t>Locate where warnings and destination checks are currently handled</a:t>
+            </a:r>
+          </a:p>
+        </p:txBody>
+      </p:sp>
+      <p:sp>
+        <p:nvSpPr>
+          <p:cNvPr id="12" name="Google Shape;86;p15">
+            <a:extLst>
+              <a:ext uri="{FF2B5EF4-FFF2-40B4-BE49-F238E27FC236}">
+                <a16:creationId xmlns:a16="http://schemas.microsoft.com/office/drawing/2014/main" id="{1AD6C094-7226-241E-6DB2-42C55C804D5E}"/>
+              </a:ext>
+            </a:extLst>
+          </p:cNvPr>
+          <p:cNvSpPr/>
+          <p:nvPr/>
+        </p:nvSpPr>
+        <p:spPr>
+          <a:xfrm>
+            <a:off x="18668880" y="7389683"/>
+            <a:ext cx="2436120" cy="1158203"/>
+          </a:xfrm>
+          <a:prstGeom prst="roundRect">
+            <a:avLst>
+              <a:gd name="adj" fmla="val 16667"/>
+            </a:avLst>
+          </a:prstGeom>
+          <a:solidFill>
+            <a:srgbClr val="D9EAD3"/>
+          </a:solidFill>
+          <a:ln w="28575">
+            <a:solidFill>
+              <a:srgbClr val="274E13"/>
+            </a:solidFill>
+            <a:round/>
+          </a:ln>
+        </p:spPr>
+        <p:style>
+          <a:lnRef idx="0">
+            <a:scrgbClr r="0" g="0" b="0"/>
+          </a:lnRef>
+          <a:fillRef idx="0">
+            <a:scrgbClr r="0" g="0" b="0"/>
+          </a:fillRef>
+          <a:effectRef idx="0">
+            <a:scrgbClr r="0" g="0" b="0"/>
+          </a:effectRef>
+          <a:fontRef idx="minor"/>
+        </p:style>
+        <p:txBody>
+          <a:bodyPr lIns="90000" tIns="91440" rIns="90000" bIns="91440" anchor="t">
+            <a:noAutofit/>
+          </a:bodyPr>
+          <a:lstStyle/>
+          <a:p>
+            <a:pPr>
+              <a:lnSpc>
+                <a:spcPct val="100000"/>
+              </a:lnSpc>
+            </a:pPr>
+            <a:r>
+              <a:rPr lang="pt-PT" sz="1400" dirty="0">
+                <a:solidFill>
+                  <a:srgbClr val="000000"/>
+                </a:solidFill>
+                <a:latin typeface="Arial"/>
+              </a:rPr>
+              <a:t>Define the structure and behavior of the new warning messages</a:t>
+            </a:r>
+            <a:endParaRPr lang="pt-PT" sz="1400" b="0" u="none" strike="noStrike" dirty="0">
+              <a:solidFill>
+                <a:srgbClr val="000000"/>
+              </a:solidFill>
+              <a:effectLst/>
+              <a:uFillTx/>
+              <a:latin typeface="Arial"/>
+            </a:endParaRPr>
+          </a:p>
+        </p:txBody>
+      </p:sp>
+      <p:sp>
+        <p:nvSpPr>
+          <p:cNvPr id="2" name="Google Shape;86;p15">
+            <a:extLst>
+              <a:ext uri="{FF2B5EF4-FFF2-40B4-BE49-F238E27FC236}">
+                <a16:creationId xmlns:a16="http://schemas.microsoft.com/office/drawing/2014/main" id="{27697F4F-64C0-511E-B9E3-8A837346B691}"/>
+              </a:ext>
+            </a:extLst>
+          </p:cNvPr>
+          <p:cNvSpPr/>
+          <p:nvPr/>
+        </p:nvSpPr>
+        <p:spPr>
+          <a:xfrm>
+            <a:off x="12424500" y="1382566"/>
+            <a:ext cx="2409840" cy="879561"/>
+          </a:xfrm>
+          <a:prstGeom prst="roundRect">
+            <a:avLst>
+              <a:gd name="adj" fmla="val 16667"/>
+            </a:avLst>
+          </a:prstGeom>
+          <a:solidFill>
+            <a:srgbClr val="D9EAD3"/>
+          </a:solidFill>
+          <a:ln w="28575">
+            <a:solidFill>
+              <a:srgbClr val="274E13"/>
+            </a:solidFill>
+            <a:round/>
+          </a:ln>
+        </p:spPr>
+        <p:style>
+          <a:lnRef idx="0">
+            <a:scrgbClr r="0" g="0" b="0"/>
+          </a:lnRef>
+          <a:fillRef idx="0">
+            <a:scrgbClr r="0" g="0" b="0"/>
+          </a:fillRef>
+          <a:effectRef idx="0">
+            <a:scrgbClr r="0" g="0" b="0"/>
+          </a:effectRef>
+          <a:fontRef idx="minor"/>
+        </p:style>
+        <p:txBody>
+          <a:bodyPr lIns="90000" tIns="91440" rIns="90000" bIns="91440" anchor="t">
+            <a:noAutofit/>
+          </a:bodyPr>
+          <a:lstStyle/>
+          <a:p>
+            <a:pPr>
+              <a:lnSpc>
+                <a:spcPct val="100000"/>
+              </a:lnSpc>
+            </a:pPr>
+            <a:r>
+              <a:rPr lang="pt-PT" sz="1400" dirty="0">
+                <a:solidFill>
+                  <a:srgbClr val="000000"/>
+                </a:solidFill>
+                <a:latin typeface="Arial"/>
+              </a:rPr>
+              <a:t>US1</a:t>
+            </a:r>
+            <a:r>
+              <a:rPr lang="en-US" sz="1400" dirty="0">
+                <a:solidFill>
+                  <a:srgbClr val="000000"/>
+                </a:solidFill>
+                <a:latin typeface="Arial"/>
+              </a:rPr>
+              <a:t>: implementing</a:t>
+            </a:r>
+          </a:p>
+          <a:p>
+            <a:pPr>
+              <a:lnSpc>
+                <a:spcPct val="100000"/>
+              </a:lnSpc>
+            </a:pPr>
+            <a:endParaRPr lang="pt-PT" sz="1400" b="0" u="none" strike="noStrike" dirty="0">
+              <a:solidFill>
+                <a:srgbClr val="000000"/>
+              </a:solidFill>
+              <a:effectLst/>
+              <a:uFillTx/>
+              <a:latin typeface="Arial"/>
+            </a:endParaRPr>
+          </a:p>
+        </p:txBody>
+      </p:sp>
+      <p:sp>
+        <p:nvSpPr>
+          <p:cNvPr id="3" name="Google Shape;86;p15">
+            <a:extLst>
+              <a:ext uri="{FF2B5EF4-FFF2-40B4-BE49-F238E27FC236}">
+                <a16:creationId xmlns:a16="http://schemas.microsoft.com/office/drawing/2014/main" id="{B01D7A90-0FAD-D5A6-F526-414F260045E9}"/>
+              </a:ext>
+            </a:extLst>
+          </p:cNvPr>
+          <p:cNvSpPr/>
+          <p:nvPr/>
+        </p:nvSpPr>
+        <p:spPr>
+          <a:xfrm>
+            <a:off x="12395880" y="5940128"/>
+            <a:ext cx="2393010" cy="879561"/>
+          </a:xfrm>
+          <a:prstGeom prst="roundRect">
+            <a:avLst>
+              <a:gd name="adj" fmla="val 16667"/>
+            </a:avLst>
+          </a:prstGeom>
+          <a:solidFill>
+            <a:srgbClr val="D9EAD3"/>
+          </a:solidFill>
+          <a:ln w="28575">
+            <a:solidFill>
+              <a:srgbClr val="274E13"/>
+            </a:solidFill>
+            <a:round/>
+          </a:ln>
+        </p:spPr>
+        <p:style>
+          <a:lnRef idx="0">
+            <a:scrgbClr r="0" g="0" b="0"/>
+          </a:lnRef>
+          <a:fillRef idx="0">
+            <a:scrgbClr r="0" g="0" b="0"/>
+          </a:fillRef>
+          <a:effectRef idx="0">
+            <a:scrgbClr r="0" g="0" b="0"/>
+          </a:effectRef>
+          <a:fontRef idx="minor"/>
+        </p:style>
+        <p:txBody>
+          <a:bodyPr lIns="90000" tIns="91440" rIns="90000" bIns="91440" anchor="t">
+            <a:noAutofit/>
+          </a:bodyPr>
+          <a:lstStyle/>
+          <a:p>
+            <a:pPr>
+              <a:lnSpc>
+                <a:spcPct val="100000"/>
+              </a:lnSpc>
+            </a:pPr>
+            <a:r>
+              <a:rPr lang="pt-PT" sz="1400" dirty="0">
+                <a:solidFill>
+                  <a:srgbClr val="000000"/>
+                </a:solidFill>
+                <a:latin typeface="Arial"/>
+              </a:rPr>
+              <a:t>US2</a:t>
+            </a:r>
+            <a:r>
+              <a:rPr lang="en-US" sz="1400" dirty="0">
+                <a:solidFill>
+                  <a:srgbClr val="000000"/>
+                </a:solidFill>
+                <a:latin typeface="Arial"/>
+              </a:rPr>
+              <a:t>: implementing</a:t>
+            </a:r>
+          </a:p>
+          <a:p>
+            <a:pPr>
+              <a:lnSpc>
+                <a:spcPct val="100000"/>
+              </a:lnSpc>
+            </a:pPr>
+            <a:endParaRPr lang="pt-PT" sz="1400" b="0" u="none" strike="noStrike" dirty="0">
+              <a:solidFill>
+                <a:srgbClr val="000000"/>
+              </a:solidFill>
+              <a:effectLst/>
+              <a:uFillTx/>
+              <a:latin typeface="Arial"/>
+            </a:endParaRPr>
+          </a:p>
+        </p:txBody>
+      </p:sp>
+      <p:sp>
+        <p:nvSpPr>
+          <p:cNvPr id="4" name="Google Shape;86;p15">
+            <a:extLst>
+              <a:ext uri="{FF2B5EF4-FFF2-40B4-BE49-F238E27FC236}">
+                <a16:creationId xmlns:a16="http://schemas.microsoft.com/office/drawing/2014/main" id="{1AC69F1E-2231-B90F-6D33-E931C11569AA}"/>
+              </a:ext>
+            </a:extLst>
+          </p:cNvPr>
+          <p:cNvSpPr/>
+          <p:nvPr/>
+        </p:nvSpPr>
+        <p:spPr>
+          <a:xfrm>
+            <a:off x="12424500" y="2775604"/>
+            <a:ext cx="2409840" cy="879561"/>
+          </a:xfrm>
+          <a:prstGeom prst="roundRect">
+            <a:avLst>
+              <a:gd name="adj" fmla="val 16667"/>
+            </a:avLst>
+          </a:prstGeom>
+          <a:solidFill>
+            <a:srgbClr val="D9EAD3"/>
+          </a:solidFill>
+          <a:ln w="28575">
+            <a:solidFill>
+              <a:srgbClr val="274E13"/>
+            </a:solidFill>
+            <a:round/>
+          </a:ln>
+        </p:spPr>
+        <p:style>
+          <a:lnRef idx="0">
+            <a:scrgbClr r="0" g="0" b="0"/>
+          </a:lnRef>
+          <a:fillRef idx="0">
+            <a:scrgbClr r="0" g="0" b="0"/>
+          </a:fillRef>
+          <a:effectRef idx="0">
+            <a:scrgbClr r="0" g="0" b="0"/>
+          </a:effectRef>
+          <a:fontRef idx="minor"/>
+        </p:style>
+        <p:txBody>
+          <a:bodyPr lIns="90000" tIns="91440" rIns="90000" bIns="91440" anchor="t">
+            <a:noAutofit/>
+          </a:bodyPr>
+          <a:lstStyle/>
+          <a:p>
+            <a:pPr>
+              <a:lnSpc>
+                <a:spcPct val="100000"/>
+              </a:lnSpc>
+            </a:pPr>
+            <a:r>
+              <a:rPr lang="pt-PT" sz="1400" dirty="0">
+                <a:solidFill>
+                  <a:srgbClr val="000000"/>
+                </a:solidFill>
+                <a:latin typeface="Arial"/>
+              </a:rPr>
+              <a:t>US1</a:t>
+            </a:r>
+            <a:r>
+              <a:rPr lang="en-US" sz="1400" dirty="0">
+                <a:solidFill>
+                  <a:srgbClr val="000000"/>
+                </a:solidFill>
+                <a:latin typeface="Arial"/>
+              </a:rPr>
+              <a:t>: implementing</a:t>
+            </a:r>
+          </a:p>
+          <a:p>
+            <a:pPr>
+              <a:lnSpc>
+                <a:spcPct val="100000"/>
+              </a:lnSpc>
+            </a:pPr>
+            <a:endParaRPr lang="pt-PT" sz="1400" b="0" u="none" strike="noStrike" dirty="0">
+              <a:solidFill>
+                <a:srgbClr val="000000"/>
+              </a:solidFill>
+              <a:effectLst/>
+              <a:uFillTx/>
+              <a:latin typeface="Arial"/>
+            </a:endParaRPr>
+          </a:p>
+        </p:txBody>
+      </p:sp>
+      <p:sp>
+        <p:nvSpPr>
+          <p:cNvPr id="7" name="Google Shape;86;p15">
+            <a:extLst>
+              <a:ext uri="{FF2B5EF4-FFF2-40B4-BE49-F238E27FC236}">
+                <a16:creationId xmlns:a16="http://schemas.microsoft.com/office/drawing/2014/main" id="{D959B60C-9E5C-1B51-CC1C-CA750F9BEA94}"/>
+              </a:ext>
+            </a:extLst>
+          </p:cNvPr>
+          <p:cNvSpPr/>
+          <p:nvPr/>
+        </p:nvSpPr>
+        <p:spPr>
+          <a:xfrm>
+            <a:off x="12395880" y="4329211"/>
+            <a:ext cx="2409840" cy="879561"/>
+          </a:xfrm>
+          <a:prstGeom prst="roundRect">
+            <a:avLst>
+              <a:gd name="adj" fmla="val 16667"/>
+            </a:avLst>
+          </a:prstGeom>
+          <a:solidFill>
+            <a:srgbClr val="D9EAD3"/>
+          </a:solidFill>
+          <a:ln w="28575">
+            <a:solidFill>
+              <a:srgbClr val="274E13"/>
+            </a:solidFill>
+            <a:round/>
+          </a:ln>
+        </p:spPr>
+        <p:style>
+          <a:lnRef idx="0">
+            <a:scrgbClr r="0" g="0" b="0"/>
+          </a:lnRef>
+          <a:fillRef idx="0">
+            <a:scrgbClr r="0" g="0" b="0"/>
+          </a:fillRef>
+          <a:effectRef idx="0">
+            <a:scrgbClr r="0" g="0" b="0"/>
+          </a:effectRef>
+          <a:fontRef idx="minor"/>
+        </p:style>
+        <p:txBody>
+          <a:bodyPr lIns="90000" tIns="91440" rIns="90000" bIns="91440" anchor="t">
+            <a:noAutofit/>
+          </a:bodyPr>
+          <a:lstStyle/>
+          <a:p>
+            <a:pPr>
+              <a:lnSpc>
+                <a:spcPct val="100000"/>
+              </a:lnSpc>
+            </a:pPr>
+            <a:r>
+              <a:rPr lang="pt-PT" sz="1400" dirty="0">
+                <a:solidFill>
+                  <a:srgbClr val="000000"/>
+                </a:solidFill>
+                <a:latin typeface="Arial"/>
+              </a:rPr>
+              <a:t>US1</a:t>
+            </a:r>
+            <a:r>
+              <a:rPr lang="en-US" sz="1400" dirty="0">
+                <a:solidFill>
+                  <a:srgbClr val="000000"/>
+                </a:solidFill>
+                <a:latin typeface="Arial"/>
+              </a:rPr>
+              <a:t>: implementing</a:t>
+            </a:r>
+          </a:p>
+          <a:p>
+            <a:pPr>
+              <a:lnSpc>
+                <a:spcPct val="100000"/>
+              </a:lnSpc>
+            </a:pPr>
+            <a:endParaRPr lang="pt-PT" sz="1400" b="0" u="none" strike="noStrike" dirty="0">
+              <a:solidFill>
+                <a:srgbClr val="000000"/>
+              </a:solidFill>
+              <a:effectLst/>
+              <a:uFillTx/>
+              <a:latin typeface="Arial"/>
+            </a:endParaRPr>
+          </a:p>
+        </p:txBody>
+      </p:sp>
+      <p:sp>
+        <p:nvSpPr>
+          <p:cNvPr id="14" name="Google Shape;86;p15">
+            <a:extLst>
+              <a:ext uri="{FF2B5EF4-FFF2-40B4-BE49-F238E27FC236}">
+                <a16:creationId xmlns:a16="http://schemas.microsoft.com/office/drawing/2014/main" id="{E17E7993-E2F3-995B-C2AD-361026EE112C}"/>
+              </a:ext>
+            </a:extLst>
+          </p:cNvPr>
+          <p:cNvSpPr/>
+          <p:nvPr/>
+        </p:nvSpPr>
+        <p:spPr>
+          <a:xfrm>
+            <a:off x="12395880" y="9079172"/>
+            <a:ext cx="2393010" cy="879561"/>
+          </a:xfrm>
+          <a:prstGeom prst="roundRect">
+            <a:avLst>
+              <a:gd name="adj" fmla="val 16667"/>
+            </a:avLst>
+          </a:prstGeom>
+          <a:solidFill>
+            <a:srgbClr val="D9EAD3"/>
+          </a:solidFill>
+          <a:ln w="28575">
+            <a:solidFill>
+              <a:srgbClr val="274E13"/>
+            </a:solidFill>
+            <a:round/>
+          </a:ln>
+        </p:spPr>
+        <p:style>
+          <a:lnRef idx="0">
+            <a:scrgbClr r="0" g="0" b="0"/>
+          </a:lnRef>
+          <a:fillRef idx="0">
+            <a:scrgbClr r="0" g="0" b="0"/>
+          </a:fillRef>
+          <a:effectRef idx="0">
+            <a:scrgbClr r="0" g="0" b="0"/>
+          </a:effectRef>
+          <a:fontRef idx="minor"/>
+        </p:style>
+        <p:txBody>
+          <a:bodyPr lIns="90000" tIns="91440" rIns="90000" bIns="91440" anchor="t">
+            <a:noAutofit/>
+          </a:bodyPr>
+          <a:lstStyle/>
+          <a:p>
+            <a:pPr>
+              <a:lnSpc>
+                <a:spcPct val="100000"/>
+              </a:lnSpc>
+            </a:pPr>
+            <a:r>
+              <a:rPr lang="pt-PT" sz="1400" dirty="0">
+                <a:solidFill>
+                  <a:srgbClr val="000000"/>
+                </a:solidFill>
+                <a:latin typeface="Arial"/>
+              </a:rPr>
+              <a:t>US2</a:t>
+            </a:r>
+            <a:r>
+              <a:rPr lang="en-US" sz="1400" dirty="0">
+                <a:solidFill>
+                  <a:srgbClr val="000000"/>
+                </a:solidFill>
+                <a:latin typeface="Arial"/>
+              </a:rPr>
+              <a:t>: implementing</a:t>
+            </a:r>
+          </a:p>
+          <a:p>
+            <a:pPr>
+              <a:lnSpc>
+                <a:spcPct val="100000"/>
+              </a:lnSpc>
+            </a:pPr>
+            <a:endParaRPr lang="pt-PT" sz="1400" b="0" u="none" strike="noStrike" dirty="0">
+              <a:solidFill>
+                <a:srgbClr val="000000"/>
+              </a:solidFill>
+              <a:effectLst/>
+              <a:uFillTx/>
+              <a:latin typeface="Arial"/>
+            </a:endParaRPr>
+          </a:p>
+        </p:txBody>
+      </p:sp>
+      <p:sp>
+        <p:nvSpPr>
+          <p:cNvPr id="15" name="Google Shape;86;p15">
+            <a:extLst>
+              <a:ext uri="{FF2B5EF4-FFF2-40B4-BE49-F238E27FC236}">
+                <a16:creationId xmlns:a16="http://schemas.microsoft.com/office/drawing/2014/main" id="{B95E067B-FFF7-EE91-437F-9D4B5805B73D}"/>
+              </a:ext>
+            </a:extLst>
+          </p:cNvPr>
+          <p:cNvSpPr/>
+          <p:nvPr/>
+        </p:nvSpPr>
+        <p:spPr>
+          <a:xfrm>
+            <a:off x="12424500" y="7385601"/>
+            <a:ext cx="2393010" cy="879561"/>
+          </a:xfrm>
+          <a:prstGeom prst="roundRect">
+            <a:avLst>
+              <a:gd name="adj" fmla="val 16667"/>
+            </a:avLst>
+          </a:prstGeom>
+          <a:solidFill>
+            <a:srgbClr val="D9EAD3"/>
+          </a:solidFill>
+          <a:ln w="28575">
+            <a:solidFill>
+              <a:srgbClr val="274E13"/>
+            </a:solidFill>
+            <a:round/>
+          </a:ln>
+        </p:spPr>
+        <p:style>
+          <a:lnRef idx="0">
+            <a:scrgbClr r="0" g="0" b="0"/>
+          </a:lnRef>
+          <a:fillRef idx="0">
+            <a:scrgbClr r="0" g="0" b="0"/>
+          </a:fillRef>
+          <a:effectRef idx="0">
+            <a:scrgbClr r="0" g="0" b="0"/>
+          </a:effectRef>
+          <a:fontRef idx="minor"/>
+        </p:style>
+        <p:txBody>
+          <a:bodyPr lIns="90000" tIns="91440" rIns="90000" bIns="91440" anchor="t">
+            <a:noAutofit/>
+          </a:bodyPr>
+          <a:lstStyle/>
+          <a:p>
+            <a:pPr>
+              <a:lnSpc>
+                <a:spcPct val="100000"/>
+              </a:lnSpc>
+            </a:pPr>
+            <a:r>
+              <a:rPr lang="pt-PT" sz="1400" dirty="0">
+                <a:solidFill>
+                  <a:srgbClr val="000000"/>
+                </a:solidFill>
+                <a:latin typeface="Arial"/>
+              </a:rPr>
+              <a:t>US2</a:t>
+            </a:r>
+            <a:r>
+              <a:rPr lang="en-US" sz="1400" dirty="0">
+                <a:solidFill>
+                  <a:srgbClr val="000000"/>
+                </a:solidFill>
+                <a:latin typeface="Arial"/>
+              </a:rPr>
+              <a:t>: implementing</a:t>
+            </a:r>
+          </a:p>
+          <a:p>
+            <a:pPr>
+              <a:lnSpc>
+                <a:spcPct val="100000"/>
+              </a:lnSpc>
+            </a:pPr>
+            <a:endParaRPr lang="pt-PT" sz="1400" b="0" u="none" strike="noStrike" dirty="0">
+              <a:solidFill>
+                <a:srgbClr val="000000"/>
+              </a:solidFill>
+              <a:effectLst/>
+              <a:uFillTx/>
+              <a:latin typeface="Arial"/>
+            </a:endParaRPr>
+          </a:p>
+        </p:txBody>
+      </p:sp>
+    </p:spTree>
+    <p:extLst>
+      <p:ext uri="{BB962C8B-B14F-4D97-AF65-F5344CB8AC3E}">
+        <p14:creationId xmlns:p14="http://schemas.microsoft.com/office/powerpoint/2010/main" val="114089205"/>
       </p:ext>
     </p:extLst>
   </p:cSld>

</xml_diff>